<commit_message>
Deploy RecallRoom on Firebase with private storage and resilient extraction jobs
</commit_message>
<xml_diff>
--- a/docs/pitch/RecallRoom-pitch.pptx
+++ b/docs/pitch/RecallRoom-pitch.pptx
@@ -2,18 +2,18 @@
 <file path=ppt/presentation.xml><?xml version="1.0" encoding="utf-8"?>
 <p:presentation xmlns:p="http://schemas.openxmlformats.org/presentationml/2006/main">
   <p:sldMasterIdLst>
-    <p:sldMasterId xmlns:r="http://schemas.openxmlformats.org/officeDocument/2006/relationships" id="2147483648" r:id="R5cb3e19bb11d45af"/>
+    <p:sldMasterId xmlns:r="http://schemas.openxmlformats.org/officeDocument/2006/relationships" id="2147483648" r:id="R152b21608ff84913"/>
   </p:sldMasterIdLst>
   <p:notesMasterIdLst>
-    <p:notesMasterId xmlns:r="http://schemas.openxmlformats.org/officeDocument/2006/relationships" r:id="R727ffa2cf86f40f6"/>
+    <p:notesMasterId xmlns:r="http://schemas.openxmlformats.org/officeDocument/2006/relationships" r:id="R7ab1fae14c714cf7"/>
   </p:notesMasterIdLst>
   <p:sldIdLst>
-    <p:sldId xmlns:r="http://schemas.openxmlformats.org/officeDocument/2006/relationships" id="256" r:id="R0de078de9f9f4440"/>
-    <p:sldId xmlns:r="http://schemas.openxmlformats.org/officeDocument/2006/relationships" id="257" r:id="Ref18f2c14cba43a2"/>
-    <p:sldId xmlns:r="http://schemas.openxmlformats.org/officeDocument/2006/relationships" id="258" r:id="R6281102badd84e49"/>
-    <p:sldId xmlns:r="http://schemas.openxmlformats.org/officeDocument/2006/relationships" id="259" r:id="R50c87db49747465d"/>
-    <p:sldId xmlns:r="http://schemas.openxmlformats.org/officeDocument/2006/relationships" id="260" r:id="R2f37dade0f9942ef"/>
-    <p:sldId xmlns:r="http://schemas.openxmlformats.org/officeDocument/2006/relationships" id="261" r:id="Rb514776774c1476d"/>
+    <p:sldId xmlns:r="http://schemas.openxmlformats.org/officeDocument/2006/relationships" id="256" r:id="R77de9039fc314506"/>
+    <p:sldId xmlns:r="http://schemas.openxmlformats.org/officeDocument/2006/relationships" id="257" r:id="R5e50a74ff58a4837"/>
+    <p:sldId xmlns:r="http://schemas.openxmlformats.org/officeDocument/2006/relationships" id="258" r:id="R416071f98dcd424f"/>
+    <p:sldId xmlns:r="http://schemas.openxmlformats.org/officeDocument/2006/relationships" id="259" r:id="R70186713d40a441f"/>
+    <p:sldId xmlns:r="http://schemas.openxmlformats.org/officeDocument/2006/relationships" id="260" r:id="Rc86d9527bd9b4a59"/>
+    <p:sldId xmlns:r="http://schemas.openxmlformats.org/officeDocument/2006/relationships" id="261" r:id="R098e4d078f264231"/>
   </p:sldIdLst>
   <p:sldSz cx="12192000" cy="6858000"/>
   <p:notesSz cx="6858000" cy="9144000"/>
@@ -447,7 +447,7 @@
           <a:lstStyle xmlns:a="http://schemas.openxmlformats.org/drawingml/2006/main"/>
           <a:p xmlns:a="http://schemas.openxmlformats.org/drawingml/2006/main">
             <a:r>
-              <a:t>RecallRoom was created by Shivam Gupta with AI-assisted research, implementation, testing, and documentation. This deck describes the MVP and synthetic demonstration as of September 16, 2026. Live NVIDIA Nemotron execution through Nebius Token Factory is pending a credential. No customer results or live model performance measurements are claimed.</a:t>
+              <a:t>RecallRoom was created by Shivam Gupta with AI-assisted research, implementation, testing, and documentation. This deck describes the Firebase MVP and synthetic demonstration. Public demo: https://recallroom.web.app . Live NVIDIA Nemotron execution through Nebius Token Factory is pending a credential. No customer results or live model performance measurements are claimed.</a:t>
             </a:r>
           </a:p>
         </p:txBody>
@@ -657,7 +657,7 @@
           <a:lstStyle xmlns:a="http://schemas.openxmlformats.org/drawingml/2006/main"/>
           <a:p xmlns:a="http://schemas.openxmlformats.org/drawingml/2006/main">
             <a:r>
-              <a:t>Implemented capabilities supplied by engineering: private authentication, saved cases using D1, original source files in R2, text/CSV/JSON and text-PDF upload flow with manual verification of PDF text, structured NVIDIA Nemotron drafting through Nebius Token Factory with human approval, deterministic graph/ranges, evidence decision log, portable HTML/CSV/JSON packets, and customer-specific drafts that are never sent automatically. The deployment status and live model execution must be independently verified before public submission. The live integration still requires a Nebius credential.</a:t>
+              <a:t>The active deployment uses Firebase Hosting and Firebase Authentication, with server-verified Google or email/password identities. A Cloud Run API controls owner-scoped Firestore investigations and private Google Cloud Storage originals. Cloud Tasks dispatches authenticated background extraction. The NVIDIA Nemotron adapter targets Nebius Token Factory and remains unverified against a live NVIDIA model. Text, CSV, JSON and selectable-text PDFs are supported. A reviewer must compare browser-extracted PDF text with the original. The app validates schema, exact quotations, references, cycles, units and balances, computes deterministic scope and ranges, and preserves reviewed decisions. Customer drafts remain unsent. Sources: repository README.md, docs/architecture.md and docs/STATUS.md for this Firebase release. Public demo: https://recallroom.web.app .</a:t>
             </a:r>
           </a:p>
         </p:txBody>
@@ -797,7 +797,7 @@
           <a:lstStyle xmlns:a="http://schemas.openxmlformats.org/drawingml/2006/main"/>
           <a:p xmlns:a="http://schemas.openxmlformats.org/drawingml/2006/main">
             <a:r>
-              <a:t>Repository: https://github.com/shi1720/Nebius-x-NVIDIA . Founder/project creator credit: Shivam Gupta. AI assistance covered research, implementation, testing, and documentation; no additional personal actions or external validation are invented. Submission requires verified use of an NVIDIA open-source model on Nebius Token Factory or Nebius AI Cloud, a working public demo, public repository with license, and a public demo video at most three minutes with audio naming the provider and model. This deck is an honest MVP pitch, not a claim of readiness for real incident reliance.</a:t>
+              <a:t>Public demo: https://recallroom.web.app . Repository: https://github.com/shi1720/Nebius-x-NVIDIA . Application verification: 37 automated tests, 58 hosted Firebase API checks and 10 operator checks against production Firestore functions. Hosted API checks use real disposable Firebase accounts and synthetic records. Operator checks do not enqueue inference. Provider contracts use mocks. These results do not prove live NVIDIA inference, customer value, or real-world recall accuracy. Sources: docs/STATUS.md, docs/evaluation/firebase-api.json and docs/evaluation/firebase-operator.json. Founder/project creator credit: Shivam Gupta. AI assistance covered research, implementation, testing, and documentation; no additional personal actions or external validation are invented. Submission requires verified use of an NVIDIA open-source model on Nebius Token Factory or Nebius AI Cloud, a working public demo, public repository with license, and a public demo video at most three minutes with audio naming the provider and model. This deck is an honest MVP pitch, not a claim of readiness for real incident reliance.</a:t>
             </a:r>
           </a:p>
         </p:txBody>
@@ -865,7 +865,7 @@
   </p:cSld>
   <p:clrMap bg1="lt1" tx1="dk1" bg2="lt2" tx2="dk2" accent1="accent1" accent2="accent2" accent3="accent3" accent4="accent4" accent5="accent5" accent6="accent6" hlink="hlink" folHlink="folHlink"/>
   <p:sldLayoutIdLst>
-    <p:sldLayoutId xmlns:r="http://schemas.openxmlformats.org/officeDocument/2006/relationships" id="2147483649" r:id="R4273ed9ab5b74e3f"/>
+    <p:sldLayoutId xmlns:r="http://schemas.openxmlformats.org/officeDocument/2006/relationships" id="2147483649" r:id="Raba6836651854886"/>
   </p:sldLayoutIdLst>
   <p:txStyles>
     <p:titleStyle>
@@ -1413,10 +1413,341 @@
       </p:grpSpPr>
       <p:sp>
         <p:nvSpPr>
+          <p:cNvPr id="7" name="">
+            <a:extLst xmlns:a="http://schemas.openxmlformats.org/drawingml/2006/main">
+              <a:ext uri="{FF2B5EF4-FFF2-40B4-BE49-F238E27FC236}">
+                <a16:creationId xmlns:a16="http://schemas.microsoft.com/office/drawing/2014/main" id="{CF5C17A8-F587-4EA0-8052-50C236A3DCE7}"/>
+              </a:ext>
+            </a:extLst>
+          </p:cNvPr>
+          <p:cNvSpPr>
+            <a:spLocks xmlns:a="http://schemas.openxmlformats.org/drawingml/2006/main" noGrp="1"/>
+          </p:cNvSpPr>
+          <p:nvPr/>
+        </p:nvSpPr>
+        <p:spPr>
+          <a:xfrm xmlns:a="http://schemas.openxmlformats.org/drawingml/2006/main">
+            <a:off x="609600" y="1304925"/>
+            <a:ext cx="10477500" cy="1095375"/>
+          </a:xfrm>
+          <a:prstGeom xmlns:a="http://schemas.openxmlformats.org/drawingml/2006/main" prst="rect">
+            <a:avLst/>
+          </a:prstGeom>
+          <a:noFill xmlns:a="http://schemas.openxmlformats.org/drawingml/2006/main"/>
+          <a:ln xmlns:a="http://schemas.openxmlformats.org/drawingml/2006/main" w="0">
+            <a:noFill/>
+          </a:ln>
+        </p:spPr>
+        <p:txBody>
+          <a:bodyPr xmlns:a="http://schemas.openxmlformats.org/drawingml/2006/main">
+            <a:noAutofit/>
+          </a:bodyPr>
+          <a:lstStyle xmlns:a="http://schemas.openxmlformats.org/drawingml/2006/main"/>
+          <a:p xmlns:a="http://schemas.openxmlformats.org/drawingml/2006/main">
+            <a:pPr>
+              <a:defRPr sz="6750" b="1">
+                <a:solidFill>
+                  <a:srgbClr val="FFFFFF"/>
+                </a:solidFill>
+                <a:latin typeface="Helvetica Neue"/>
+                <a:ea typeface="Helvetica Neue"/>
+                <a:cs typeface="Helvetica Neue"/>
+              </a:defRPr>
+            </a:pPr>
+            <a:r>
+              <a:rPr sz="6750" b="1">
+                <a:solidFill>
+                  <a:srgbClr val="FFFFFF"/>
+                </a:solidFill>
+                <a:latin typeface="Helvetica Neue"/>
+                <a:ea typeface="Helvetica Neue"/>
+                <a:cs typeface="Helvetica Neue"/>
+              </a:rPr>
+              <a:t>RecallRoom</a:t>
+            </a:r>
+          </a:p>
+        </p:txBody>
+      </p:sp>
+      <p:sp>
+        <p:nvSpPr>
+          <p:cNvPr id="2" name="">
+            <a:extLst xmlns:a="http://schemas.openxmlformats.org/drawingml/2006/main">
+              <a:ext uri="{FF2B5EF4-FFF2-40B4-BE49-F238E27FC236}">
+                <a16:creationId xmlns:a16="http://schemas.microsoft.com/office/drawing/2014/main" id="{8EC0EF8B-11C9-4E81-BC3A-CB8B6BB2A42F}"/>
+              </a:ext>
+            </a:extLst>
+          </p:cNvPr>
+          <p:cNvSpPr>
+            <a:spLocks xmlns:a="http://schemas.openxmlformats.org/drawingml/2006/main" noGrp="1"/>
+          </p:cNvSpPr>
+          <p:nvPr/>
+        </p:nvSpPr>
+        <p:spPr>
+          <a:xfrm xmlns:a="http://schemas.openxmlformats.org/drawingml/2006/main">
+            <a:off x="647700" y="2733675"/>
+            <a:ext cx="10382250" cy="1428750"/>
+          </a:xfrm>
+          <a:prstGeom xmlns:a="http://schemas.openxmlformats.org/drawingml/2006/main" prst="rect">
+            <a:avLst/>
+          </a:prstGeom>
+          <a:noFill xmlns:a="http://schemas.openxmlformats.org/drawingml/2006/main"/>
+          <a:ln xmlns:a="http://schemas.openxmlformats.org/drawingml/2006/main" w="0">
+            <a:noFill/>
+          </a:ln>
+        </p:spPr>
+        <p:txBody>
+          <a:bodyPr xmlns:a="http://schemas.openxmlformats.org/drawingml/2006/main">
+            <a:noAutofit/>
+          </a:bodyPr>
+          <a:lstStyle xmlns:a="http://schemas.openxmlformats.org/drawingml/2006/main"/>
+          <a:p xmlns:a="http://schemas.openxmlformats.org/drawingml/2006/main">
+            <a:pPr>
+              <a:defRPr sz="3225" b="0">
+                <a:solidFill>
+                  <a:srgbClr val="A6E1CB"/>
+                </a:solidFill>
+                <a:latin typeface="Helvetica Neue"/>
+                <a:ea typeface="Helvetica Neue"/>
+                <a:cs typeface="Helvetica Neue"/>
+              </a:defRPr>
+            </a:pPr>
+            <a:r>
+              <a:rPr sz="3225" b="0">
+                <a:solidFill>
+                  <a:srgbClr val="A6E1CB"/>
+                </a:solidFill>
+                <a:latin typeface="Helvetica Neue"/>
+                <a:ea typeface="Helvetica Neue"/>
+                <a:cs typeface="Helvetica Neue"/>
+              </a:rPr>
+              <a:t>A supplier recalls one ingredient lot.</a:t>
+            </a:r>
+          </a:p>
+          <a:p xmlns:a="http://schemas.openxmlformats.org/drawingml/2006/main">
+            <a:pPr>
+              <a:defRPr sz="3225" b="0">
+                <a:solidFill>
+                  <a:srgbClr val="A6E1CB"/>
+                </a:solidFill>
+                <a:latin typeface="Helvetica Neue"/>
+                <a:ea typeface="Helvetica Neue"/>
+                <a:cs typeface="Helvetica Neue"/>
+              </a:defRPr>
+            </a:pPr>
+            <a:r>
+              <a:rPr sz="3225" b="0">
+                <a:solidFill>
+                  <a:srgbClr val="A6E1CB"/>
+                </a:solidFill>
+                <a:latin typeface="Helvetica Neue"/>
+                <a:ea typeface="Helvetica Neue"/>
+                <a:cs typeface="Helvetica Neue"/>
+              </a:rPr>
+              <a:t>Which products and customers did it reach?</a:t>
+            </a:r>
+          </a:p>
+        </p:txBody>
+      </p:sp>
+      <p:sp>
+        <p:nvSpPr>
+          <p:cNvPr id="3" name="">
+            <a:extLst xmlns:a="http://schemas.openxmlformats.org/drawingml/2006/main">
+              <a:ext uri="{FF2B5EF4-FFF2-40B4-BE49-F238E27FC236}">
+                <a16:creationId xmlns:a16="http://schemas.microsoft.com/office/drawing/2014/main" id="{86E5F057-03B6-4229-996F-54083BD33411}"/>
+              </a:ext>
+            </a:extLst>
+          </p:cNvPr>
+          <p:cNvSpPr>
+            <a:spLocks xmlns:a="http://schemas.openxmlformats.org/drawingml/2006/main" noGrp="1"/>
+          </p:cNvSpPr>
+          <p:nvPr/>
+        </p:nvSpPr>
+        <p:spPr>
+          <a:xfrm xmlns:a="http://schemas.openxmlformats.org/drawingml/2006/main">
+            <a:off x="647700" y="4552950"/>
+            <a:ext cx="10382250" cy="476250"/>
+          </a:xfrm>
+          <a:prstGeom xmlns:a="http://schemas.openxmlformats.org/drawingml/2006/main" prst="rect">
+            <a:avLst/>
+          </a:prstGeom>
+          <a:noFill xmlns:a="http://schemas.openxmlformats.org/drawingml/2006/main"/>
+          <a:ln xmlns:a="http://schemas.openxmlformats.org/drawingml/2006/main" w="0">
+            <a:noFill/>
+          </a:ln>
+        </p:spPr>
+        <p:txBody>
+          <a:bodyPr xmlns:a="http://schemas.openxmlformats.org/drawingml/2006/main">
+            <a:noAutofit/>
+          </a:bodyPr>
+          <a:lstStyle xmlns:a="http://schemas.openxmlformats.org/drawingml/2006/main"/>
+          <a:p xmlns:a="http://schemas.openxmlformats.org/drawingml/2006/main">
+            <a:pPr>
+              <a:defRPr sz="2025" b="0">
+                <a:solidFill>
+                  <a:srgbClr val="FFFFFF"/>
+                </a:solidFill>
+                <a:latin typeface="Helvetica Neue"/>
+                <a:ea typeface="Helvetica Neue"/>
+                <a:cs typeface="Helvetica Neue"/>
+              </a:defRPr>
+            </a:pPr>
+            <a:r>
+              <a:rPr sz="2025" b="0">
+                <a:solidFill>
+                  <a:srgbClr val="FFFFFF"/>
+                </a:solidFill>
+                <a:latin typeface="Helvetica Neue"/>
+                <a:ea typeface="Helvetica Neue"/>
+                <a:cs typeface="Helvetica Neue"/>
+              </a:rPr>
+              <a:t>An evidence workspace for small food manufacturers</a:t>
+            </a:r>
+          </a:p>
+        </p:txBody>
+      </p:sp>
+      <p:sp>
+        <p:nvSpPr>
+          <p:cNvPr id="4" name="">
+            <a:extLst xmlns:a="http://schemas.openxmlformats.org/drawingml/2006/main">
+              <a:ext uri="{FF2B5EF4-FFF2-40B4-BE49-F238E27FC236}">
+                <a16:creationId xmlns:a16="http://schemas.microsoft.com/office/drawing/2014/main" id="{84B71015-9A69-4823-83D2-5D61C8227A58}"/>
+              </a:ext>
+            </a:extLst>
+          </p:cNvPr>
+          <p:cNvSpPr>
+            <a:spLocks xmlns:a="http://schemas.openxmlformats.org/drawingml/2006/main" noGrp="1"/>
+          </p:cNvSpPr>
+          <p:nvPr/>
+        </p:nvSpPr>
+        <p:spPr>
+          <a:xfrm xmlns:a="http://schemas.openxmlformats.org/drawingml/2006/main">
+            <a:off x="647700" y="5162550"/>
+            <a:ext cx="10382250" cy="342900"/>
+          </a:xfrm>
+          <a:prstGeom xmlns:a="http://schemas.openxmlformats.org/drawingml/2006/main" prst="rect">
+            <a:avLst/>
+          </a:prstGeom>
+          <a:noFill xmlns:a="http://schemas.openxmlformats.org/drawingml/2006/main"/>
+          <a:ln xmlns:a="http://schemas.openxmlformats.org/drawingml/2006/main" w="0">
+            <a:noFill/>
+          </a:ln>
+        </p:spPr>
+        <p:txBody>
+          <a:bodyPr xmlns:a="http://schemas.openxmlformats.org/drawingml/2006/main">
+            <a:noAutofit/>
+          </a:bodyPr>
+          <a:lstStyle xmlns:a="http://schemas.openxmlformats.org/drawingml/2006/main"/>
+          <a:p xmlns:a="http://schemas.openxmlformats.org/drawingml/2006/main">
+            <a:pPr>
+              <a:defRPr sz="1875" b="0">
+                <a:solidFill>
+                  <a:srgbClr val="A6E1CB"/>
+                </a:solidFill>
+                <a:latin typeface="Helvetica Neue"/>
+                <a:ea typeface="Helvetica Neue"/>
+                <a:cs typeface="Helvetica Neue"/>
+              </a:defRPr>
+            </a:pPr>
+            <a:r>
+              <a:rPr sz="1875" b="0">
+                <a:solidFill>
+                  <a:srgbClr val="A6E1CB"/>
+                </a:solidFill>
+                <a:latin typeface="Helvetica Neue"/>
+                <a:ea typeface="Helvetica Neue"/>
+                <a:cs typeface="Helvetica Neue"/>
+              </a:rPr>
+              <a:t>recallroom.web.app</a:t>
+            </a:r>
+          </a:p>
+        </p:txBody>
+      </p:sp>
+      <p:sp>
+        <p:nvSpPr>
+          <p:cNvPr id="5" name="">
+            <a:extLst xmlns:a="http://schemas.openxmlformats.org/drawingml/2006/main">
+              <a:ext uri="{FF2B5EF4-FFF2-40B4-BE49-F238E27FC236}">
+                <a16:creationId xmlns:a16="http://schemas.microsoft.com/office/drawing/2014/main" id="{12F87530-E1B5-4554-9947-506440E80987}"/>
+              </a:ext>
+            </a:extLst>
+          </p:cNvPr>
+          <p:cNvSpPr>
+            <a:spLocks xmlns:a="http://schemas.openxmlformats.org/drawingml/2006/main" noGrp="1"/>
+          </p:cNvSpPr>
+          <p:nvPr/>
+        </p:nvSpPr>
+        <p:spPr>
+          <a:xfrm xmlns:a="http://schemas.openxmlformats.org/drawingml/2006/main">
+            <a:off x="647700" y="5734050"/>
+            <a:ext cx="6858000" cy="552450"/>
+          </a:xfrm>
+          <a:prstGeom xmlns:a="http://schemas.openxmlformats.org/drawingml/2006/main" prst="rect">
+            <a:avLst/>
+          </a:prstGeom>
+          <a:noFill xmlns:a="http://schemas.openxmlformats.org/drawingml/2006/main"/>
+          <a:ln xmlns:a="http://schemas.openxmlformats.org/drawingml/2006/main" w="0">
+            <a:noFill/>
+          </a:ln>
+        </p:spPr>
+        <p:txBody>
+          <a:bodyPr xmlns:a="http://schemas.openxmlformats.org/drawingml/2006/main">
+            <a:noAutofit/>
+          </a:bodyPr>
+          <a:lstStyle xmlns:a="http://schemas.openxmlformats.org/drawingml/2006/main"/>
+          <a:p xmlns:a="http://schemas.openxmlformats.org/drawingml/2006/main">
+            <a:pPr>
+              <a:defRPr sz="1650" b="0">
+                <a:solidFill>
+                  <a:srgbClr val="FFFFFF"/>
+                </a:solidFill>
+                <a:latin typeface="Helvetica Neue"/>
+                <a:ea typeface="Helvetica Neue"/>
+                <a:cs typeface="Helvetica Neue"/>
+              </a:defRPr>
+            </a:pPr>
+            <a:r>
+              <a:rPr sz="1650" b="0">
+                <a:solidFill>
+                  <a:srgbClr val="FFFFFF"/>
+                </a:solidFill>
+                <a:latin typeface="Helvetica Neue"/>
+                <a:ea typeface="Helvetica Neue"/>
+                <a:cs typeface="Helvetica Neue"/>
+              </a:rPr>
+              <a:t>Shivam Gupta</a:t>
+            </a:r>
+          </a:p>
+          <a:p xmlns:a="http://schemas.openxmlformats.org/drawingml/2006/main">
+            <a:pPr>
+              <a:defRPr sz="1650" b="0">
+                <a:solidFill>
+                  <a:srgbClr val="FFFFFF"/>
+                </a:solidFill>
+                <a:latin typeface="Helvetica Neue"/>
+                <a:ea typeface="Helvetica Neue"/>
+                <a:cs typeface="Helvetica Neue"/>
+              </a:defRPr>
+            </a:pPr>
+            <a:r>
+              <a:rPr sz="1650" b="0">
+                <a:solidFill>
+                  <a:srgbClr val="FFFFFF"/>
+                </a:solidFill>
+                <a:latin typeface="Helvetica Neue"/>
+                <a:ea typeface="Helvetica Neue"/>
+                <a:cs typeface="Helvetica Neue"/>
+              </a:rPr>
+              <a:t>Project creator</a:t>
+            </a:r>
+          </a:p>
+        </p:txBody>
+      </p:sp>
+      <p:sp>
+        <p:nvSpPr>
           <p:cNvPr id="6" name="">
             <a:extLst xmlns:a="http://schemas.openxmlformats.org/drawingml/2006/main">
               <a:ext uri="{FF2B5EF4-FFF2-40B4-BE49-F238E27FC236}">
-                <a16:creationId xmlns:a16="http://schemas.microsoft.com/office/drawing/2014/main" id="{72090A5E-D5CC-43B7-ABEB-2EC4D0EEC06B}"/>
+                <a16:creationId xmlns:a16="http://schemas.microsoft.com/office/drawing/2014/main" id="{477C78F6-D897-4F93-A1B2-B99954B66CF6}"/>
               </a:ext>
             </a:extLst>
           </p:cNvPr>
@@ -1427,8 +1758,8 @@
         </p:nvSpPr>
         <p:spPr>
           <a:xfrm xmlns:a="http://schemas.openxmlformats.org/drawingml/2006/main">
-            <a:off x="609600" y="1304925"/>
-            <a:ext cx="10477500" cy="1095375"/>
+            <a:off x="8534400" y="5734050"/>
+            <a:ext cx="3048000" cy="552450"/>
           </a:xfrm>
           <a:prstGeom xmlns:a="http://schemas.openxmlformats.org/drawingml/2006/main" prst="rect">
             <a:avLst/>
@@ -1445,280 +1776,6 @@
           <a:lstStyle xmlns:a="http://schemas.openxmlformats.org/drawingml/2006/main"/>
           <a:p xmlns:a="http://schemas.openxmlformats.org/drawingml/2006/main">
             <a:pPr>
-              <a:defRPr sz="6750" b="1">
-                <a:solidFill>
-                  <a:srgbClr val="FFFFFF"/>
-                </a:solidFill>
-                <a:latin typeface="Helvetica Neue"/>
-                <a:ea typeface="Helvetica Neue"/>
-                <a:cs typeface="Helvetica Neue"/>
-              </a:defRPr>
-            </a:pPr>
-            <a:r>
-              <a:rPr sz="6750" b="1">
-                <a:solidFill>
-                  <a:srgbClr val="FFFFFF"/>
-                </a:solidFill>
-                <a:latin typeface="Helvetica Neue"/>
-                <a:ea typeface="Helvetica Neue"/>
-                <a:cs typeface="Helvetica Neue"/>
-              </a:rPr>
-              <a:t>RecallRoom</a:t>
-            </a:r>
-          </a:p>
-        </p:txBody>
-      </p:sp>
-      <p:sp>
-        <p:nvSpPr>
-          <p:cNvPr id="2" name="">
-            <a:extLst xmlns:a="http://schemas.openxmlformats.org/drawingml/2006/main">
-              <a:ext uri="{FF2B5EF4-FFF2-40B4-BE49-F238E27FC236}">
-                <a16:creationId xmlns:a16="http://schemas.microsoft.com/office/drawing/2014/main" id="{FAC3816E-C343-4F3B-BAE4-92EBAE452EA9}"/>
-              </a:ext>
-            </a:extLst>
-          </p:cNvPr>
-          <p:cNvSpPr>
-            <a:spLocks xmlns:a="http://schemas.openxmlformats.org/drawingml/2006/main" noGrp="1"/>
-          </p:cNvSpPr>
-          <p:nvPr/>
-        </p:nvSpPr>
-        <p:spPr>
-          <a:xfrm xmlns:a="http://schemas.openxmlformats.org/drawingml/2006/main">
-            <a:off x="647700" y="2733675"/>
-            <a:ext cx="10382250" cy="1428750"/>
-          </a:xfrm>
-          <a:prstGeom xmlns:a="http://schemas.openxmlformats.org/drawingml/2006/main" prst="rect">
-            <a:avLst/>
-          </a:prstGeom>
-          <a:noFill xmlns:a="http://schemas.openxmlformats.org/drawingml/2006/main"/>
-          <a:ln xmlns:a="http://schemas.openxmlformats.org/drawingml/2006/main" w="0">
-            <a:noFill/>
-          </a:ln>
-        </p:spPr>
-        <p:txBody>
-          <a:bodyPr xmlns:a="http://schemas.openxmlformats.org/drawingml/2006/main">
-            <a:noAutofit/>
-          </a:bodyPr>
-          <a:lstStyle xmlns:a="http://schemas.openxmlformats.org/drawingml/2006/main"/>
-          <a:p xmlns:a="http://schemas.openxmlformats.org/drawingml/2006/main">
-            <a:pPr>
-              <a:defRPr sz="3225" b="0">
-                <a:solidFill>
-                  <a:srgbClr val="A6E1CB"/>
-                </a:solidFill>
-                <a:latin typeface="Helvetica Neue"/>
-                <a:ea typeface="Helvetica Neue"/>
-                <a:cs typeface="Helvetica Neue"/>
-              </a:defRPr>
-            </a:pPr>
-            <a:r>
-              <a:rPr sz="3225" b="0">
-                <a:solidFill>
-                  <a:srgbClr val="A6E1CB"/>
-                </a:solidFill>
-                <a:latin typeface="Helvetica Neue"/>
-                <a:ea typeface="Helvetica Neue"/>
-                <a:cs typeface="Helvetica Neue"/>
-              </a:rPr>
-              <a:t>A supplier recalls one ingredient lot.</a:t>
-            </a:r>
-          </a:p>
-          <a:p xmlns:a="http://schemas.openxmlformats.org/drawingml/2006/main">
-            <a:pPr>
-              <a:defRPr sz="3225" b="0">
-                <a:solidFill>
-                  <a:srgbClr val="A6E1CB"/>
-                </a:solidFill>
-                <a:latin typeface="Helvetica Neue"/>
-                <a:ea typeface="Helvetica Neue"/>
-                <a:cs typeface="Helvetica Neue"/>
-              </a:defRPr>
-            </a:pPr>
-            <a:r>
-              <a:rPr sz="3225" b="0">
-                <a:solidFill>
-                  <a:srgbClr val="A6E1CB"/>
-                </a:solidFill>
-                <a:latin typeface="Helvetica Neue"/>
-                <a:ea typeface="Helvetica Neue"/>
-                <a:cs typeface="Helvetica Neue"/>
-              </a:rPr>
-              <a:t>Which products and customers did it reach?</a:t>
-            </a:r>
-          </a:p>
-        </p:txBody>
-      </p:sp>
-      <p:sp>
-        <p:nvSpPr>
-          <p:cNvPr id="3" name="">
-            <a:extLst xmlns:a="http://schemas.openxmlformats.org/drawingml/2006/main">
-              <a:ext uri="{FF2B5EF4-FFF2-40B4-BE49-F238E27FC236}">
-                <a16:creationId xmlns:a16="http://schemas.microsoft.com/office/drawing/2014/main" id="{632D12AB-09C9-48E9-BD2D-9C783F57C9FB}"/>
-              </a:ext>
-            </a:extLst>
-          </p:cNvPr>
-          <p:cNvSpPr>
-            <a:spLocks xmlns:a="http://schemas.openxmlformats.org/drawingml/2006/main" noGrp="1"/>
-          </p:cNvSpPr>
-          <p:nvPr/>
-        </p:nvSpPr>
-        <p:spPr>
-          <a:xfrm xmlns:a="http://schemas.openxmlformats.org/drawingml/2006/main">
-            <a:off x="647700" y="4552950"/>
-            <a:ext cx="10382250" cy="476250"/>
-          </a:xfrm>
-          <a:prstGeom xmlns:a="http://schemas.openxmlformats.org/drawingml/2006/main" prst="rect">
-            <a:avLst/>
-          </a:prstGeom>
-          <a:noFill xmlns:a="http://schemas.openxmlformats.org/drawingml/2006/main"/>
-          <a:ln xmlns:a="http://schemas.openxmlformats.org/drawingml/2006/main" w="0">
-            <a:noFill/>
-          </a:ln>
-        </p:spPr>
-        <p:txBody>
-          <a:bodyPr xmlns:a="http://schemas.openxmlformats.org/drawingml/2006/main">
-            <a:noAutofit/>
-          </a:bodyPr>
-          <a:lstStyle xmlns:a="http://schemas.openxmlformats.org/drawingml/2006/main"/>
-          <a:p xmlns:a="http://schemas.openxmlformats.org/drawingml/2006/main">
-            <a:pPr>
-              <a:defRPr sz="2025" b="0">
-                <a:solidFill>
-                  <a:srgbClr val="FFFFFF"/>
-                </a:solidFill>
-                <a:latin typeface="Helvetica Neue"/>
-                <a:ea typeface="Helvetica Neue"/>
-                <a:cs typeface="Helvetica Neue"/>
-              </a:defRPr>
-            </a:pPr>
-            <a:r>
-              <a:rPr sz="2025" b="0">
-                <a:solidFill>
-                  <a:srgbClr val="FFFFFF"/>
-                </a:solidFill>
-                <a:latin typeface="Helvetica Neue"/>
-                <a:ea typeface="Helvetica Neue"/>
-                <a:cs typeface="Helvetica Neue"/>
-              </a:rPr>
-              <a:t>An evidence workspace for small food manufacturers</a:t>
-            </a:r>
-          </a:p>
-        </p:txBody>
-      </p:sp>
-      <p:sp>
-        <p:nvSpPr>
-          <p:cNvPr id="4" name="">
-            <a:extLst xmlns:a="http://schemas.openxmlformats.org/drawingml/2006/main">
-              <a:ext uri="{FF2B5EF4-FFF2-40B4-BE49-F238E27FC236}">
-                <a16:creationId xmlns:a16="http://schemas.microsoft.com/office/drawing/2014/main" id="{145A7DFC-64B9-44B4-A5E6-99AB4C9CF420}"/>
-              </a:ext>
-            </a:extLst>
-          </p:cNvPr>
-          <p:cNvSpPr>
-            <a:spLocks xmlns:a="http://schemas.openxmlformats.org/drawingml/2006/main" noGrp="1"/>
-          </p:cNvSpPr>
-          <p:nvPr/>
-        </p:nvSpPr>
-        <p:spPr>
-          <a:xfrm xmlns:a="http://schemas.openxmlformats.org/drawingml/2006/main">
-            <a:off x="647700" y="5734050"/>
-            <a:ext cx="6858000" cy="552450"/>
-          </a:xfrm>
-          <a:prstGeom xmlns:a="http://schemas.openxmlformats.org/drawingml/2006/main" prst="rect">
-            <a:avLst/>
-          </a:prstGeom>
-          <a:noFill xmlns:a="http://schemas.openxmlformats.org/drawingml/2006/main"/>
-          <a:ln xmlns:a="http://schemas.openxmlformats.org/drawingml/2006/main" w="0">
-            <a:noFill/>
-          </a:ln>
-        </p:spPr>
-        <p:txBody>
-          <a:bodyPr xmlns:a="http://schemas.openxmlformats.org/drawingml/2006/main">
-            <a:noAutofit/>
-          </a:bodyPr>
-          <a:lstStyle xmlns:a="http://schemas.openxmlformats.org/drawingml/2006/main"/>
-          <a:p xmlns:a="http://schemas.openxmlformats.org/drawingml/2006/main">
-            <a:pPr>
-              <a:defRPr sz="1650" b="0">
-                <a:solidFill>
-                  <a:srgbClr val="FFFFFF"/>
-                </a:solidFill>
-                <a:latin typeface="Helvetica Neue"/>
-                <a:ea typeface="Helvetica Neue"/>
-                <a:cs typeface="Helvetica Neue"/>
-              </a:defRPr>
-            </a:pPr>
-            <a:r>
-              <a:rPr sz="1650" b="0">
-                <a:solidFill>
-                  <a:srgbClr val="FFFFFF"/>
-                </a:solidFill>
-                <a:latin typeface="Helvetica Neue"/>
-                <a:ea typeface="Helvetica Neue"/>
-                <a:cs typeface="Helvetica Neue"/>
-              </a:rPr>
-              <a:t>Shivam Gupta</a:t>
-            </a:r>
-          </a:p>
-          <a:p xmlns:a="http://schemas.openxmlformats.org/drawingml/2006/main">
-            <a:pPr>
-              <a:defRPr sz="1650" b="0">
-                <a:solidFill>
-                  <a:srgbClr val="FFFFFF"/>
-                </a:solidFill>
-                <a:latin typeface="Helvetica Neue"/>
-                <a:ea typeface="Helvetica Neue"/>
-                <a:cs typeface="Helvetica Neue"/>
-              </a:defRPr>
-            </a:pPr>
-            <a:r>
-              <a:rPr sz="1650" b="0">
-                <a:solidFill>
-                  <a:srgbClr val="FFFFFF"/>
-                </a:solidFill>
-                <a:latin typeface="Helvetica Neue"/>
-                <a:ea typeface="Helvetica Neue"/>
-                <a:cs typeface="Helvetica Neue"/>
-              </a:rPr>
-              <a:t>Project creator</a:t>
-            </a:r>
-          </a:p>
-        </p:txBody>
-      </p:sp>
-      <p:sp>
-        <p:nvSpPr>
-          <p:cNvPr id="5" name="">
-            <a:extLst xmlns:a="http://schemas.openxmlformats.org/drawingml/2006/main">
-              <a:ext uri="{FF2B5EF4-FFF2-40B4-BE49-F238E27FC236}">
-                <a16:creationId xmlns:a16="http://schemas.microsoft.com/office/drawing/2014/main" id="{08919110-AEBA-4C25-B3E2-F8AAF7D57F91}"/>
-              </a:ext>
-            </a:extLst>
-          </p:cNvPr>
-          <p:cNvSpPr>
-            <a:spLocks xmlns:a="http://schemas.openxmlformats.org/drawingml/2006/main" noGrp="1"/>
-          </p:cNvSpPr>
-          <p:nvPr/>
-        </p:nvSpPr>
-        <p:spPr>
-          <a:xfrm xmlns:a="http://schemas.openxmlformats.org/drawingml/2006/main">
-            <a:off x="8534400" y="5734050"/>
-            <a:ext cx="3048000" cy="552450"/>
-          </a:xfrm>
-          <a:prstGeom xmlns:a="http://schemas.openxmlformats.org/drawingml/2006/main" prst="rect">
-            <a:avLst/>
-          </a:prstGeom>
-          <a:noFill xmlns:a="http://schemas.openxmlformats.org/drawingml/2006/main"/>
-          <a:ln xmlns:a="http://schemas.openxmlformats.org/drawingml/2006/main" w="0">
-            <a:noFill/>
-          </a:ln>
-        </p:spPr>
-        <p:txBody>
-          <a:bodyPr xmlns:a="http://schemas.openxmlformats.org/drawingml/2006/main">
-            <a:noAutofit/>
-          </a:bodyPr>
-          <a:lstStyle xmlns:a="http://schemas.openxmlformats.org/drawingml/2006/main"/>
-          <a:p xmlns:a="http://schemas.openxmlformats.org/drawingml/2006/main">
-            <a:pPr>
               <a:defRPr sz="1650" b="0">
                 <a:solidFill>
                   <a:srgbClr val="A6E1CB"/>
@@ -1768,7 +1825,7 @@
     </p:spTree>
     <p:extLst>
       <p:ext uri="{BB962C8B-B14F-4D97-AF65-F5344CB8AC3E}">
-        <p14:creationId xmlns:p14="http://schemas.microsoft.com/office/powerpoint/2010/main" val="549135376"/>
+        <p14:creationId xmlns:p14="http://schemas.microsoft.com/office/powerpoint/2010/main" val="788433132"/>
       </p:ext>
     </p:extLst>
   </p:cSld>
@@ -1799,7 +1856,7 @@
           <p:cNvPr id="18" name="">
             <a:extLst xmlns:a="http://schemas.openxmlformats.org/drawingml/2006/main">
               <a:ext uri="{FF2B5EF4-FFF2-40B4-BE49-F238E27FC236}">
-                <a16:creationId xmlns:a16="http://schemas.microsoft.com/office/drawing/2014/main" id="{ACFC3F12-BADF-49AE-BED0-9C0A003D96B6}"/>
+                <a16:creationId xmlns:a16="http://schemas.microsoft.com/office/drawing/2014/main" id="{DF793AEA-2BAA-4114-9C78-AC44B40AB9E2}"/>
               </a:ext>
             </a:extLst>
           </p:cNvPr>
@@ -1856,7 +1913,7 @@
           <p:cNvPr id="2" name="">
             <a:extLst xmlns:a="http://schemas.openxmlformats.org/drawingml/2006/main">
               <a:ext uri="{FF2B5EF4-FFF2-40B4-BE49-F238E27FC236}">
-                <a16:creationId xmlns:a16="http://schemas.microsoft.com/office/drawing/2014/main" id="{B721633C-34DE-41D1-91EF-FF4A6469A05A}"/>
+                <a16:creationId xmlns:a16="http://schemas.microsoft.com/office/drawing/2014/main" id="{9F06051C-23B6-425A-B3D5-311E930AA0A5}"/>
               </a:ext>
             </a:extLst>
           </p:cNvPr>
@@ -1913,7 +1970,7 @@
           <p:cNvPr id="3" name="">
             <a:extLst xmlns:a="http://schemas.openxmlformats.org/drawingml/2006/main">
               <a:ext uri="{FF2B5EF4-FFF2-40B4-BE49-F238E27FC236}">
-                <a16:creationId xmlns:a16="http://schemas.microsoft.com/office/drawing/2014/main" id="{53D24517-F4CF-4DE1-8009-316A39D34157}"/>
+                <a16:creationId xmlns:a16="http://schemas.microsoft.com/office/drawing/2014/main" id="{2736C22A-0236-40F8-BA50-8717727C415B}"/>
               </a:ext>
             </a:extLst>
           </p:cNvPr>
@@ -1970,7 +2027,7 @@
           <p:cNvPr id="4" name="">
             <a:extLst xmlns:a="http://schemas.openxmlformats.org/drawingml/2006/main">
               <a:ext uri="{FF2B5EF4-FFF2-40B4-BE49-F238E27FC236}">
-                <a16:creationId xmlns:a16="http://schemas.microsoft.com/office/drawing/2014/main" id="{4DDEB30E-50B3-4764-AD7D-C95F2D1404F7}"/>
+                <a16:creationId xmlns:a16="http://schemas.microsoft.com/office/drawing/2014/main" id="{9A167458-0577-4A10-9DD2-0D0F241AFFE4}"/>
               </a:ext>
             </a:extLst>
           </p:cNvPr>
@@ -2054,7 +2111,7 @@
           <p:cNvPr id="5" name="">
             <a:extLst xmlns:a="http://schemas.openxmlformats.org/drawingml/2006/main">
               <a:ext uri="{FF2B5EF4-FFF2-40B4-BE49-F238E27FC236}">
-                <a16:creationId xmlns:a16="http://schemas.microsoft.com/office/drawing/2014/main" id="{8294B085-09C7-455D-8F95-2667617DC37A}"/>
+                <a16:creationId xmlns:a16="http://schemas.microsoft.com/office/drawing/2014/main" id="{459EF511-2228-4699-AC65-7C8DC1925507}"/>
               </a:ext>
             </a:extLst>
           </p:cNvPr>
@@ -2138,7 +2195,7 @@
           <p:cNvPr id="6" name="">
             <a:extLst xmlns:a="http://schemas.openxmlformats.org/drawingml/2006/main">
               <a:ext uri="{FF2B5EF4-FFF2-40B4-BE49-F238E27FC236}">
-                <a16:creationId xmlns:a16="http://schemas.microsoft.com/office/drawing/2014/main" id="{D0B30712-E376-49E1-9F13-32F95BF69CA5}"/>
+                <a16:creationId xmlns:a16="http://schemas.microsoft.com/office/drawing/2014/main" id="{894FF768-AD83-42D4-93EB-EA6E23B6AE33}"/>
               </a:ext>
             </a:extLst>
           </p:cNvPr>
@@ -2222,7 +2279,7 @@
           <p:cNvPr id="7" name="">
             <a:extLst xmlns:a="http://schemas.openxmlformats.org/drawingml/2006/main">
               <a:ext uri="{FF2B5EF4-FFF2-40B4-BE49-F238E27FC236}">
-                <a16:creationId xmlns:a16="http://schemas.microsoft.com/office/drawing/2014/main" id="{049AF6C2-AFE3-460B-9B15-A5C330062C60}"/>
+                <a16:creationId xmlns:a16="http://schemas.microsoft.com/office/drawing/2014/main" id="{88641617-B341-470F-9A0C-D285224DF5C2}"/>
               </a:ext>
             </a:extLst>
           </p:cNvPr>
@@ -2306,7 +2363,7 @@
           <p:cNvPr id="8" name="">
             <a:extLst xmlns:a="http://schemas.openxmlformats.org/drawingml/2006/main">
               <a:ext uri="{FF2B5EF4-FFF2-40B4-BE49-F238E27FC236}">
-                <a16:creationId xmlns:a16="http://schemas.microsoft.com/office/drawing/2014/main" id="{0B398C23-6579-4147-8EF2-DB3028FFA0D1}"/>
+                <a16:creationId xmlns:a16="http://schemas.microsoft.com/office/drawing/2014/main" id="{491FBF08-A8C0-47E1-97C1-E685F8F0A1A8}"/>
               </a:ext>
             </a:extLst>
           </p:cNvPr>
@@ -2390,7 +2447,7 @@
           <p:cNvPr id="9" name="">
             <a:extLst xmlns:a="http://schemas.openxmlformats.org/drawingml/2006/main">
               <a:ext uri="{FF2B5EF4-FFF2-40B4-BE49-F238E27FC236}">
-                <a16:creationId xmlns:a16="http://schemas.microsoft.com/office/drawing/2014/main" id="{F6B39747-831E-4D35-B4CA-4C30A741FD34}"/>
+                <a16:creationId xmlns:a16="http://schemas.microsoft.com/office/drawing/2014/main" id="{10C6935A-3508-45C4-8A85-A18DCB7D6127}"/>
               </a:ext>
             </a:extLst>
           </p:cNvPr>
@@ -2642,7 +2699,7 @@
           <p:cNvPr id="16" name="">
             <a:extLst xmlns:a="http://schemas.openxmlformats.org/drawingml/2006/main">
               <a:ext uri="{FF2B5EF4-FFF2-40B4-BE49-F238E27FC236}">
-                <a16:creationId xmlns:a16="http://schemas.microsoft.com/office/drawing/2014/main" id="{258F5C52-6426-4A1C-8505-EAA79F43DDDC}"/>
+                <a16:creationId xmlns:a16="http://schemas.microsoft.com/office/drawing/2014/main" id="{787FEF18-BC21-4C46-A717-1955A053A5B3}"/>
               </a:ext>
             </a:extLst>
           </p:cNvPr>
@@ -2699,7 +2756,7 @@
           <p:cNvPr id="17" name="">
             <a:extLst xmlns:a="http://schemas.openxmlformats.org/drawingml/2006/main">
               <a:ext uri="{FF2B5EF4-FFF2-40B4-BE49-F238E27FC236}">
-                <a16:creationId xmlns:a16="http://schemas.microsoft.com/office/drawing/2014/main" id="{DD503838-B876-45DB-ACCF-BB0464A39A88}"/>
+                <a16:creationId xmlns:a16="http://schemas.microsoft.com/office/drawing/2014/main" id="{A160867B-5AFD-4DEC-932A-11BEE9311CE8}"/>
               </a:ext>
             </a:extLst>
           </p:cNvPr>
@@ -2754,7 +2811,7 @@
     </p:spTree>
     <p:extLst>
       <p:ext uri="{BB962C8B-B14F-4D97-AF65-F5344CB8AC3E}">
-        <p14:creationId xmlns:p14="http://schemas.microsoft.com/office/powerpoint/2010/main" val="1376081006"/>
+        <p14:creationId xmlns:p14="http://schemas.microsoft.com/office/powerpoint/2010/main" val="1843487133"/>
       </p:ext>
     </p:extLst>
   </p:cSld>
@@ -2785,7 +2842,7 @@
           <p:cNvPr id="13" name="">
             <a:extLst xmlns:a="http://schemas.openxmlformats.org/drawingml/2006/main">
               <a:ext uri="{FF2B5EF4-FFF2-40B4-BE49-F238E27FC236}">
-                <a16:creationId xmlns:a16="http://schemas.microsoft.com/office/drawing/2014/main" id="{54116475-E19F-43E7-8DFC-35509A06000C}"/>
+                <a16:creationId xmlns:a16="http://schemas.microsoft.com/office/drawing/2014/main" id="{D2153BEE-4766-45B8-AC5F-314A46A5CB86}"/>
               </a:ext>
             </a:extLst>
           </p:cNvPr>
@@ -2842,7 +2899,7 @@
           <p:cNvPr id="2" name="">
             <a:extLst xmlns:a="http://schemas.openxmlformats.org/drawingml/2006/main">
               <a:ext uri="{FF2B5EF4-FFF2-40B4-BE49-F238E27FC236}">
-                <a16:creationId xmlns:a16="http://schemas.microsoft.com/office/drawing/2014/main" id="{16643066-0FD2-4F6F-80F2-7C6780C1331C}"/>
+                <a16:creationId xmlns:a16="http://schemas.microsoft.com/office/drawing/2014/main" id="{6AFCD8AA-876E-477F-B913-2796D2A68C7B}"/>
               </a:ext>
             </a:extLst>
           </p:cNvPr>
@@ -2899,7 +2956,7 @@
           <p:cNvPr id="3" name="">
             <a:extLst xmlns:a="http://schemas.openxmlformats.org/drawingml/2006/main">
               <a:ext uri="{FF2B5EF4-FFF2-40B4-BE49-F238E27FC236}">
-                <a16:creationId xmlns:a16="http://schemas.microsoft.com/office/drawing/2014/main" id="{83516A18-61F8-4DB2-A841-B37BE737E942}"/>
+                <a16:creationId xmlns:a16="http://schemas.microsoft.com/office/drawing/2014/main" id="{F0D07AF6-0199-423A-B7EB-1CE2F35F51FB}"/>
               </a:ext>
             </a:extLst>
           </p:cNvPr>
@@ -2956,7 +3013,7 @@
           <p:cNvPr id="4" name="">
             <a:extLst xmlns:a="http://schemas.openxmlformats.org/drawingml/2006/main">
               <a:ext uri="{FF2B5EF4-FFF2-40B4-BE49-F238E27FC236}">
-                <a16:creationId xmlns:a16="http://schemas.microsoft.com/office/drawing/2014/main" id="{F26B8948-E17A-4E42-9C24-162E04DC2202}"/>
+                <a16:creationId xmlns:a16="http://schemas.microsoft.com/office/drawing/2014/main" id="{9B5806AC-F31A-48AD-B851-403D33369236}"/>
               </a:ext>
             </a:extLst>
           </p:cNvPr>
@@ -3013,7 +3070,7 @@
           <p:cNvPr id="5" name="">
             <a:extLst xmlns:a="http://schemas.openxmlformats.org/drawingml/2006/main">
               <a:ext uri="{FF2B5EF4-FFF2-40B4-BE49-F238E27FC236}">
-                <a16:creationId xmlns:a16="http://schemas.microsoft.com/office/drawing/2014/main" id="{5E3AC2D1-01C0-4BFD-912E-F85B2D094DB0}"/>
+                <a16:creationId xmlns:a16="http://schemas.microsoft.com/office/drawing/2014/main" id="{418B74F0-5425-4776-B17E-FFB396F21841}"/>
               </a:ext>
             </a:extLst>
           </p:cNvPr>
@@ -3116,7 +3173,7 @@
           <p:cNvPr id="6" name="">
             <a:extLst xmlns:a="http://schemas.openxmlformats.org/drawingml/2006/main">
               <a:ext uri="{FF2B5EF4-FFF2-40B4-BE49-F238E27FC236}">
-                <a16:creationId xmlns:a16="http://schemas.microsoft.com/office/drawing/2014/main" id="{22EC54F8-5C12-4C48-BC9F-2CF6EEB68389}"/>
+                <a16:creationId xmlns:a16="http://schemas.microsoft.com/office/drawing/2014/main" id="{13FD8E38-C40B-406D-BC19-3CD4C710F5A1}"/>
               </a:ext>
             </a:extLst>
           </p:cNvPr>
@@ -3163,7 +3220,7 @@
                 <a:ea typeface="Helvetica Neue"/>
                 <a:cs typeface="Helvetica Neue"/>
               </a:rPr>
-              <a:t>40–50 kg</a:t>
+              <a:t>40-50 kg</a:t>
             </a:r>
           </a:p>
         </p:txBody>
@@ -3173,7 +3230,7 @@
           <p:cNvPr id="7" name="">
             <a:extLst xmlns:a="http://schemas.openxmlformats.org/drawingml/2006/main">
               <a:ext uri="{FF2B5EF4-FFF2-40B4-BE49-F238E27FC236}">
-                <a16:creationId xmlns:a16="http://schemas.microsoft.com/office/drawing/2014/main" id="{47877583-DD4E-4343-BC98-720352BF6251}"/>
+                <a16:creationId xmlns:a16="http://schemas.microsoft.com/office/drawing/2014/main" id="{34A59564-F7CD-468D-B168-6E557BF78C89}"/>
               </a:ext>
             </a:extLst>
           </p:cNvPr>
@@ -3230,7 +3287,7 @@
           <p:cNvPr id="8" name="">
             <a:extLst xmlns:a="http://schemas.openxmlformats.org/drawingml/2006/main">
               <a:ext uri="{FF2B5EF4-FFF2-40B4-BE49-F238E27FC236}">
-                <a16:creationId xmlns:a16="http://schemas.microsoft.com/office/drawing/2014/main" id="{3FC6D95C-FB32-4310-AD77-FB092A7C667E}"/>
+                <a16:creationId xmlns:a16="http://schemas.microsoft.com/office/drawing/2014/main" id="{A44CA76E-AA79-457A-91CA-049391C0FB9B}"/>
               </a:ext>
             </a:extLst>
           </p:cNvPr>
@@ -3287,7 +3344,7 @@
           <p:cNvPr id="9" name="">
             <a:extLst xmlns:a="http://schemas.openxmlformats.org/drawingml/2006/main">
               <a:ext uri="{FF2B5EF4-FFF2-40B4-BE49-F238E27FC236}">
-                <a16:creationId xmlns:a16="http://schemas.microsoft.com/office/drawing/2014/main" id="{0606549D-9187-44FD-899C-B96AC5AC7266}"/>
+                <a16:creationId xmlns:a16="http://schemas.microsoft.com/office/drawing/2014/main" id="{6781A426-C8D3-4D1D-8856-6D4A5DF1438B}"/>
               </a:ext>
             </a:extLst>
           </p:cNvPr>
@@ -3344,7 +3401,7 @@
           <p:cNvPr id="10" name="">
             <a:extLst xmlns:a="http://schemas.openxmlformats.org/drawingml/2006/main">
               <a:ext uri="{FF2B5EF4-FFF2-40B4-BE49-F238E27FC236}">
-                <a16:creationId xmlns:a16="http://schemas.microsoft.com/office/drawing/2014/main" id="{59642773-3A15-476C-9F60-50E7139B36C0}"/>
+                <a16:creationId xmlns:a16="http://schemas.microsoft.com/office/drawing/2014/main" id="{444A5B1C-0538-4A11-9BD9-E2DE1BDE3AC5}"/>
               </a:ext>
             </a:extLst>
           </p:cNvPr>
@@ -3447,7 +3504,7 @@
           <p:cNvPr id="11" name="">
             <a:extLst xmlns:a="http://schemas.openxmlformats.org/drawingml/2006/main">
               <a:ext uri="{FF2B5EF4-FFF2-40B4-BE49-F238E27FC236}">
-                <a16:creationId xmlns:a16="http://schemas.microsoft.com/office/drawing/2014/main" id="{A38D3BBC-8498-4A97-B991-F6D6EB4E849C}"/>
+                <a16:creationId xmlns:a16="http://schemas.microsoft.com/office/drawing/2014/main" id="{12776A74-86A8-4634-BEDB-4F129FCC5E91}"/>
               </a:ext>
             </a:extLst>
           </p:cNvPr>
@@ -3504,7 +3561,7 @@
           <p:cNvPr id="12" name="">
             <a:extLst xmlns:a="http://schemas.openxmlformats.org/drawingml/2006/main">
               <a:ext uri="{FF2B5EF4-FFF2-40B4-BE49-F238E27FC236}">
-                <a16:creationId xmlns:a16="http://schemas.microsoft.com/office/drawing/2014/main" id="{E8063939-EDF7-48DC-B1BF-BDC362948EC0}"/>
+                <a16:creationId xmlns:a16="http://schemas.microsoft.com/office/drawing/2014/main" id="{20041EC0-5D7A-4318-B520-10CA33F0C918}"/>
               </a:ext>
             </a:extLst>
           </p:cNvPr>
@@ -3559,7 +3616,7 @@
     </p:spTree>
     <p:extLst>
       <p:ext uri="{BB962C8B-B14F-4D97-AF65-F5344CB8AC3E}">
-        <p14:creationId xmlns:p14="http://schemas.microsoft.com/office/powerpoint/2010/main" val="1002474642"/>
+        <p14:creationId xmlns:p14="http://schemas.microsoft.com/office/powerpoint/2010/main" val="1053100795"/>
       </p:ext>
     </p:extLst>
   </p:cSld>
@@ -3587,10 +3644,10 @@
       </p:grpSpPr>
       <p:sp>
         <p:nvSpPr>
-          <p:cNvPr id="17" name="">
+          <p:cNvPr id="18" name="">
             <a:extLst xmlns:a="http://schemas.openxmlformats.org/drawingml/2006/main">
               <a:ext uri="{FF2B5EF4-FFF2-40B4-BE49-F238E27FC236}">
-                <a16:creationId xmlns:a16="http://schemas.microsoft.com/office/drawing/2014/main" id="{EF710B35-1698-47A6-9C81-98AADE6CD919}"/>
+                <a16:creationId xmlns:a16="http://schemas.microsoft.com/office/drawing/2014/main" id="{7DB9EF44-BC8A-4D4F-962D-25E97A199BD1}"/>
               </a:ext>
             </a:extLst>
           </p:cNvPr>
@@ -3647,7 +3704,7 @@
           <p:cNvPr id="2" name="">
             <a:extLst xmlns:a="http://schemas.openxmlformats.org/drawingml/2006/main">
               <a:ext uri="{FF2B5EF4-FFF2-40B4-BE49-F238E27FC236}">
-                <a16:creationId xmlns:a16="http://schemas.microsoft.com/office/drawing/2014/main" id="{5EE399FF-2143-48B4-88FE-E4A1870FB302}"/>
+                <a16:creationId xmlns:a16="http://schemas.microsoft.com/office/drawing/2014/main" id="{69B14E4F-1FAC-4E2A-85F9-5DCD2B3EDCA5}"/>
               </a:ext>
             </a:extLst>
           </p:cNvPr>
@@ -3704,7 +3761,7 @@
           <p:cNvPr id="3" name="">
             <a:extLst xmlns:a="http://schemas.openxmlformats.org/drawingml/2006/main">
               <a:ext uri="{FF2B5EF4-FFF2-40B4-BE49-F238E27FC236}">
-                <a16:creationId xmlns:a16="http://schemas.microsoft.com/office/drawing/2014/main" id="{A5254834-6A54-485E-B8FF-8080CB28DDEC}"/>
+                <a16:creationId xmlns:a16="http://schemas.microsoft.com/office/drawing/2014/main" id="{B7AFE5EE-8333-4F43-8784-22E56B42EB7C}"/>
               </a:ext>
             </a:extLst>
           </p:cNvPr>
@@ -3765,7 +3822,7 @@
           <p:cNvPr id="4" name="">
             <a:extLst xmlns:a="http://schemas.openxmlformats.org/drawingml/2006/main">
               <a:ext uri="{FF2B5EF4-FFF2-40B4-BE49-F238E27FC236}">
-                <a16:creationId xmlns:a16="http://schemas.microsoft.com/office/drawing/2014/main" id="{A5C677FA-807E-4109-A5AF-9E1B214E45C2}"/>
+                <a16:creationId xmlns:a16="http://schemas.microsoft.com/office/drawing/2014/main" id="{939599BE-F4C0-4C28-A31D-5A088EC46F42}"/>
               </a:ext>
             </a:extLst>
           </p:cNvPr>
@@ -3826,7 +3883,7 @@
           <p:cNvPr id="5" name="">
             <a:extLst xmlns:a="http://schemas.openxmlformats.org/drawingml/2006/main">
               <a:ext uri="{FF2B5EF4-FFF2-40B4-BE49-F238E27FC236}">
-                <a16:creationId xmlns:a16="http://schemas.microsoft.com/office/drawing/2014/main" id="{ED8D4BB5-C9B0-44C8-A816-88655BC7708B}"/>
+                <a16:creationId xmlns:a16="http://schemas.microsoft.com/office/drawing/2014/main" id="{9A649BE5-1B79-47F2-A6CD-50083D5785B3}"/>
               </a:ext>
             </a:extLst>
           </p:cNvPr>
@@ -3887,7 +3944,7 @@
           <p:cNvPr id="6" name="">
             <a:extLst xmlns:a="http://schemas.openxmlformats.org/drawingml/2006/main">
               <a:ext uri="{FF2B5EF4-FFF2-40B4-BE49-F238E27FC236}">
-                <a16:creationId xmlns:a16="http://schemas.microsoft.com/office/drawing/2014/main" id="{846E74F1-E880-4536-AB57-0B85E91FAE8D}"/>
+                <a16:creationId xmlns:a16="http://schemas.microsoft.com/office/drawing/2014/main" id="{25B621D2-57AE-4A2E-9FD9-95CA2632486A}"/>
               </a:ext>
             </a:extLst>
           </p:cNvPr>
@@ -3945,7 +4002,7 @@
       </p:sp>
       <p:cxnSp>
         <p:nvCxnSpPr>
-          <p:cNvPr id="23" name=""/>
+          <p:cNvPr id="24" name=""/>
           <p:cNvCxnSpPr>
             <a:stCxn xmlns:a="http://schemas.openxmlformats.org/drawingml/2006/main" id="3" idx="3"/>
             <a:endCxn xmlns:a="http://schemas.openxmlformats.org/drawingml/2006/main" id="4" idx="1"/>
@@ -3971,7 +4028,7 @@
       </p:cxnSp>
       <p:cxnSp>
         <p:nvCxnSpPr>
-          <p:cNvPr id="24" name=""/>
+          <p:cNvPr id="25" name=""/>
           <p:cNvCxnSpPr>
             <a:stCxn xmlns:a="http://schemas.openxmlformats.org/drawingml/2006/main" id="4" idx="3"/>
             <a:endCxn xmlns:a="http://schemas.openxmlformats.org/drawingml/2006/main" id="5" idx="1"/>
@@ -3997,7 +4054,7 @@
       </p:cxnSp>
       <p:cxnSp>
         <p:nvCxnSpPr>
-          <p:cNvPr id="25" name=""/>
+          <p:cNvPr id="26" name=""/>
           <p:cNvCxnSpPr>
             <a:stCxn xmlns:a="http://schemas.openxmlformats.org/drawingml/2006/main" id="5" idx="3"/>
             <a:endCxn xmlns:a="http://schemas.openxmlformats.org/drawingml/2006/main" id="6" idx="1"/>
@@ -4026,7 +4083,7 @@
           <p:cNvPr id="10" name="">
             <a:extLst xmlns:a="http://schemas.openxmlformats.org/drawingml/2006/main">
               <a:ext uri="{FF2B5EF4-FFF2-40B4-BE49-F238E27FC236}">
-                <a16:creationId xmlns:a16="http://schemas.microsoft.com/office/drawing/2014/main" id="{0251C0C1-AAAB-4200-85B9-81ED25ECEA63}"/>
+                <a16:creationId xmlns:a16="http://schemas.microsoft.com/office/drawing/2014/main" id="{C3A0A629-3BAB-4829-8C63-8B4C150FE662}"/>
               </a:ext>
             </a:extLst>
           </p:cNvPr>
@@ -4073,7 +4130,7 @@
                 <a:ea typeface="Helvetica Neue"/>
                 <a:cs typeface="Helvetica Neue"/>
               </a:rPr>
-              <a:t>Private uploads</a:t>
+              <a:t>Firebase sign-in</a:t>
             </a:r>
           </a:p>
           <a:p xmlns:a="http://schemas.openxmlformats.org/drawingml/2006/main">
@@ -4096,7 +4153,7 @@
                 <a:ea typeface="Helvetica Neue"/>
                 <a:cs typeface="Helvetica Neue"/>
               </a:rPr>
-              <a:t>Originals in R2</a:t>
+              <a:t>Private GCS originals</a:t>
             </a:r>
           </a:p>
           <a:p xmlns:a="http://schemas.openxmlformats.org/drawingml/2006/main">
@@ -4129,7 +4186,7 @@
           <p:cNvPr id="11" name="">
             <a:extLst xmlns:a="http://schemas.openxmlformats.org/drawingml/2006/main">
               <a:ext uri="{FF2B5EF4-FFF2-40B4-BE49-F238E27FC236}">
-                <a16:creationId xmlns:a16="http://schemas.microsoft.com/office/drawing/2014/main" id="{B8340079-682D-4250-B6AA-E443A5F1C16F}"/>
+                <a16:creationId xmlns:a16="http://schemas.microsoft.com/office/drawing/2014/main" id="{969B75FD-742A-48F4-B445-EBEA23DD3ECB}"/>
               </a:ext>
             </a:extLst>
           </p:cNvPr>
@@ -4232,7 +4289,7 @@
           <p:cNvPr id="12" name="">
             <a:extLst xmlns:a="http://schemas.openxmlformats.org/drawingml/2006/main">
               <a:ext uri="{FF2B5EF4-FFF2-40B4-BE49-F238E27FC236}">
-                <a16:creationId xmlns:a16="http://schemas.microsoft.com/office/drawing/2014/main" id="{D2B27AB6-F229-4F92-9EA6-46937B8E50FE}"/>
+                <a16:creationId xmlns:a16="http://schemas.microsoft.com/office/drawing/2014/main" id="{C2F7D9E1-8AB6-4237-86FD-AFB6F31E3579}"/>
               </a:ext>
             </a:extLst>
           </p:cNvPr>
@@ -4335,7 +4392,7 @@
           <p:cNvPr id="13" name="">
             <a:extLst xmlns:a="http://schemas.openxmlformats.org/drawingml/2006/main">
               <a:ext uri="{FF2B5EF4-FFF2-40B4-BE49-F238E27FC236}">
-                <a16:creationId xmlns:a16="http://schemas.microsoft.com/office/drawing/2014/main" id="{3DCE47DD-A963-4B20-AA51-8BACEB4B0483}"/>
+                <a16:creationId xmlns:a16="http://schemas.microsoft.com/office/drawing/2014/main" id="{97BF7EA8-A1C4-4C22-B26D-4B2F3F361A12}"/>
               </a:ext>
             </a:extLst>
           </p:cNvPr>
@@ -4405,7 +4462,7 @@
                 <a:ea typeface="Helvetica Neue"/>
                 <a:cs typeface="Helvetica Neue"/>
               </a:rPr>
-              <a:t>Saved cases in D1</a:t>
+              <a:t>Cases in Firestore</a:t>
             </a:r>
           </a:p>
           <a:p xmlns:a="http://schemas.openxmlformats.org/drawingml/2006/main">
@@ -4438,7 +4495,7 @@
           <p:cNvPr id="14" name="">
             <a:extLst xmlns:a="http://schemas.openxmlformats.org/drawingml/2006/main">
               <a:ext uri="{FF2B5EF4-FFF2-40B4-BE49-F238E27FC236}">
-                <a16:creationId xmlns:a16="http://schemas.microsoft.com/office/drawing/2014/main" id="{A4265C96-6C33-43A0-BE99-7C32D4A1D641}"/>
+                <a16:creationId xmlns:a16="http://schemas.microsoft.com/office/drawing/2014/main" id="{2A77013B-DAD7-4DB2-9E3C-2EBD32A5820C}"/>
               </a:ext>
             </a:extLst>
           </p:cNvPr>
@@ -4449,8 +4506,8 @@
         </p:nvSpPr>
         <p:spPr>
           <a:xfrm xmlns:a="http://schemas.openxmlformats.org/drawingml/2006/main">
-            <a:off x="628650" y="4314825"/>
-            <a:ext cx="10858500" cy="876300"/>
+            <a:off x="628650" y="4105275"/>
+            <a:ext cx="10858500" cy="323850"/>
           </a:xfrm>
           <a:prstGeom xmlns:a="http://schemas.openxmlformats.org/drawingml/2006/main" prst="rect">
             <a:avLst/>
@@ -4467,25 +4524,25 @@
           <a:lstStyle xmlns:a="http://schemas.openxmlformats.org/drawingml/2006/main"/>
           <a:p xmlns:a="http://schemas.openxmlformats.org/drawingml/2006/main">
             <a:pPr>
-              <a:defRPr sz="2175" b="1">
-                <a:solidFill>
-                  <a:srgbClr val="136956"/>
-                </a:solidFill>
-                <a:latin typeface="Helvetica Neue"/>
-                <a:ea typeface="Helvetica Neue"/>
-                <a:cs typeface="Helvetica Neue"/>
-              </a:defRPr>
-            </a:pPr>
-            <a:r>
-              <a:rPr sz="2175" b="1">
-                <a:solidFill>
-                  <a:srgbClr val="136956"/>
-                </a:solidFill>
-                <a:latin typeface="Helvetica Neue"/>
-                <a:ea typeface="Helvetica Neue"/>
-                <a:cs typeface="Helvetica Neue"/>
-              </a:rPr>
-              <a:t>HTML, CSV and JSON exports include evidence and customer drafts. The app never sends those drafts.</a:t>
+              <a:defRPr sz="1725" b="0">
+                <a:solidFill>
+                  <a:srgbClr val="526970"/>
+                </a:solidFill>
+                <a:latin typeface="Helvetica Neue"/>
+                <a:ea typeface="Helvetica Neue"/>
+                <a:cs typeface="Helvetica Neue"/>
+              </a:defRPr>
+            </a:pPr>
+            <a:r>
+              <a:rPr sz="1725" b="0">
+                <a:solidFill>
+                  <a:srgbClr val="526970"/>
+                </a:solidFill>
+                <a:latin typeface="Helvetica Neue"/>
+                <a:ea typeface="Helvetica Neue"/>
+                <a:cs typeface="Helvetica Neue"/>
+              </a:rPr>
+              <a:t>Firebase hosts the app. Cloud Run and Cloud Tasks handle authenticated extraction.</a:t>
             </a:r>
           </a:p>
         </p:txBody>
@@ -4495,7 +4552,7 @@
           <p:cNvPr id="15" name="">
             <a:extLst xmlns:a="http://schemas.openxmlformats.org/drawingml/2006/main">
               <a:ext uri="{FF2B5EF4-FFF2-40B4-BE49-F238E27FC236}">
-                <a16:creationId xmlns:a16="http://schemas.microsoft.com/office/drawing/2014/main" id="{C6E58EA0-4EE8-4D00-9263-D5C579B1273B}"/>
+                <a16:creationId xmlns:a16="http://schemas.microsoft.com/office/drawing/2014/main" id="{B0372479-57C4-42AC-9C03-D26CD9346232}"/>
               </a:ext>
             </a:extLst>
           </p:cNvPr>
@@ -4506,8 +4563,8 @@
         </p:nvSpPr>
         <p:spPr>
           <a:xfrm xmlns:a="http://schemas.openxmlformats.org/drawingml/2006/main">
-            <a:off x="628650" y="5400675"/>
-            <a:ext cx="10858500" cy="495300"/>
+            <a:off x="628650" y="4657725"/>
+            <a:ext cx="10858500" cy="647700"/>
           </a:xfrm>
           <a:prstGeom xmlns:a="http://schemas.openxmlformats.org/drawingml/2006/main" prst="rect">
             <a:avLst/>
@@ -4524,25 +4581,25 @@
           <a:lstStyle xmlns:a="http://schemas.openxmlformats.org/drawingml/2006/main"/>
           <a:p xmlns:a="http://schemas.openxmlformats.org/drawingml/2006/main">
             <a:pPr>
-              <a:defRPr sz="1725" b="1">
-                <a:solidFill>
-                  <a:srgbClr val="9B6409"/>
-                </a:solidFill>
-                <a:latin typeface="Helvetica Neue"/>
-                <a:ea typeface="Helvetica Neue"/>
-                <a:cs typeface="Helvetica Neue"/>
-              </a:defRPr>
-            </a:pPr>
-            <a:r>
-              <a:rPr sz="1725" b="1">
-                <a:solidFill>
-                  <a:srgbClr val="9B6409"/>
-                </a:solidFill>
-                <a:latin typeface="Helvetica Neue"/>
-                <a:ea typeface="Helvetica Neue"/>
-                <a:cs typeface="Helvetica Neue"/>
-              </a:rPr>
-              <a:t>Live Nebius execution awaits a credential. No measured model latency, accuracy or cost yet.</a:t>
+              <a:defRPr sz="2175" b="1">
+                <a:solidFill>
+                  <a:srgbClr val="136956"/>
+                </a:solidFill>
+                <a:latin typeface="Helvetica Neue"/>
+                <a:ea typeface="Helvetica Neue"/>
+                <a:cs typeface="Helvetica Neue"/>
+              </a:defRPr>
+            </a:pPr>
+            <a:r>
+              <a:rPr sz="2175" b="1">
+                <a:solidFill>
+                  <a:srgbClr val="136956"/>
+                </a:solidFill>
+                <a:latin typeface="Helvetica Neue"/>
+                <a:ea typeface="Helvetica Neue"/>
+                <a:cs typeface="Helvetica Neue"/>
+              </a:rPr>
+              <a:t>HTML, CSV and JSON exports include evidence and unsent customer drafts.</a:t>
             </a:r>
           </a:p>
         </p:txBody>
@@ -4552,7 +4609,7 @@
           <p:cNvPr id="16" name="">
             <a:extLst xmlns:a="http://schemas.openxmlformats.org/drawingml/2006/main">
               <a:ext uri="{FF2B5EF4-FFF2-40B4-BE49-F238E27FC236}">
-                <a16:creationId xmlns:a16="http://schemas.microsoft.com/office/drawing/2014/main" id="{622C69E3-3302-4B24-BDED-7D388FBDF736}"/>
+                <a16:creationId xmlns:a16="http://schemas.microsoft.com/office/drawing/2014/main" id="{72010F46-4C0A-4566-9A85-39EB584E16B0}"/>
               </a:ext>
             </a:extLst>
           </p:cNvPr>
@@ -4563,8 +4620,8 @@
         </p:nvSpPr>
         <p:spPr>
           <a:xfrm xmlns:a="http://schemas.openxmlformats.org/drawingml/2006/main">
-            <a:off x="628650" y="5991225"/>
-            <a:ext cx="10858500" cy="238125"/>
+            <a:off x="628650" y="5400675"/>
+            <a:ext cx="10858500" cy="495300"/>
           </a:xfrm>
           <a:prstGeom xmlns:a="http://schemas.openxmlformats.org/drawingml/2006/main" prst="rect">
             <a:avLst/>
@@ -4581,6 +4638,63 @@
           <a:lstStyle xmlns:a="http://schemas.openxmlformats.org/drawingml/2006/main"/>
           <a:p xmlns:a="http://schemas.openxmlformats.org/drawingml/2006/main">
             <a:pPr>
+              <a:defRPr sz="1725" b="1">
+                <a:solidFill>
+                  <a:srgbClr val="9B6409"/>
+                </a:solidFill>
+                <a:latin typeface="Helvetica Neue"/>
+                <a:ea typeface="Helvetica Neue"/>
+                <a:cs typeface="Helvetica Neue"/>
+              </a:defRPr>
+            </a:pPr>
+            <a:r>
+              <a:rPr sz="1725" b="1">
+                <a:solidFill>
+                  <a:srgbClr val="9B6409"/>
+                </a:solidFill>
+                <a:latin typeface="Helvetica Neue"/>
+                <a:ea typeface="Helvetica Neue"/>
+                <a:cs typeface="Helvetica Neue"/>
+              </a:rPr>
+              <a:t>Live Nebius execution awaits a credential. No measured model latency, accuracy or cost yet.</a:t>
+            </a:r>
+          </a:p>
+        </p:txBody>
+      </p:sp>
+      <p:sp>
+        <p:nvSpPr>
+          <p:cNvPr id="17" name="">
+            <a:extLst xmlns:a="http://schemas.openxmlformats.org/drawingml/2006/main">
+              <a:ext uri="{FF2B5EF4-FFF2-40B4-BE49-F238E27FC236}">
+                <a16:creationId xmlns:a16="http://schemas.microsoft.com/office/drawing/2014/main" id="{FEBCD277-BD09-4A0D-B4FC-858A6D4425E5}"/>
+              </a:ext>
+            </a:extLst>
+          </p:cNvPr>
+          <p:cNvSpPr>
+            <a:spLocks xmlns:a="http://schemas.openxmlformats.org/drawingml/2006/main" noGrp="1"/>
+          </p:cNvSpPr>
+          <p:nvPr/>
+        </p:nvSpPr>
+        <p:spPr>
+          <a:xfrm xmlns:a="http://schemas.openxmlformats.org/drawingml/2006/main">
+            <a:off x="628650" y="5991225"/>
+            <a:ext cx="10858500" cy="238125"/>
+          </a:xfrm>
+          <a:prstGeom xmlns:a="http://schemas.openxmlformats.org/drawingml/2006/main" prst="rect">
+            <a:avLst/>
+          </a:prstGeom>
+          <a:noFill xmlns:a="http://schemas.openxmlformats.org/drawingml/2006/main"/>
+          <a:ln xmlns:a="http://schemas.openxmlformats.org/drawingml/2006/main" w="0">
+            <a:noFill/>
+          </a:ln>
+        </p:spPr>
+        <p:txBody>
+          <a:bodyPr xmlns:a="http://schemas.openxmlformats.org/drawingml/2006/main">
+            <a:noAutofit/>
+          </a:bodyPr>
+          <a:lstStyle xmlns:a="http://schemas.openxmlformats.org/drawingml/2006/main"/>
+          <a:p xmlns:a="http://schemas.openxmlformats.org/drawingml/2006/main">
+            <a:pPr>
               <a:defRPr sz="1275" b="0">
                 <a:solidFill>
                   <a:srgbClr val="526970"/>
@@ -4607,7 +4721,7 @@
     </p:spTree>
     <p:extLst>
       <p:ext uri="{BB962C8B-B14F-4D97-AF65-F5344CB8AC3E}">
-        <p14:creationId xmlns:p14="http://schemas.microsoft.com/office/powerpoint/2010/main" val="319025653"/>
+        <p14:creationId xmlns:p14="http://schemas.microsoft.com/office/powerpoint/2010/main" val="609472238"/>
       </p:ext>
     </p:extLst>
   </p:cSld>
@@ -4638,7 +4752,7 @@
           <p:cNvPr id="10" name="">
             <a:extLst xmlns:a="http://schemas.openxmlformats.org/drawingml/2006/main">
               <a:ext uri="{FF2B5EF4-FFF2-40B4-BE49-F238E27FC236}">
-                <a16:creationId xmlns:a16="http://schemas.microsoft.com/office/drawing/2014/main" id="{673CFBDA-E194-4360-B224-571E6A164399}"/>
+                <a16:creationId xmlns:a16="http://schemas.microsoft.com/office/drawing/2014/main" id="{FDC4AAC6-37E0-4C3C-977E-3D4A4A33E9A0}"/>
               </a:ext>
             </a:extLst>
           </p:cNvPr>
@@ -4695,7 +4809,7 @@
           <p:cNvPr id="2" name="">
             <a:extLst xmlns:a="http://schemas.openxmlformats.org/drawingml/2006/main">
               <a:ext uri="{FF2B5EF4-FFF2-40B4-BE49-F238E27FC236}">
-                <a16:creationId xmlns:a16="http://schemas.microsoft.com/office/drawing/2014/main" id="{E6FF9C96-7335-437A-94BC-9A8F0DD69EE2}"/>
+                <a16:creationId xmlns:a16="http://schemas.microsoft.com/office/drawing/2014/main" id="{D50B1D4A-D014-4A2A-9549-1E4064140380}"/>
               </a:ext>
             </a:extLst>
           </p:cNvPr>
@@ -4752,7 +4866,7 @@
           <p:cNvPr id="3" name="">
             <a:extLst xmlns:a="http://schemas.openxmlformats.org/drawingml/2006/main">
               <a:ext uri="{FF2B5EF4-FFF2-40B4-BE49-F238E27FC236}">
-                <a16:creationId xmlns:a16="http://schemas.microsoft.com/office/drawing/2014/main" id="{92E7AE74-3A16-48C6-9028-4836F5181A11}"/>
+                <a16:creationId xmlns:a16="http://schemas.microsoft.com/office/drawing/2014/main" id="{6681EC46-A27E-4239-A01C-A2F8EDDDA6B4}"/>
               </a:ext>
             </a:extLst>
           </p:cNvPr>
@@ -4832,7 +4946,7 @@
           <p:cNvPr id="4" name="">
             <a:extLst xmlns:a="http://schemas.openxmlformats.org/drawingml/2006/main">
               <a:ext uri="{FF2B5EF4-FFF2-40B4-BE49-F238E27FC236}">
-                <a16:creationId xmlns:a16="http://schemas.microsoft.com/office/drawing/2014/main" id="{C0E8CBB0-0AE1-475B-BAD0-CD389F822F59}"/>
+                <a16:creationId xmlns:a16="http://schemas.microsoft.com/office/drawing/2014/main" id="{0D3B1B67-2607-42BC-95EC-7B93A7CEEF03}"/>
               </a:ext>
             </a:extLst>
           </p:cNvPr>
@@ -4935,7 +5049,7 @@
           <p:cNvPr id="5" name="">
             <a:extLst xmlns:a="http://schemas.openxmlformats.org/drawingml/2006/main">
               <a:ext uri="{FF2B5EF4-FFF2-40B4-BE49-F238E27FC236}">
-                <a16:creationId xmlns:a16="http://schemas.microsoft.com/office/drawing/2014/main" id="{EA8C43FB-C995-4CC7-B02F-B98FCA15B498}"/>
+                <a16:creationId xmlns:a16="http://schemas.microsoft.com/office/drawing/2014/main" id="{76300A18-AC55-40EF-96C7-1AB978C60293}"/>
               </a:ext>
             </a:extLst>
           </p:cNvPr>
@@ -4992,7 +5106,7 @@
           <p:cNvPr id="6" name="">
             <a:extLst xmlns:a="http://schemas.openxmlformats.org/drawingml/2006/main">
               <a:ext uri="{FF2B5EF4-FFF2-40B4-BE49-F238E27FC236}">
-                <a16:creationId xmlns:a16="http://schemas.microsoft.com/office/drawing/2014/main" id="{19A47B79-0D35-4BAC-AB1B-C96165D6CD4A}"/>
+                <a16:creationId xmlns:a16="http://schemas.microsoft.com/office/drawing/2014/main" id="{9FAE2DDD-9B7E-4AFA-A94E-7CD706A633E0}"/>
               </a:ext>
             </a:extLst>
           </p:cNvPr>
@@ -5049,7 +5163,7 @@
           <p:cNvPr id="7" name="">
             <a:extLst xmlns:a="http://schemas.openxmlformats.org/drawingml/2006/main">
               <a:ext uri="{FF2B5EF4-FFF2-40B4-BE49-F238E27FC236}">
-                <a16:creationId xmlns:a16="http://schemas.microsoft.com/office/drawing/2014/main" id="{FC9B3EB1-BA10-4507-9FC9-ACABEA527204}"/>
+                <a16:creationId xmlns:a16="http://schemas.microsoft.com/office/drawing/2014/main" id="{31E815E4-4594-498B-B649-97A97FD00F81}"/>
               </a:ext>
             </a:extLst>
           </p:cNvPr>
@@ -5129,7 +5243,7 @@
           <p:cNvPr id="8" name="">
             <a:extLst xmlns:a="http://schemas.openxmlformats.org/drawingml/2006/main">
               <a:ext uri="{FF2B5EF4-FFF2-40B4-BE49-F238E27FC236}">
-                <a16:creationId xmlns:a16="http://schemas.microsoft.com/office/drawing/2014/main" id="{38392044-D42E-4CD6-963A-02684473C605}"/>
+                <a16:creationId xmlns:a16="http://schemas.microsoft.com/office/drawing/2014/main" id="{31BD49C8-9968-4EFC-AD40-E695D86FDBDC}"/>
               </a:ext>
             </a:extLst>
           </p:cNvPr>
@@ -5186,7 +5300,7 @@
           <p:cNvPr id="9" name="">
             <a:extLst xmlns:a="http://schemas.openxmlformats.org/drawingml/2006/main">
               <a:ext uri="{FF2B5EF4-FFF2-40B4-BE49-F238E27FC236}">
-                <a16:creationId xmlns:a16="http://schemas.microsoft.com/office/drawing/2014/main" id="{2E8B0282-37A0-4D88-AD26-0907B044C22B}"/>
+                <a16:creationId xmlns:a16="http://schemas.microsoft.com/office/drawing/2014/main" id="{686A8D72-171F-4EF6-9E5D-9F0DB942737B}"/>
               </a:ext>
             </a:extLst>
           </p:cNvPr>
@@ -5241,7 +5355,7 @@
     </p:spTree>
     <p:extLst>
       <p:ext uri="{BB962C8B-B14F-4D97-AF65-F5344CB8AC3E}">
-        <p14:creationId xmlns:p14="http://schemas.microsoft.com/office/powerpoint/2010/main" val="1466511358"/>
+        <p14:creationId xmlns:p14="http://schemas.microsoft.com/office/powerpoint/2010/main" val="1070336842"/>
       </p:ext>
     </p:extLst>
   </p:cSld>
@@ -5269,10 +5383,581 @@
       </p:grpSpPr>
       <p:sp>
         <p:nvSpPr>
+          <p:cNvPr id="10" name="">
+            <a:extLst xmlns:a="http://schemas.openxmlformats.org/drawingml/2006/main">
+              <a:ext uri="{FF2B5EF4-FFF2-40B4-BE49-F238E27FC236}">
+                <a16:creationId xmlns:a16="http://schemas.microsoft.com/office/drawing/2014/main" id="{3B9539AE-5395-4CEF-B2A3-3D0BC63DE54F}"/>
+              </a:ext>
+            </a:extLst>
+          </p:cNvPr>
+          <p:cNvSpPr>
+            <a:spLocks xmlns:a="http://schemas.openxmlformats.org/drawingml/2006/main" noGrp="1"/>
+          </p:cNvSpPr>
+          <p:nvPr/>
+        </p:nvSpPr>
+        <p:spPr>
+          <a:xfrm xmlns:a="http://schemas.openxmlformats.org/drawingml/2006/main">
+            <a:off x="609600" y="476250"/>
+            <a:ext cx="10972800" cy="762000"/>
+          </a:xfrm>
+          <a:prstGeom xmlns:a="http://schemas.openxmlformats.org/drawingml/2006/main" prst="rect">
+            <a:avLst/>
+          </a:prstGeom>
+          <a:noFill xmlns:a="http://schemas.openxmlformats.org/drawingml/2006/main"/>
+          <a:ln xmlns:a="http://schemas.openxmlformats.org/drawingml/2006/main" w="0">
+            <a:noFill/>
+          </a:ln>
+        </p:spPr>
+        <p:txBody>
+          <a:bodyPr xmlns:a="http://schemas.openxmlformats.org/drawingml/2006/main">
+            <a:noAutofit/>
+          </a:bodyPr>
+          <a:lstStyle xmlns:a="http://schemas.openxmlformats.org/drawingml/2006/main"/>
+          <a:p xmlns:a="http://schemas.openxmlformats.org/drawingml/2006/main">
+            <a:pPr>
+              <a:defRPr sz="3450" b="1">
+                <a:solidFill>
+                  <a:srgbClr val="FFFFFF"/>
+                </a:solidFill>
+                <a:latin typeface="Helvetica Neue"/>
+                <a:ea typeface="Helvetica Neue"/>
+                <a:cs typeface="Helvetica Neue"/>
+              </a:defRPr>
+            </a:pPr>
+            <a:r>
+              <a:rPr sz="3450" b="1">
+                <a:solidFill>
+                  <a:srgbClr val="FFFFFF"/>
+                </a:solidFill>
+                <a:latin typeface="Helvetica Neue"/>
+                <a:ea typeface="Helvetica Neue"/>
+                <a:cs typeface="Helvetica Neue"/>
+              </a:rPr>
+              <a:t>Application evidence and next validation</a:t>
+            </a:r>
+          </a:p>
+        </p:txBody>
+      </p:sp>
+      <p:sp>
+        <p:nvSpPr>
+          <p:cNvPr id="2" name="">
+            <a:extLst xmlns:a="http://schemas.openxmlformats.org/drawingml/2006/main">
+              <a:ext uri="{FF2B5EF4-FFF2-40B4-BE49-F238E27FC236}">
+                <a16:creationId xmlns:a16="http://schemas.microsoft.com/office/drawing/2014/main" id="{FF25F875-AD37-4B5A-9940-E949B3D2B77F}"/>
+              </a:ext>
+            </a:extLst>
+          </p:cNvPr>
+          <p:cNvSpPr>
+            <a:spLocks xmlns:a="http://schemas.openxmlformats.org/drawingml/2006/main" noGrp="1"/>
+          </p:cNvSpPr>
+          <p:nvPr/>
+        </p:nvSpPr>
+        <p:spPr>
+          <a:xfrm xmlns:a="http://schemas.openxmlformats.org/drawingml/2006/main">
+            <a:off x="609600" y="6372225"/>
+            <a:ext cx="6191250" cy="209550"/>
+          </a:xfrm>
+          <a:prstGeom xmlns:a="http://schemas.openxmlformats.org/drawingml/2006/main" prst="rect">
+            <a:avLst/>
+          </a:prstGeom>
+          <a:noFill xmlns:a="http://schemas.openxmlformats.org/drawingml/2006/main"/>
+          <a:ln xmlns:a="http://schemas.openxmlformats.org/drawingml/2006/main" w="0">
+            <a:noFill/>
+          </a:ln>
+        </p:spPr>
+        <p:txBody>
+          <a:bodyPr xmlns:a="http://schemas.openxmlformats.org/drawingml/2006/main">
+            <a:noAutofit/>
+          </a:bodyPr>
+          <a:lstStyle xmlns:a="http://schemas.openxmlformats.org/drawingml/2006/main"/>
+          <a:p xmlns:a="http://schemas.openxmlformats.org/drawingml/2006/main">
+            <a:pPr>
+              <a:defRPr sz="1200" b="0">
+                <a:solidFill>
+                  <a:srgbClr val="A6E1CB"/>
+                </a:solidFill>
+                <a:latin typeface="Helvetica Neue"/>
+                <a:ea typeface="Helvetica Neue"/>
+                <a:cs typeface="Helvetica Neue"/>
+              </a:defRPr>
+            </a:pPr>
+            <a:r>
+              <a:rPr sz="1200" b="0">
+                <a:solidFill>
+                  <a:srgbClr val="A6E1CB"/>
+                </a:solidFill>
+                <a:latin typeface="Helvetica Neue"/>
+                <a:ea typeface="Helvetica Neue"/>
+                <a:cs typeface="Helvetica Neue"/>
+              </a:rPr>
+              <a:t>RecallRoom   /   6</a:t>
+            </a:r>
+          </a:p>
+        </p:txBody>
+      </p:sp>
+      <p:sp>
+        <p:nvSpPr>
+          <p:cNvPr id="3" name="">
+            <a:extLst xmlns:a="http://schemas.openxmlformats.org/drawingml/2006/main">
+              <a:ext uri="{FF2B5EF4-FFF2-40B4-BE49-F238E27FC236}">
+                <a16:creationId xmlns:a16="http://schemas.microsoft.com/office/drawing/2014/main" id="{645B738D-5331-46DB-BBFC-AFC7A9F52E35}"/>
+              </a:ext>
+            </a:extLst>
+          </p:cNvPr>
+          <p:cNvSpPr>
+            <a:spLocks xmlns:a="http://schemas.openxmlformats.org/drawingml/2006/main" noGrp="1"/>
+          </p:cNvSpPr>
+          <p:nvPr/>
+        </p:nvSpPr>
+        <p:spPr>
+          <a:xfrm xmlns:a="http://schemas.openxmlformats.org/drawingml/2006/main">
+            <a:off x="619125" y="1581150"/>
+            <a:ext cx="5334000" cy="476250"/>
+          </a:xfrm>
+          <a:prstGeom xmlns:a="http://schemas.openxmlformats.org/drawingml/2006/main" prst="rect">
+            <a:avLst/>
+          </a:prstGeom>
+          <a:noFill xmlns:a="http://schemas.openxmlformats.org/drawingml/2006/main"/>
+          <a:ln xmlns:a="http://schemas.openxmlformats.org/drawingml/2006/main" w="0">
+            <a:noFill/>
+          </a:ln>
+        </p:spPr>
+        <p:txBody>
+          <a:bodyPr xmlns:a="http://schemas.openxmlformats.org/drawingml/2006/main">
+            <a:noAutofit/>
+          </a:bodyPr>
+          <a:lstStyle xmlns:a="http://schemas.openxmlformats.org/drawingml/2006/main"/>
+          <a:p xmlns:a="http://schemas.openxmlformats.org/drawingml/2006/main">
+            <a:pPr>
+              <a:defRPr sz="2325" b="1">
+                <a:solidFill>
+                  <a:srgbClr val="A6E1CB"/>
+                </a:solidFill>
+                <a:latin typeface="Helvetica Neue"/>
+                <a:ea typeface="Helvetica Neue"/>
+                <a:cs typeface="Helvetica Neue"/>
+              </a:defRPr>
+            </a:pPr>
+            <a:r>
+              <a:rPr sz="2325" b="1">
+                <a:solidFill>
+                  <a:srgbClr val="A6E1CB"/>
+                </a:solidFill>
+                <a:latin typeface="Helvetica Neue"/>
+                <a:ea typeface="Helvetica Neue"/>
+                <a:cs typeface="Helvetica Neue"/>
+              </a:rPr>
+              <a:t>Verified application checks</a:t>
+            </a:r>
+          </a:p>
+        </p:txBody>
+      </p:sp>
+      <p:sp>
+        <p:nvSpPr>
+          <p:cNvPr id="4" name="">
+            <a:extLst xmlns:a="http://schemas.openxmlformats.org/drawingml/2006/main">
+              <a:ext uri="{FF2B5EF4-FFF2-40B4-BE49-F238E27FC236}">
+                <a16:creationId xmlns:a16="http://schemas.microsoft.com/office/drawing/2014/main" id="{CFD05328-AD9E-4CA3-ACF4-5BDB6F67EA18}"/>
+              </a:ext>
+            </a:extLst>
+          </p:cNvPr>
+          <p:cNvSpPr>
+            <a:spLocks xmlns:a="http://schemas.openxmlformats.org/drawingml/2006/main" noGrp="1"/>
+          </p:cNvSpPr>
+          <p:nvPr/>
+        </p:nvSpPr>
+        <p:spPr>
+          <a:xfrm xmlns:a="http://schemas.openxmlformats.org/drawingml/2006/main">
+            <a:off x="638175" y="2343150"/>
+            <a:ext cx="4810125" cy="2038350"/>
+          </a:xfrm>
+          <a:prstGeom xmlns:a="http://schemas.openxmlformats.org/drawingml/2006/main" prst="rect">
+            <a:avLst/>
+          </a:prstGeom>
+          <a:noFill xmlns:a="http://schemas.openxmlformats.org/drawingml/2006/main"/>
+          <a:ln xmlns:a="http://schemas.openxmlformats.org/drawingml/2006/main" w="0">
+            <a:noFill/>
+          </a:ln>
+        </p:spPr>
+        <p:txBody>
+          <a:bodyPr xmlns:a="http://schemas.openxmlformats.org/drawingml/2006/main">
+            <a:noAutofit/>
+          </a:bodyPr>
+          <a:lstStyle xmlns:a="http://schemas.openxmlformats.org/drawingml/2006/main"/>
+          <a:p xmlns:a="http://schemas.openxmlformats.org/drawingml/2006/main">
+            <a:pPr>
+              <a:defRPr sz="2325" b="0">
+                <a:solidFill>
+                  <a:srgbClr val="FFFFFF"/>
+                </a:solidFill>
+                <a:latin typeface="Helvetica Neue"/>
+                <a:ea typeface="Helvetica Neue"/>
+                <a:cs typeface="Helvetica Neue"/>
+              </a:defRPr>
+            </a:pPr>
+            <a:r>
+              <a:rPr sz="2325" b="0">
+                <a:solidFill>
+                  <a:srgbClr val="FFFFFF"/>
+                </a:solidFill>
+                <a:latin typeface="Helvetica Neue"/>
+                <a:ea typeface="Helvetica Neue"/>
+                <a:cs typeface="Helvetica Neue"/>
+              </a:rPr>
+              <a:t>37 automated tests</a:t>
+            </a:r>
+          </a:p>
+          <a:p xmlns:a="http://schemas.openxmlformats.org/drawingml/2006/main">
+            <a:pPr>
+              <a:defRPr sz="2325" b="0">
+                <a:solidFill>
+                  <a:srgbClr val="FFFFFF"/>
+                </a:solidFill>
+                <a:latin typeface="Helvetica Neue"/>
+                <a:ea typeface="Helvetica Neue"/>
+                <a:cs typeface="Helvetica Neue"/>
+              </a:defRPr>
+            </a:pPr>
+            <a:r>
+              <a:rPr sz="2325" b="0">
+                <a:solidFill>
+                  <a:srgbClr val="FFFFFF"/>
+                </a:solidFill>
+                <a:latin typeface="Helvetica Neue"/>
+                <a:ea typeface="Helvetica Neue"/>
+                <a:cs typeface="Helvetica Neue"/>
+              </a:rPr>
+              <a:t>58 hosted API checks</a:t>
+            </a:r>
+          </a:p>
+          <a:p xmlns:a="http://schemas.openxmlformats.org/drawingml/2006/main">
+            <a:pPr>
+              <a:defRPr sz="2325" b="0">
+                <a:solidFill>
+                  <a:srgbClr val="FFFFFF"/>
+                </a:solidFill>
+                <a:latin typeface="Helvetica Neue"/>
+                <a:ea typeface="Helvetica Neue"/>
+                <a:cs typeface="Helvetica Neue"/>
+              </a:defRPr>
+            </a:pPr>
+            <a:r>
+              <a:rPr sz="2325" b="0">
+                <a:solidFill>
+                  <a:srgbClr val="FFFFFF"/>
+                </a:solidFill>
+                <a:latin typeface="Helvetica Neue"/>
+                <a:ea typeface="Helvetica Neue"/>
+                <a:cs typeface="Helvetica Neue"/>
+              </a:rPr>
+              <a:t>10 operator checks</a:t>
+            </a:r>
+          </a:p>
+        </p:txBody>
+      </p:sp>
+      <p:sp>
+        <p:nvSpPr>
+          <p:cNvPr id="5" name="">
+            <a:extLst xmlns:a="http://schemas.openxmlformats.org/drawingml/2006/main">
+              <a:ext uri="{FF2B5EF4-FFF2-40B4-BE49-F238E27FC236}">
+                <a16:creationId xmlns:a16="http://schemas.microsoft.com/office/drawing/2014/main" id="{6FC2BD4B-4558-4C1E-A6A6-D670BCA69CB9}"/>
+              </a:ext>
+            </a:extLst>
+          </p:cNvPr>
+          <p:cNvSpPr>
+            <a:spLocks xmlns:a="http://schemas.openxmlformats.org/drawingml/2006/main" noGrp="1"/>
+          </p:cNvSpPr>
+          <p:nvPr/>
+        </p:nvSpPr>
+        <p:spPr>
+          <a:xfrm xmlns:a="http://schemas.openxmlformats.org/drawingml/2006/main">
+            <a:off x="6581775" y="1581150"/>
+            <a:ext cx="4991100" cy="476250"/>
+          </a:xfrm>
+          <a:prstGeom xmlns:a="http://schemas.openxmlformats.org/drawingml/2006/main" prst="rect">
+            <a:avLst/>
+          </a:prstGeom>
+          <a:noFill xmlns:a="http://schemas.openxmlformats.org/drawingml/2006/main"/>
+          <a:ln xmlns:a="http://schemas.openxmlformats.org/drawingml/2006/main" w="0">
+            <a:noFill/>
+          </a:ln>
+        </p:spPr>
+        <p:txBody>
+          <a:bodyPr xmlns:a="http://schemas.openxmlformats.org/drawingml/2006/main">
+            <a:noAutofit/>
+          </a:bodyPr>
+          <a:lstStyle xmlns:a="http://schemas.openxmlformats.org/drawingml/2006/main"/>
+          <a:p xmlns:a="http://schemas.openxmlformats.org/drawingml/2006/main">
+            <a:pPr>
+              <a:defRPr sz="2325" b="1">
+                <a:solidFill>
+                  <a:srgbClr val="A6E1CB"/>
+                </a:solidFill>
+                <a:latin typeface="Helvetica Neue"/>
+                <a:ea typeface="Helvetica Neue"/>
+                <a:cs typeface="Helvetica Neue"/>
+              </a:defRPr>
+            </a:pPr>
+            <a:r>
+              <a:rPr sz="2325" b="1">
+                <a:solidFill>
+                  <a:srgbClr val="A6E1CB"/>
+                </a:solidFill>
+                <a:latin typeface="Helvetica Neue"/>
+                <a:ea typeface="Helvetica Neue"/>
+                <a:cs typeface="Helvetica Neue"/>
+              </a:rPr>
+              <a:t>Next evidence</a:t>
+            </a:r>
+          </a:p>
+        </p:txBody>
+      </p:sp>
+      <p:sp>
+        <p:nvSpPr>
+          <p:cNvPr id="6" name="">
+            <a:extLst xmlns:a="http://schemas.openxmlformats.org/drawingml/2006/main">
+              <a:ext uri="{FF2B5EF4-FFF2-40B4-BE49-F238E27FC236}">
+                <a16:creationId xmlns:a16="http://schemas.microsoft.com/office/drawing/2014/main" id="{0215B353-076A-468C-A226-724BDE750F3B}"/>
+              </a:ext>
+            </a:extLst>
+          </p:cNvPr>
+          <p:cNvSpPr>
+            <a:spLocks xmlns:a="http://schemas.openxmlformats.org/drawingml/2006/main" noGrp="1"/>
+          </p:cNvSpPr>
+          <p:nvPr/>
+        </p:nvSpPr>
+        <p:spPr>
+          <a:xfrm xmlns:a="http://schemas.openxmlformats.org/drawingml/2006/main">
+            <a:off x="6600825" y="2343150"/>
+            <a:ext cx="4972050" cy="2038350"/>
+          </a:xfrm>
+          <a:prstGeom xmlns:a="http://schemas.openxmlformats.org/drawingml/2006/main" prst="rect">
+            <a:avLst/>
+          </a:prstGeom>
+          <a:noFill xmlns:a="http://schemas.openxmlformats.org/drawingml/2006/main"/>
+          <a:ln xmlns:a="http://schemas.openxmlformats.org/drawingml/2006/main" w="0">
+            <a:noFill/>
+          </a:ln>
+        </p:spPr>
+        <p:txBody>
+          <a:bodyPr xmlns:a="http://schemas.openxmlformats.org/drawingml/2006/main">
+            <a:noAutofit/>
+          </a:bodyPr>
+          <a:lstStyle xmlns:a="http://schemas.openxmlformats.org/drawingml/2006/main"/>
+          <a:p xmlns:a="http://schemas.openxmlformats.org/drawingml/2006/main">
+            <a:pPr>
+              <a:defRPr sz="2325" b="0">
+                <a:solidFill>
+                  <a:srgbClr val="FFFFFF"/>
+                </a:solidFill>
+                <a:latin typeface="Helvetica Neue"/>
+                <a:ea typeface="Helvetica Neue"/>
+                <a:cs typeface="Helvetica Neue"/>
+              </a:defRPr>
+            </a:pPr>
+            <a:r>
+              <a:rPr sz="2325" b="0">
+                <a:solidFill>
+                  <a:srgbClr val="FFFFFF"/>
+                </a:solidFill>
+                <a:latin typeface="Helvetica Neue"/>
+                <a:ea typeface="Helvetica Neue"/>
+                <a:cs typeface="Helvetica Neue"/>
+              </a:rPr>
+              <a:t>Verify live Nemotron on Nebius</a:t>
+            </a:r>
+          </a:p>
+          <a:p xmlns:a="http://schemas.openxmlformats.org/drawingml/2006/main">
+            <a:pPr>
+              <a:defRPr sz="2325" b="0">
+                <a:solidFill>
+                  <a:srgbClr val="FFFFFF"/>
+                </a:solidFill>
+                <a:latin typeface="Helvetica Neue"/>
+                <a:ea typeface="Helvetica Neue"/>
+                <a:cs typeface="Helvetica Neue"/>
+              </a:defRPr>
+            </a:pPr>
+            <a:r>
+              <a:rPr sz="2325" b="0">
+                <a:solidFill>
+                  <a:srgbClr val="FFFFFF"/>
+                </a:solidFill>
+                <a:latin typeface="Helvetica Neue"/>
+                <a:ea typeface="Helvetica Neue"/>
+                <a:cs typeface="Helvetica Neue"/>
+              </a:rPr>
+              <a:t>Measure against human answer keys</a:t>
+            </a:r>
+          </a:p>
+          <a:p xmlns:a="http://schemas.openxmlformats.org/drawingml/2006/main">
+            <a:pPr>
+              <a:defRPr sz="2325" b="0">
+                <a:solidFill>
+                  <a:srgbClr val="FFFFFF"/>
+                </a:solidFill>
+                <a:latin typeface="Helvetica Neue"/>
+                <a:ea typeface="Helvetica Neue"/>
+                <a:cs typeface="Helvetica Neue"/>
+              </a:defRPr>
+            </a:pPr>
+            <a:r>
+              <a:rPr sz="2325" b="0">
+                <a:solidFill>
+                  <a:srgbClr val="FFFFFF"/>
+                </a:solidFill>
+                <a:latin typeface="Helvetica Neue"/>
+                <a:ea typeface="Helvetica Neue"/>
+                <a:cs typeface="Helvetica Neue"/>
+              </a:rPr>
+              <a:t>Observe quality managers using it</a:t>
+            </a:r>
+          </a:p>
+          <a:p xmlns:a="http://schemas.openxmlformats.org/drawingml/2006/main">
+            <a:pPr>
+              <a:defRPr sz="2325" b="0">
+                <a:solidFill>
+                  <a:srgbClr val="FFFFFF"/>
+                </a:solidFill>
+                <a:latin typeface="Helvetica Neue"/>
+                <a:ea typeface="Helvetica Neue"/>
+                <a:cs typeface="Helvetica Neue"/>
+              </a:defRPr>
+            </a:pPr>
+            <a:r>
+              <a:rPr sz="2325" b="0">
+                <a:solidFill>
+                  <a:srgbClr val="FFFFFF"/>
+                </a:solidFill>
+                <a:latin typeface="Helvetica Neue"/>
+                <a:ea typeface="Helvetica Neue"/>
+                <a:cs typeface="Helvetica Neue"/>
+              </a:rPr>
+              <a:t>Test a paid pilot and repeat usage</a:t>
+            </a:r>
+          </a:p>
+        </p:txBody>
+      </p:sp>
+      <p:sp>
+        <p:nvSpPr>
+          <p:cNvPr id="7" name="">
+            <a:extLst xmlns:a="http://schemas.openxmlformats.org/drawingml/2006/main">
+              <a:ext uri="{FF2B5EF4-FFF2-40B4-BE49-F238E27FC236}">
+                <a16:creationId xmlns:a16="http://schemas.microsoft.com/office/drawing/2014/main" id="{D0605519-B711-482A-B732-7904F2EE6392}"/>
+              </a:ext>
+            </a:extLst>
+          </p:cNvPr>
+          <p:cNvSpPr>
+            <a:spLocks xmlns:a="http://schemas.openxmlformats.org/drawingml/2006/main" noGrp="1"/>
+          </p:cNvSpPr>
+          <p:nvPr/>
+        </p:nvSpPr>
+        <p:spPr>
+          <a:xfrm xmlns:a="http://schemas.openxmlformats.org/drawingml/2006/main">
+            <a:off x="638175" y="4419600"/>
+            <a:ext cx="10763250" cy="428625"/>
+          </a:xfrm>
+          <a:prstGeom xmlns:a="http://schemas.openxmlformats.org/drawingml/2006/main" prst="rect">
+            <a:avLst/>
+          </a:prstGeom>
+          <a:noFill xmlns:a="http://schemas.openxmlformats.org/drawingml/2006/main"/>
+          <a:ln xmlns:a="http://schemas.openxmlformats.org/drawingml/2006/main" w="0">
+            <a:noFill/>
+          </a:ln>
+        </p:spPr>
+        <p:txBody>
+          <a:bodyPr xmlns:a="http://schemas.openxmlformats.org/drawingml/2006/main">
+            <a:noAutofit/>
+          </a:bodyPr>
+          <a:lstStyle xmlns:a="http://schemas.openxmlformats.org/drawingml/2006/main"/>
+          <a:p xmlns:a="http://schemas.openxmlformats.org/drawingml/2006/main">
+            <a:pPr>
+              <a:defRPr sz="1650" b="0">
+                <a:solidFill>
+                  <a:srgbClr val="A6E1CB"/>
+                </a:solidFill>
+                <a:latin typeface="Helvetica Neue"/>
+                <a:ea typeface="Helvetica Neue"/>
+                <a:cs typeface="Helvetica Neue"/>
+              </a:defRPr>
+            </a:pPr>
+            <a:r>
+              <a:rPr sz="1650" b="0">
+                <a:solidFill>
+                  <a:srgbClr val="A6E1CB"/>
+                </a:solidFill>
+                <a:latin typeface="Helvetica Neue"/>
+                <a:ea typeface="Helvetica Neue"/>
+                <a:cs typeface="Helvetica Neue"/>
+              </a:rPr>
+              <a:t>Synthetic records and mocked provider contracts do not verify live model quality.</a:t>
+            </a:r>
+          </a:p>
+        </p:txBody>
+      </p:sp>
+      <p:sp>
+        <p:nvSpPr>
+          <p:cNvPr id="8" name="">
+            <a:extLst xmlns:a="http://schemas.openxmlformats.org/drawingml/2006/main">
+              <a:ext uri="{FF2B5EF4-FFF2-40B4-BE49-F238E27FC236}">
+                <a16:creationId xmlns:a16="http://schemas.microsoft.com/office/drawing/2014/main" id="{738837BB-330C-42D8-AB66-A2A455BADD10}"/>
+              </a:ext>
+            </a:extLst>
+          </p:cNvPr>
+          <p:cNvSpPr>
+            <a:spLocks xmlns:a="http://schemas.openxmlformats.org/drawingml/2006/main" noGrp="1"/>
+          </p:cNvSpPr>
+          <p:nvPr/>
+        </p:nvSpPr>
+        <p:spPr>
+          <a:xfrm xmlns:a="http://schemas.openxmlformats.org/drawingml/2006/main">
+            <a:off x="619125" y="5086350"/>
+            <a:ext cx="6667500" cy="514350"/>
+          </a:xfrm>
+          <a:prstGeom xmlns:a="http://schemas.openxmlformats.org/drawingml/2006/main" prst="rect">
+            <a:avLst/>
+          </a:prstGeom>
+          <a:noFill xmlns:a="http://schemas.openxmlformats.org/drawingml/2006/main"/>
+          <a:ln xmlns:a="http://schemas.openxmlformats.org/drawingml/2006/main" w="0">
+            <a:noFill/>
+          </a:ln>
+        </p:spPr>
+        <p:txBody>
+          <a:bodyPr xmlns:a="http://schemas.openxmlformats.org/drawingml/2006/main">
+            <a:noAutofit/>
+          </a:bodyPr>
+          <a:lstStyle xmlns:a="http://schemas.openxmlformats.org/drawingml/2006/main"/>
+          <a:p xmlns:a="http://schemas.openxmlformats.org/drawingml/2006/main">
+            <a:pPr>
+              <a:defRPr sz="2625" b="1">
+                <a:solidFill>
+                  <a:srgbClr val="FFFFFF"/>
+                </a:solidFill>
+                <a:latin typeface="Helvetica Neue"/>
+                <a:ea typeface="Helvetica Neue"/>
+                <a:cs typeface="Helvetica Neue"/>
+              </a:defRPr>
+            </a:pPr>
+            <a:r>
+              <a:rPr sz="2625" b="1">
+                <a:solidFill>
+                  <a:srgbClr val="FFFFFF"/>
+                </a:solidFill>
+                <a:latin typeface="Helvetica Neue"/>
+                <a:ea typeface="Helvetica Neue"/>
+                <a:cs typeface="Helvetica Neue"/>
+              </a:rPr>
+              <a:t>Shivam Gupta</a:t>
+            </a:r>
+          </a:p>
+        </p:txBody>
+      </p:sp>
+      <p:sp>
+        <p:nvSpPr>
           <p:cNvPr id="9" name="">
             <a:extLst xmlns:a="http://schemas.openxmlformats.org/drawingml/2006/main">
               <a:ext uri="{FF2B5EF4-FFF2-40B4-BE49-F238E27FC236}">
-                <a16:creationId xmlns:a16="http://schemas.microsoft.com/office/drawing/2014/main" id="{E9E78E9A-0BAF-41E6-93DE-FFA71B7F55C8}"/>
+                <a16:creationId xmlns:a16="http://schemas.microsoft.com/office/drawing/2014/main" id="{1AB3AC7E-8A19-4889-9A6C-9CE3E0356898}"/>
               </a:ext>
             </a:extLst>
           </p:cNvPr>
@@ -5283,8 +5968,8 @@
         </p:nvSpPr>
         <p:spPr>
           <a:xfrm xmlns:a="http://schemas.openxmlformats.org/drawingml/2006/main">
-            <a:off x="609600" y="476250"/>
-            <a:ext cx="10972800" cy="762000"/>
+            <a:off x="638175" y="5648325"/>
+            <a:ext cx="10763250" cy="419100"/>
           </a:xfrm>
           <a:prstGeom xmlns:a="http://schemas.openxmlformats.org/drawingml/2006/main" prst="rect">
             <a:avLst/>
@@ -5301,543 +5986,6 @@
           <a:lstStyle xmlns:a="http://schemas.openxmlformats.org/drawingml/2006/main"/>
           <a:p xmlns:a="http://schemas.openxmlformats.org/drawingml/2006/main">
             <a:pPr>
-              <a:defRPr sz="3450" b="1">
-                <a:solidFill>
-                  <a:srgbClr val="FFFFFF"/>
-                </a:solidFill>
-                <a:latin typeface="Helvetica Neue"/>
-                <a:ea typeface="Helvetica Neue"/>
-                <a:cs typeface="Helvetica Neue"/>
-              </a:defRPr>
-            </a:pPr>
-            <a:r>
-              <a:rPr sz="3450" b="1">
-                <a:solidFill>
-                  <a:srgbClr val="FFFFFF"/>
-                </a:solidFill>
-                <a:latin typeface="Helvetica Neue"/>
-                <a:ea typeface="Helvetica Neue"/>
-                <a:cs typeface="Helvetica Neue"/>
-              </a:rPr>
-              <a:t>The next proof is a real drill</a:t>
-            </a:r>
-          </a:p>
-        </p:txBody>
-      </p:sp>
-      <p:sp>
-        <p:nvSpPr>
-          <p:cNvPr id="2" name="">
-            <a:extLst xmlns:a="http://schemas.openxmlformats.org/drawingml/2006/main">
-              <a:ext uri="{FF2B5EF4-FFF2-40B4-BE49-F238E27FC236}">
-                <a16:creationId xmlns:a16="http://schemas.microsoft.com/office/drawing/2014/main" id="{C5CD2EA8-5F29-4B1F-8B77-DDF9BDA8E5B0}"/>
-              </a:ext>
-            </a:extLst>
-          </p:cNvPr>
-          <p:cNvSpPr>
-            <a:spLocks xmlns:a="http://schemas.openxmlformats.org/drawingml/2006/main" noGrp="1"/>
-          </p:cNvSpPr>
-          <p:nvPr/>
-        </p:nvSpPr>
-        <p:spPr>
-          <a:xfrm xmlns:a="http://schemas.openxmlformats.org/drawingml/2006/main">
-            <a:off x="609600" y="6372225"/>
-            <a:ext cx="6191250" cy="209550"/>
-          </a:xfrm>
-          <a:prstGeom xmlns:a="http://schemas.openxmlformats.org/drawingml/2006/main" prst="rect">
-            <a:avLst/>
-          </a:prstGeom>
-          <a:noFill xmlns:a="http://schemas.openxmlformats.org/drawingml/2006/main"/>
-          <a:ln xmlns:a="http://schemas.openxmlformats.org/drawingml/2006/main" w="0">
-            <a:noFill/>
-          </a:ln>
-        </p:spPr>
-        <p:txBody>
-          <a:bodyPr xmlns:a="http://schemas.openxmlformats.org/drawingml/2006/main">
-            <a:noAutofit/>
-          </a:bodyPr>
-          <a:lstStyle xmlns:a="http://schemas.openxmlformats.org/drawingml/2006/main"/>
-          <a:p xmlns:a="http://schemas.openxmlformats.org/drawingml/2006/main">
-            <a:pPr>
-              <a:defRPr sz="1200" b="0">
-                <a:solidFill>
-                  <a:srgbClr val="A6E1CB"/>
-                </a:solidFill>
-                <a:latin typeface="Helvetica Neue"/>
-                <a:ea typeface="Helvetica Neue"/>
-                <a:cs typeface="Helvetica Neue"/>
-              </a:defRPr>
-            </a:pPr>
-            <a:r>
-              <a:rPr sz="1200" b="0">
-                <a:solidFill>
-                  <a:srgbClr val="A6E1CB"/>
-                </a:solidFill>
-                <a:latin typeface="Helvetica Neue"/>
-                <a:ea typeface="Helvetica Neue"/>
-                <a:cs typeface="Helvetica Neue"/>
-              </a:rPr>
-              <a:t>RecallRoom   /   6</a:t>
-            </a:r>
-          </a:p>
-        </p:txBody>
-      </p:sp>
-      <p:sp>
-        <p:nvSpPr>
-          <p:cNvPr id="3" name="">
-            <a:extLst xmlns:a="http://schemas.openxmlformats.org/drawingml/2006/main">
-              <a:ext uri="{FF2B5EF4-FFF2-40B4-BE49-F238E27FC236}">
-                <a16:creationId xmlns:a16="http://schemas.microsoft.com/office/drawing/2014/main" id="{D7FF9EC4-362A-40DA-8657-F46B426559FB}"/>
-              </a:ext>
-            </a:extLst>
-          </p:cNvPr>
-          <p:cNvSpPr>
-            <a:spLocks xmlns:a="http://schemas.openxmlformats.org/drawingml/2006/main" noGrp="1"/>
-          </p:cNvSpPr>
-          <p:nvPr/>
-        </p:nvSpPr>
-        <p:spPr>
-          <a:xfrm xmlns:a="http://schemas.openxmlformats.org/drawingml/2006/main">
-            <a:off x="619125" y="1581150"/>
-            <a:ext cx="4667250" cy="476250"/>
-          </a:xfrm>
-          <a:prstGeom xmlns:a="http://schemas.openxmlformats.org/drawingml/2006/main" prst="rect">
-            <a:avLst/>
-          </a:prstGeom>
-          <a:noFill xmlns:a="http://schemas.openxmlformats.org/drawingml/2006/main"/>
-          <a:ln xmlns:a="http://schemas.openxmlformats.org/drawingml/2006/main" w="0">
-            <a:noFill/>
-          </a:ln>
-        </p:spPr>
-        <p:txBody>
-          <a:bodyPr xmlns:a="http://schemas.openxmlformats.org/drawingml/2006/main">
-            <a:noAutofit/>
-          </a:bodyPr>
-          <a:lstStyle xmlns:a="http://schemas.openxmlformats.org/drawingml/2006/main"/>
-          <a:p xmlns:a="http://schemas.openxmlformats.org/drawingml/2006/main">
-            <a:pPr>
-              <a:defRPr sz="2325" b="1">
-                <a:solidFill>
-                  <a:srgbClr val="A6E1CB"/>
-                </a:solidFill>
-                <a:latin typeface="Helvetica Neue"/>
-                <a:ea typeface="Helvetica Neue"/>
-                <a:cs typeface="Helvetica Neue"/>
-              </a:defRPr>
-            </a:pPr>
-            <a:r>
-              <a:rPr sz="2325" b="1">
-                <a:solidFill>
-                  <a:srgbClr val="A6E1CB"/>
-                </a:solidFill>
-                <a:latin typeface="Helvetica Neue"/>
-                <a:ea typeface="Helvetica Neue"/>
-                <a:cs typeface="Helvetica Neue"/>
-              </a:rPr>
-              <a:t>Built</a:t>
-            </a:r>
-          </a:p>
-        </p:txBody>
-      </p:sp>
-      <p:sp>
-        <p:nvSpPr>
-          <p:cNvPr id="4" name="">
-            <a:extLst xmlns:a="http://schemas.openxmlformats.org/drawingml/2006/main">
-              <a:ext uri="{FF2B5EF4-FFF2-40B4-BE49-F238E27FC236}">
-                <a16:creationId xmlns:a16="http://schemas.microsoft.com/office/drawing/2014/main" id="{9FE74206-1E55-49BD-86BF-2E586A9767A9}"/>
-              </a:ext>
-            </a:extLst>
-          </p:cNvPr>
-          <p:cNvSpPr>
-            <a:spLocks xmlns:a="http://schemas.openxmlformats.org/drawingml/2006/main" noGrp="1"/>
-          </p:cNvSpPr>
-          <p:nvPr/>
-        </p:nvSpPr>
-        <p:spPr>
-          <a:xfrm xmlns:a="http://schemas.openxmlformats.org/drawingml/2006/main">
-            <a:off x="638175" y="2343150"/>
-            <a:ext cx="4810125" cy="2038350"/>
-          </a:xfrm>
-          <a:prstGeom xmlns:a="http://schemas.openxmlformats.org/drawingml/2006/main" prst="rect">
-            <a:avLst/>
-          </a:prstGeom>
-          <a:noFill xmlns:a="http://schemas.openxmlformats.org/drawingml/2006/main"/>
-          <a:ln xmlns:a="http://schemas.openxmlformats.org/drawingml/2006/main" w="0">
-            <a:noFill/>
-          </a:ln>
-        </p:spPr>
-        <p:txBody>
-          <a:bodyPr xmlns:a="http://schemas.openxmlformats.org/drawingml/2006/main">
-            <a:noAutofit/>
-          </a:bodyPr>
-          <a:lstStyle xmlns:a="http://schemas.openxmlformats.org/drawingml/2006/main"/>
-          <a:p xmlns:a="http://schemas.openxmlformats.org/drawingml/2006/main">
-            <a:pPr>
-              <a:defRPr sz="2325" b="0">
-                <a:solidFill>
-                  <a:srgbClr val="FFFFFF"/>
-                </a:solidFill>
-                <a:latin typeface="Helvetica Neue"/>
-                <a:ea typeface="Helvetica Neue"/>
-                <a:cs typeface="Helvetica Neue"/>
-              </a:defRPr>
-            </a:pPr>
-            <a:r>
-              <a:rPr sz="2325" b="0">
-                <a:solidFill>
-                  <a:srgbClr val="FFFFFF"/>
-                </a:solidFill>
-                <a:latin typeface="Helvetica Neue"/>
-                <a:ea typeface="Helvetica Neue"/>
-                <a:cs typeface="Helvetica Neue"/>
-              </a:rPr>
-              <a:t>Private cases with source originals</a:t>
-            </a:r>
-          </a:p>
-          <a:p xmlns:a="http://schemas.openxmlformats.org/drawingml/2006/main">
-            <a:pPr>
-              <a:defRPr sz="2325" b="0">
-                <a:solidFill>
-                  <a:srgbClr val="FFFFFF"/>
-                </a:solidFill>
-                <a:latin typeface="Helvetica Neue"/>
-                <a:ea typeface="Helvetica Neue"/>
-                <a:cs typeface="Helvetica Neue"/>
-              </a:defRPr>
-            </a:pPr>
-            <a:r>
-              <a:rPr sz="2325" b="0">
-                <a:solidFill>
-                  <a:srgbClr val="FFFFFF"/>
-                </a:solidFill>
-                <a:latin typeface="Helvetica Neue"/>
-                <a:ea typeface="Helvetica Neue"/>
-                <a:cs typeface="Helvetica Neue"/>
-              </a:rPr>
-              <a:t>Evidence-linked lot tracing</a:t>
-            </a:r>
-          </a:p>
-          <a:p xmlns:a="http://schemas.openxmlformats.org/drawingml/2006/main">
-            <a:pPr>
-              <a:defRPr sz="2325" b="0">
-                <a:solidFill>
-                  <a:srgbClr val="FFFFFF"/>
-                </a:solidFill>
-                <a:latin typeface="Helvetica Neue"/>
-                <a:ea typeface="Helvetica Neue"/>
-                <a:cs typeface="Helvetica Neue"/>
-              </a:defRPr>
-            </a:pPr>
-            <a:r>
-              <a:rPr sz="2325" b="0">
-                <a:solidFill>
-                  <a:srgbClr val="FFFFFF"/>
-                </a:solidFill>
-                <a:latin typeface="Helvetica Neue"/>
-                <a:ea typeface="Helvetica Neue"/>
-                <a:cs typeface="Helvetica Neue"/>
-              </a:rPr>
-              <a:t>Reviewed ambiguity decisions</a:t>
-            </a:r>
-          </a:p>
-          <a:p xmlns:a="http://schemas.openxmlformats.org/drawingml/2006/main">
-            <a:pPr>
-              <a:defRPr sz="2325" b="0">
-                <a:solidFill>
-                  <a:srgbClr val="FFFFFF"/>
-                </a:solidFill>
-                <a:latin typeface="Helvetica Neue"/>
-                <a:ea typeface="Helvetica Neue"/>
-                <a:cs typeface="Helvetica Neue"/>
-              </a:defRPr>
-            </a:pPr>
-            <a:r>
-              <a:rPr sz="2325" b="0">
-                <a:solidFill>
-                  <a:srgbClr val="FFFFFF"/>
-                </a:solidFill>
-                <a:latin typeface="Helvetica Neue"/>
-                <a:ea typeface="Helvetica Neue"/>
-                <a:cs typeface="Helvetica Neue"/>
-              </a:rPr>
-              <a:t>Portable response packets</a:t>
-            </a:r>
-          </a:p>
-        </p:txBody>
-      </p:sp>
-      <p:sp>
-        <p:nvSpPr>
-          <p:cNvPr id="5" name="">
-            <a:extLst xmlns:a="http://schemas.openxmlformats.org/drawingml/2006/main">
-              <a:ext uri="{FF2B5EF4-FFF2-40B4-BE49-F238E27FC236}">
-                <a16:creationId xmlns:a16="http://schemas.microsoft.com/office/drawing/2014/main" id="{E552F011-08C3-411F-B0BC-5FD3576AFC8D}"/>
-              </a:ext>
-            </a:extLst>
-          </p:cNvPr>
-          <p:cNvSpPr>
-            <a:spLocks xmlns:a="http://schemas.openxmlformats.org/drawingml/2006/main" noGrp="1"/>
-          </p:cNvSpPr>
-          <p:nvPr/>
-        </p:nvSpPr>
-        <p:spPr>
-          <a:xfrm xmlns:a="http://schemas.openxmlformats.org/drawingml/2006/main">
-            <a:off x="6581775" y="1581150"/>
-            <a:ext cx="4991100" cy="476250"/>
-          </a:xfrm>
-          <a:prstGeom xmlns:a="http://schemas.openxmlformats.org/drawingml/2006/main" prst="rect">
-            <a:avLst/>
-          </a:prstGeom>
-          <a:noFill xmlns:a="http://schemas.openxmlformats.org/drawingml/2006/main"/>
-          <a:ln xmlns:a="http://schemas.openxmlformats.org/drawingml/2006/main" w="0">
-            <a:noFill/>
-          </a:ln>
-        </p:spPr>
-        <p:txBody>
-          <a:bodyPr xmlns:a="http://schemas.openxmlformats.org/drawingml/2006/main">
-            <a:noAutofit/>
-          </a:bodyPr>
-          <a:lstStyle xmlns:a="http://schemas.openxmlformats.org/drawingml/2006/main"/>
-          <a:p xmlns:a="http://schemas.openxmlformats.org/drawingml/2006/main">
-            <a:pPr>
-              <a:defRPr sz="2325" b="1">
-                <a:solidFill>
-                  <a:srgbClr val="A6E1CB"/>
-                </a:solidFill>
-                <a:latin typeface="Helvetica Neue"/>
-                <a:ea typeface="Helvetica Neue"/>
-                <a:cs typeface="Helvetica Neue"/>
-              </a:defRPr>
-            </a:pPr>
-            <a:r>
-              <a:rPr sz="2325" b="1">
-                <a:solidFill>
-                  <a:srgbClr val="A6E1CB"/>
-                </a:solidFill>
-                <a:latin typeface="Helvetica Neue"/>
-                <a:ea typeface="Helvetica Neue"/>
-                <a:cs typeface="Helvetica Neue"/>
-              </a:rPr>
-              <a:t>Next evidence</a:t>
-            </a:r>
-          </a:p>
-        </p:txBody>
-      </p:sp>
-      <p:sp>
-        <p:nvSpPr>
-          <p:cNvPr id="6" name="">
-            <a:extLst xmlns:a="http://schemas.openxmlformats.org/drawingml/2006/main">
-              <a:ext uri="{FF2B5EF4-FFF2-40B4-BE49-F238E27FC236}">
-                <a16:creationId xmlns:a16="http://schemas.microsoft.com/office/drawing/2014/main" id="{A617D3A7-1BDC-46FB-AF97-CF1A98EC323D}"/>
-              </a:ext>
-            </a:extLst>
-          </p:cNvPr>
-          <p:cNvSpPr>
-            <a:spLocks xmlns:a="http://schemas.openxmlformats.org/drawingml/2006/main" noGrp="1"/>
-          </p:cNvSpPr>
-          <p:nvPr/>
-        </p:nvSpPr>
-        <p:spPr>
-          <a:xfrm xmlns:a="http://schemas.openxmlformats.org/drawingml/2006/main">
-            <a:off x="6600825" y="2343150"/>
-            <a:ext cx="4972050" cy="2038350"/>
-          </a:xfrm>
-          <a:prstGeom xmlns:a="http://schemas.openxmlformats.org/drawingml/2006/main" prst="rect">
-            <a:avLst/>
-          </a:prstGeom>
-          <a:noFill xmlns:a="http://schemas.openxmlformats.org/drawingml/2006/main"/>
-          <a:ln xmlns:a="http://schemas.openxmlformats.org/drawingml/2006/main" w="0">
-            <a:noFill/>
-          </a:ln>
-        </p:spPr>
-        <p:txBody>
-          <a:bodyPr xmlns:a="http://schemas.openxmlformats.org/drawingml/2006/main">
-            <a:noAutofit/>
-          </a:bodyPr>
-          <a:lstStyle xmlns:a="http://schemas.openxmlformats.org/drawingml/2006/main"/>
-          <a:p xmlns:a="http://schemas.openxmlformats.org/drawingml/2006/main">
-            <a:pPr>
-              <a:defRPr sz="2325" b="0">
-                <a:solidFill>
-                  <a:srgbClr val="FFFFFF"/>
-                </a:solidFill>
-                <a:latin typeface="Helvetica Neue"/>
-                <a:ea typeface="Helvetica Neue"/>
-                <a:cs typeface="Helvetica Neue"/>
-              </a:defRPr>
-            </a:pPr>
-            <a:r>
-              <a:rPr sz="2325" b="0">
-                <a:solidFill>
-                  <a:srgbClr val="FFFFFF"/>
-                </a:solidFill>
-                <a:latin typeface="Helvetica Neue"/>
-                <a:ea typeface="Helvetica Neue"/>
-                <a:cs typeface="Helvetica Neue"/>
-              </a:rPr>
-              <a:t>Verify live Nemotron on Nebius</a:t>
-            </a:r>
-          </a:p>
-          <a:p xmlns:a="http://schemas.openxmlformats.org/drawingml/2006/main">
-            <a:pPr>
-              <a:defRPr sz="2325" b="0">
-                <a:solidFill>
-                  <a:srgbClr val="FFFFFF"/>
-                </a:solidFill>
-                <a:latin typeface="Helvetica Neue"/>
-                <a:ea typeface="Helvetica Neue"/>
-                <a:cs typeface="Helvetica Neue"/>
-              </a:defRPr>
-            </a:pPr>
-            <a:r>
-              <a:rPr sz="2325" b="0">
-                <a:solidFill>
-                  <a:srgbClr val="FFFFFF"/>
-                </a:solidFill>
-                <a:latin typeface="Helvetica Neue"/>
-                <a:ea typeface="Helvetica Neue"/>
-                <a:cs typeface="Helvetica Neue"/>
-              </a:rPr>
-              <a:t>Measure against human answer keys</a:t>
-            </a:r>
-          </a:p>
-          <a:p xmlns:a="http://schemas.openxmlformats.org/drawingml/2006/main">
-            <a:pPr>
-              <a:defRPr sz="2325" b="0">
-                <a:solidFill>
-                  <a:srgbClr val="FFFFFF"/>
-                </a:solidFill>
-                <a:latin typeface="Helvetica Neue"/>
-                <a:ea typeface="Helvetica Neue"/>
-                <a:cs typeface="Helvetica Neue"/>
-              </a:defRPr>
-            </a:pPr>
-            <a:r>
-              <a:rPr sz="2325" b="0">
-                <a:solidFill>
-                  <a:srgbClr val="FFFFFF"/>
-                </a:solidFill>
-                <a:latin typeface="Helvetica Neue"/>
-                <a:ea typeface="Helvetica Neue"/>
-                <a:cs typeface="Helvetica Neue"/>
-              </a:rPr>
-              <a:t>Observe quality managers using it</a:t>
-            </a:r>
-          </a:p>
-          <a:p xmlns:a="http://schemas.openxmlformats.org/drawingml/2006/main">
-            <a:pPr>
-              <a:defRPr sz="2325" b="0">
-                <a:solidFill>
-                  <a:srgbClr val="FFFFFF"/>
-                </a:solidFill>
-                <a:latin typeface="Helvetica Neue"/>
-                <a:ea typeface="Helvetica Neue"/>
-                <a:cs typeface="Helvetica Neue"/>
-              </a:defRPr>
-            </a:pPr>
-            <a:r>
-              <a:rPr sz="2325" b="0">
-                <a:solidFill>
-                  <a:srgbClr val="FFFFFF"/>
-                </a:solidFill>
-                <a:latin typeface="Helvetica Neue"/>
-                <a:ea typeface="Helvetica Neue"/>
-                <a:cs typeface="Helvetica Neue"/>
-              </a:rPr>
-              <a:t>Test a paid pilot and repeat usage</a:t>
-            </a:r>
-          </a:p>
-        </p:txBody>
-      </p:sp>
-      <p:sp>
-        <p:nvSpPr>
-          <p:cNvPr id="7" name="">
-            <a:extLst xmlns:a="http://schemas.openxmlformats.org/drawingml/2006/main">
-              <a:ext uri="{FF2B5EF4-FFF2-40B4-BE49-F238E27FC236}">
-                <a16:creationId xmlns:a16="http://schemas.microsoft.com/office/drawing/2014/main" id="{0FBED45D-390F-4EE1-A9C5-E69B20A951A7}"/>
-              </a:ext>
-            </a:extLst>
-          </p:cNvPr>
-          <p:cNvSpPr>
-            <a:spLocks xmlns:a="http://schemas.openxmlformats.org/drawingml/2006/main" noGrp="1"/>
-          </p:cNvSpPr>
-          <p:nvPr/>
-        </p:nvSpPr>
-        <p:spPr>
-          <a:xfrm xmlns:a="http://schemas.openxmlformats.org/drawingml/2006/main">
-            <a:off x="619125" y="5086350"/>
-            <a:ext cx="6667500" cy="514350"/>
-          </a:xfrm>
-          <a:prstGeom xmlns:a="http://schemas.openxmlformats.org/drawingml/2006/main" prst="rect">
-            <a:avLst/>
-          </a:prstGeom>
-          <a:noFill xmlns:a="http://schemas.openxmlformats.org/drawingml/2006/main"/>
-          <a:ln xmlns:a="http://schemas.openxmlformats.org/drawingml/2006/main" w="0">
-            <a:noFill/>
-          </a:ln>
-        </p:spPr>
-        <p:txBody>
-          <a:bodyPr xmlns:a="http://schemas.openxmlformats.org/drawingml/2006/main">
-            <a:noAutofit/>
-          </a:bodyPr>
-          <a:lstStyle xmlns:a="http://schemas.openxmlformats.org/drawingml/2006/main"/>
-          <a:p xmlns:a="http://schemas.openxmlformats.org/drawingml/2006/main">
-            <a:pPr>
-              <a:defRPr sz="2625" b="1">
-                <a:solidFill>
-                  <a:srgbClr val="FFFFFF"/>
-                </a:solidFill>
-                <a:latin typeface="Helvetica Neue"/>
-                <a:ea typeface="Helvetica Neue"/>
-                <a:cs typeface="Helvetica Neue"/>
-              </a:defRPr>
-            </a:pPr>
-            <a:r>
-              <a:rPr sz="2625" b="1">
-                <a:solidFill>
-                  <a:srgbClr val="FFFFFF"/>
-                </a:solidFill>
-                <a:latin typeface="Helvetica Neue"/>
-                <a:ea typeface="Helvetica Neue"/>
-                <a:cs typeface="Helvetica Neue"/>
-              </a:rPr>
-              <a:t>Shivam Gupta</a:t>
-            </a:r>
-          </a:p>
-        </p:txBody>
-      </p:sp>
-      <p:sp>
-        <p:nvSpPr>
-          <p:cNvPr id="8" name="">
-            <a:extLst xmlns:a="http://schemas.openxmlformats.org/drawingml/2006/main">
-              <a:ext uri="{FF2B5EF4-FFF2-40B4-BE49-F238E27FC236}">
-                <a16:creationId xmlns:a16="http://schemas.microsoft.com/office/drawing/2014/main" id="{D03C6090-3DAC-4DE7-B2BB-BAB0B32E753E}"/>
-              </a:ext>
-            </a:extLst>
-          </p:cNvPr>
-          <p:cNvSpPr>
-            <a:spLocks xmlns:a="http://schemas.openxmlformats.org/drawingml/2006/main" noGrp="1"/>
-          </p:cNvSpPr>
-          <p:nvPr/>
-        </p:nvSpPr>
-        <p:spPr>
-          <a:xfrm xmlns:a="http://schemas.openxmlformats.org/drawingml/2006/main">
-            <a:off x="638175" y="5648325"/>
-            <a:ext cx="10763250" cy="419100"/>
-          </a:xfrm>
-          <a:prstGeom xmlns:a="http://schemas.openxmlformats.org/drawingml/2006/main" prst="rect">
-            <a:avLst/>
-          </a:prstGeom>
-          <a:noFill xmlns:a="http://schemas.openxmlformats.org/drawingml/2006/main"/>
-          <a:ln xmlns:a="http://schemas.openxmlformats.org/drawingml/2006/main" w="0">
-            <a:noFill/>
-          </a:ln>
-        </p:spPr>
-        <p:txBody>
-          <a:bodyPr xmlns:a="http://schemas.openxmlformats.org/drawingml/2006/main">
-            <a:noAutofit/>
-          </a:bodyPr>
-          <a:lstStyle xmlns:a="http://schemas.openxmlformats.org/drawingml/2006/main"/>
-          <a:p xmlns:a="http://schemas.openxmlformats.org/drawingml/2006/main">
-            <a:pPr>
               <a:defRPr sz="1875" b="0">
                 <a:solidFill>
                   <a:srgbClr val="A6E1CB"/>
@@ -5864,7 +6012,7 @@
     </p:spTree>
     <p:extLst>
       <p:ext uri="{BB962C8B-B14F-4D97-AF65-F5344CB8AC3E}">
-        <p14:creationId xmlns:p14="http://schemas.microsoft.com/office/powerpoint/2010/main" val="1837869138"/>
+        <p14:creationId xmlns:p14="http://schemas.microsoft.com/office/powerpoint/2010/main" val="289799701"/>
       </p:ext>
     </p:extLst>
   </p:cSld>

</xml_diff>

<commit_message>
Record final hosted acceptance and publish captioned product walkthrough
</commit_message>
<xml_diff>
--- a/docs/pitch/RecallRoom-pitch.pptx
+++ b/docs/pitch/RecallRoom-pitch.pptx
@@ -2,18 +2,18 @@
 <file path=ppt/presentation.xml><?xml version="1.0" encoding="utf-8"?>
 <p:presentation xmlns:p="http://schemas.openxmlformats.org/presentationml/2006/main">
   <p:sldMasterIdLst>
-    <p:sldMasterId xmlns:r="http://schemas.openxmlformats.org/officeDocument/2006/relationships" id="2147483648" r:id="R152b21608ff84913"/>
+    <p:sldMasterId xmlns:r="http://schemas.openxmlformats.org/officeDocument/2006/relationships" id="2147483648" r:id="R4c8f035dc7ce4f66"/>
   </p:sldMasterIdLst>
   <p:notesMasterIdLst>
-    <p:notesMasterId xmlns:r="http://schemas.openxmlformats.org/officeDocument/2006/relationships" r:id="R7ab1fae14c714cf7"/>
+    <p:notesMasterId xmlns:r="http://schemas.openxmlformats.org/officeDocument/2006/relationships" r:id="Rb9e8d2760fbc480e"/>
   </p:notesMasterIdLst>
   <p:sldIdLst>
-    <p:sldId xmlns:r="http://schemas.openxmlformats.org/officeDocument/2006/relationships" id="256" r:id="R77de9039fc314506"/>
-    <p:sldId xmlns:r="http://schemas.openxmlformats.org/officeDocument/2006/relationships" id="257" r:id="R5e50a74ff58a4837"/>
-    <p:sldId xmlns:r="http://schemas.openxmlformats.org/officeDocument/2006/relationships" id="258" r:id="R416071f98dcd424f"/>
-    <p:sldId xmlns:r="http://schemas.openxmlformats.org/officeDocument/2006/relationships" id="259" r:id="R70186713d40a441f"/>
-    <p:sldId xmlns:r="http://schemas.openxmlformats.org/officeDocument/2006/relationships" id="260" r:id="Rc86d9527bd9b4a59"/>
-    <p:sldId xmlns:r="http://schemas.openxmlformats.org/officeDocument/2006/relationships" id="261" r:id="R098e4d078f264231"/>
+    <p:sldId xmlns:r="http://schemas.openxmlformats.org/officeDocument/2006/relationships" id="256" r:id="Ra4a3300759d244f6"/>
+    <p:sldId xmlns:r="http://schemas.openxmlformats.org/officeDocument/2006/relationships" id="257" r:id="R14232779f62042d3"/>
+    <p:sldId xmlns:r="http://schemas.openxmlformats.org/officeDocument/2006/relationships" id="258" r:id="R21eb88db50e249de"/>
+    <p:sldId xmlns:r="http://schemas.openxmlformats.org/officeDocument/2006/relationships" id="259" r:id="Rb2c3ddec8ae14c01"/>
+    <p:sldId xmlns:r="http://schemas.openxmlformats.org/officeDocument/2006/relationships" id="260" r:id="Rfb305191cf474d3e"/>
+    <p:sldId xmlns:r="http://schemas.openxmlformats.org/officeDocument/2006/relationships" id="261" r:id="R64b61bca15ed4b5e"/>
   </p:sldIdLst>
   <p:sldSz cx="12192000" cy="6858000"/>
   <p:notesSz cx="6858000" cy="9144000"/>
@@ -797,7 +797,7 @@
           <a:lstStyle xmlns:a="http://schemas.openxmlformats.org/drawingml/2006/main"/>
           <a:p xmlns:a="http://schemas.openxmlformats.org/drawingml/2006/main">
             <a:r>
-              <a:t>Public demo: https://recallroom.web.app . Repository: https://github.com/shi1720/Nebius-x-NVIDIA . Application verification: 37 automated tests, 58 hosted Firebase API checks and 10 operator checks against production Firestore functions. Hosted API checks use real disposable Firebase accounts and synthetic records. Operator checks do not enqueue inference. Provider contracts use mocks. These results do not prove live NVIDIA inference, customer value, or real-world recall accuracy. Sources: docs/STATUS.md, docs/evaluation/firebase-api.json and docs/evaluation/firebase-operator.json. Founder/project creator credit: Shivam Gupta. AI assistance covered research, implementation, testing, and documentation; no additional personal actions or external validation are invented. Submission requires verified use of an NVIDIA open-source model on Nebius Token Factory or Nebius AI Cloud, a working public demo, public repository with license, and a public demo video at most three minutes with audio naming the provider and model. This deck is an honest MVP pitch, not a claim of readiness for real incident reliance.</a:t>
+              <a:t>Public demo: https://recallroom.web.app . Repository: https://github.com/shi1720/Nebius-x-NVIDIA . Application verification: 37 automated tests, 60 hosted Firebase API checks and 10 operator checks against production Firestore functions. Hosted API checks use real disposable Firebase accounts and synthetic records. Operator checks do not enqueue inference. Provider contracts use mocks. These results do not prove live NVIDIA inference, customer value, or real-world recall accuracy. Sources: docs/STATUS.md, docs/evaluation/firebase-api.json and docs/evaluation/firebase-operator.json. Founder/project creator credit: Shivam Gupta. AI assistance covered research, implementation, testing, and documentation; no additional personal actions or external validation are invented. Submission requires verified use of an NVIDIA open-source model on Nebius Token Factory or Nebius AI Cloud, a working public demo, public repository with license, and a public demo video at most three minutes with audio naming the provider and model. This deck is an honest MVP pitch, not a claim of readiness for real incident reliance.</a:t>
             </a:r>
           </a:p>
         </p:txBody>
@@ -865,7 +865,7 @@
   </p:cSld>
   <p:clrMap bg1="lt1" tx1="dk1" bg2="lt2" tx2="dk2" accent1="accent1" accent2="accent2" accent3="accent3" accent4="accent4" accent5="accent5" accent6="accent6" hlink="hlink" folHlink="folHlink"/>
   <p:sldLayoutIdLst>
-    <p:sldLayoutId xmlns:r="http://schemas.openxmlformats.org/officeDocument/2006/relationships" id="2147483649" r:id="Raba6836651854886"/>
+    <p:sldLayoutId xmlns:r="http://schemas.openxmlformats.org/officeDocument/2006/relationships" id="2147483649" r:id="R140e9665b3e54076"/>
   </p:sldLayoutIdLst>
   <p:txStyles>
     <p:titleStyle>
@@ -1416,7 +1416,7 @@
           <p:cNvPr id="7" name="">
             <a:extLst xmlns:a="http://schemas.openxmlformats.org/drawingml/2006/main">
               <a:ext uri="{FF2B5EF4-FFF2-40B4-BE49-F238E27FC236}">
-                <a16:creationId xmlns:a16="http://schemas.microsoft.com/office/drawing/2014/main" id="{CF5C17A8-F587-4EA0-8052-50C236A3DCE7}"/>
+                <a16:creationId xmlns:a16="http://schemas.microsoft.com/office/drawing/2014/main" id="{D4007EDD-433D-45C7-B674-D7DB99946AE1}"/>
               </a:ext>
             </a:extLst>
           </p:cNvPr>
@@ -1473,7 +1473,7 @@
           <p:cNvPr id="2" name="">
             <a:extLst xmlns:a="http://schemas.openxmlformats.org/drawingml/2006/main">
               <a:ext uri="{FF2B5EF4-FFF2-40B4-BE49-F238E27FC236}">
-                <a16:creationId xmlns:a16="http://schemas.microsoft.com/office/drawing/2014/main" id="{8EC0EF8B-11C9-4E81-BC3A-CB8B6BB2A42F}"/>
+                <a16:creationId xmlns:a16="http://schemas.microsoft.com/office/drawing/2014/main" id="{95B508B4-51F3-43A1-83B5-153788E6D778}"/>
               </a:ext>
             </a:extLst>
           </p:cNvPr>
@@ -1553,7 +1553,7 @@
           <p:cNvPr id="3" name="">
             <a:extLst xmlns:a="http://schemas.openxmlformats.org/drawingml/2006/main">
               <a:ext uri="{FF2B5EF4-FFF2-40B4-BE49-F238E27FC236}">
-                <a16:creationId xmlns:a16="http://schemas.microsoft.com/office/drawing/2014/main" id="{86E5F057-03B6-4229-996F-54083BD33411}"/>
+                <a16:creationId xmlns:a16="http://schemas.microsoft.com/office/drawing/2014/main" id="{3D65BDBC-CAEC-4E1B-B95C-58CA64482364}"/>
               </a:ext>
             </a:extLst>
           </p:cNvPr>
@@ -1610,7 +1610,7 @@
           <p:cNvPr id="4" name="">
             <a:extLst xmlns:a="http://schemas.openxmlformats.org/drawingml/2006/main">
               <a:ext uri="{FF2B5EF4-FFF2-40B4-BE49-F238E27FC236}">
-                <a16:creationId xmlns:a16="http://schemas.microsoft.com/office/drawing/2014/main" id="{84B71015-9A69-4823-83D2-5D61C8227A58}"/>
+                <a16:creationId xmlns:a16="http://schemas.microsoft.com/office/drawing/2014/main" id="{C0613749-5165-43D8-8FBB-852B75082E7A}"/>
               </a:ext>
             </a:extLst>
           </p:cNvPr>
@@ -1667,7 +1667,7 @@
           <p:cNvPr id="5" name="">
             <a:extLst xmlns:a="http://schemas.openxmlformats.org/drawingml/2006/main">
               <a:ext uri="{FF2B5EF4-FFF2-40B4-BE49-F238E27FC236}">
-                <a16:creationId xmlns:a16="http://schemas.microsoft.com/office/drawing/2014/main" id="{12F87530-E1B5-4554-9947-506440E80987}"/>
+                <a16:creationId xmlns:a16="http://schemas.microsoft.com/office/drawing/2014/main" id="{F9846826-FB28-424A-9B30-31381F316C45}"/>
               </a:ext>
             </a:extLst>
           </p:cNvPr>
@@ -1747,7 +1747,7 @@
           <p:cNvPr id="6" name="">
             <a:extLst xmlns:a="http://schemas.openxmlformats.org/drawingml/2006/main">
               <a:ext uri="{FF2B5EF4-FFF2-40B4-BE49-F238E27FC236}">
-                <a16:creationId xmlns:a16="http://schemas.microsoft.com/office/drawing/2014/main" id="{477C78F6-D897-4F93-A1B2-B99954B66CF6}"/>
+                <a16:creationId xmlns:a16="http://schemas.microsoft.com/office/drawing/2014/main" id="{4AD7187A-2FB2-4A18-A599-AA6C3F14D37C}"/>
               </a:ext>
             </a:extLst>
           </p:cNvPr>
@@ -1825,7 +1825,7 @@
     </p:spTree>
     <p:extLst>
       <p:ext uri="{BB962C8B-B14F-4D97-AF65-F5344CB8AC3E}">
-        <p14:creationId xmlns:p14="http://schemas.microsoft.com/office/powerpoint/2010/main" val="788433132"/>
+        <p14:creationId xmlns:p14="http://schemas.microsoft.com/office/powerpoint/2010/main" val="292797611"/>
       </p:ext>
     </p:extLst>
   </p:cSld>
@@ -1856,7 +1856,7 @@
           <p:cNvPr id="18" name="">
             <a:extLst xmlns:a="http://schemas.openxmlformats.org/drawingml/2006/main">
               <a:ext uri="{FF2B5EF4-FFF2-40B4-BE49-F238E27FC236}">
-                <a16:creationId xmlns:a16="http://schemas.microsoft.com/office/drawing/2014/main" id="{DF793AEA-2BAA-4114-9C78-AC44B40AB9E2}"/>
+                <a16:creationId xmlns:a16="http://schemas.microsoft.com/office/drawing/2014/main" id="{1B4C0368-C5EA-4C72-B000-8F1C341E3187}"/>
               </a:ext>
             </a:extLst>
           </p:cNvPr>
@@ -1913,7 +1913,7 @@
           <p:cNvPr id="2" name="">
             <a:extLst xmlns:a="http://schemas.openxmlformats.org/drawingml/2006/main">
               <a:ext uri="{FF2B5EF4-FFF2-40B4-BE49-F238E27FC236}">
-                <a16:creationId xmlns:a16="http://schemas.microsoft.com/office/drawing/2014/main" id="{9F06051C-23B6-425A-B3D5-311E930AA0A5}"/>
+                <a16:creationId xmlns:a16="http://schemas.microsoft.com/office/drawing/2014/main" id="{FE53455A-02FB-4733-B7E2-C3D373D63417}"/>
               </a:ext>
             </a:extLst>
           </p:cNvPr>
@@ -1970,7 +1970,7 @@
           <p:cNvPr id="3" name="">
             <a:extLst xmlns:a="http://schemas.openxmlformats.org/drawingml/2006/main">
               <a:ext uri="{FF2B5EF4-FFF2-40B4-BE49-F238E27FC236}">
-                <a16:creationId xmlns:a16="http://schemas.microsoft.com/office/drawing/2014/main" id="{2736C22A-0236-40F8-BA50-8717727C415B}"/>
+                <a16:creationId xmlns:a16="http://schemas.microsoft.com/office/drawing/2014/main" id="{53C0B9F0-62A7-41A7-BC90-EEE2D55D8B71}"/>
               </a:ext>
             </a:extLst>
           </p:cNvPr>
@@ -2027,7 +2027,7 @@
           <p:cNvPr id="4" name="">
             <a:extLst xmlns:a="http://schemas.openxmlformats.org/drawingml/2006/main">
               <a:ext uri="{FF2B5EF4-FFF2-40B4-BE49-F238E27FC236}">
-                <a16:creationId xmlns:a16="http://schemas.microsoft.com/office/drawing/2014/main" id="{9A167458-0577-4A10-9DD2-0D0F241AFFE4}"/>
+                <a16:creationId xmlns:a16="http://schemas.microsoft.com/office/drawing/2014/main" id="{4B881104-82E7-4B5E-8E98-A95DF3A811B7}"/>
               </a:ext>
             </a:extLst>
           </p:cNvPr>
@@ -2111,7 +2111,7 @@
           <p:cNvPr id="5" name="">
             <a:extLst xmlns:a="http://schemas.openxmlformats.org/drawingml/2006/main">
               <a:ext uri="{FF2B5EF4-FFF2-40B4-BE49-F238E27FC236}">
-                <a16:creationId xmlns:a16="http://schemas.microsoft.com/office/drawing/2014/main" id="{459EF511-2228-4699-AC65-7C8DC1925507}"/>
+                <a16:creationId xmlns:a16="http://schemas.microsoft.com/office/drawing/2014/main" id="{D7BC225F-87D8-4107-B53F-C4DBD9FB00EF}"/>
               </a:ext>
             </a:extLst>
           </p:cNvPr>
@@ -2195,7 +2195,7 @@
           <p:cNvPr id="6" name="">
             <a:extLst xmlns:a="http://schemas.openxmlformats.org/drawingml/2006/main">
               <a:ext uri="{FF2B5EF4-FFF2-40B4-BE49-F238E27FC236}">
-                <a16:creationId xmlns:a16="http://schemas.microsoft.com/office/drawing/2014/main" id="{894FF768-AD83-42D4-93EB-EA6E23B6AE33}"/>
+                <a16:creationId xmlns:a16="http://schemas.microsoft.com/office/drawing/2014/main" id="{6348EFC0-ECA9-461A-8459-B8D34956A846}"/>
               </a:ext>
             </a:extLst>
           </p:cNvPr>
@@ -2279,7 +2279,7 @@
           <p:cNvPr id="7" name="">
             <a:extLst xmlns:a="http://schemas.openxmlformats.org/drawingml/2006/main">
               <a:ext uri="{FF2B5EF4-FFF2-40B4-BE49-F238E27FC236}">
-                <a16:creationId xmlns:a16="http://schemas.microsoft.com/office/drawing/2014/main" id="{88641617-B341-470F-9A0C-D285224DF5C2}"/>
+                <a16:creationId xmlns:a16="http://schemas.microsoft.com/office/drawing/2014/main" id="{FF54A811-9730-40F9-9112-C5082E5C3A17}"/>
               </a:ext>
             </a:extLst>
           </p:cNvPr>
@@ -2363,7 +2363,7 @@
           <p:cNvPr id="8" name="">
             <a:extLst xmlns:a="http://schemas.openxmlformats.org/drawingml/2006/main">
               <a:ext uri="{FF2B5EF4-FFF2-40B4-BE49-F238E27FC236}">
-                <a16:creationId xmlns:a16="http://schemas.microsoft.com/office/drawing/2014/main" id="{491FBF08-A8C0-47E1-97C1-E685F8F0A1A8}"/>
+                <a16:creationId xmlns:a16="http://schemas.microsoft.com/office/drawing/2014/main" id="{7DB1C37A-5071-4208-92D0-87A644E5C3EE}"/>
               </a:ext>
             </a:extLst>
           </p:cNvPr>
@@ -2447,7 +2447,7 @@
           <p:cNvPr id="9" name="">
             <a:extLst xmlns:a="http://schemas.openxmlformats.org/drawingml/2006/main">
               <a:ext uri="{FF2B5EF4-FFF2-40B4-BE49-F238E27FC236}">
-                <a16:creationId xmlns:a16="http://schemas.microsoft.com/office/drawing/2014/main" id="{10C6935A-3508-45C4-8A85-A18DCB7D6127}"/>
+                <a16:creationId xmlns:a16="http://schemas.microsoft.com/office/drawing/2014/main" id="{9FFC4BC3-21F0-4957-BD42-950ECA730D58}"/>
               </a:ext>
             </a:extLst>
           </p:cNvPr>
@@ -2699,7 +2699,7 @@
           <p:cNvPr id="16" name="">
             <a:extLst xmlns:a="http://schemas.openxmlformats.org/drawingml/2006/main">
               <a:ext uri="{FF2B5EF4-FFF2-40B4-BE49-F238E27FC236}">
-                <a16:creationId xmlns:a16="http://schemas.microsoft.com/office/drawing/2014/main" id="{787FEF18-BC21-4C46-A717-1955A053A5B3}"/>
+                <a16:creationId xmlns:a16="http://schemas.microsoft.com/office/drawing/2014/main" id="{F1EB8A74-B63C-4C06-93CC-2A0149D24C96}"/>
               </a:ext>
             </a:extLst>
           </p:cNvPr>
@@ -2756,7 +2756,7 @@
           <p:cNvPr id="17" name="">
             <a:extLst xmlns:a="http://schemas.openxmlformats.org/drawingml/2006/main">
               <a:ext uri="{FF2B5EF4-FFF2-40B4-BE49-F238E27FC236}">
-                <a16:creationId xmlns:a16="http://schemas.microsoft.com/office/drawing/2014/main" id="{A160867B-5AFD-4DEC-932A-11BEE9311CE8}"/>
+                <a16:creationId xmlns:a16="http://schemas.microsoft.com/office/drawing/2014/main" id="{CA63E4DF-B91E-42DE-8CC5-6AE6C465E5AF}"/>
               </a:ext>
             </a:extLst>
           </p:cNvPr>
@@ -2811,7 +2811,7 @@
     </p:spTree>
     <p:extLst>
       <p:ext uri="{BB962C8B-B14F-4D97-AF65-F5344CB8AC3E}">
-        <p14:creationId xmlns:p14="http://schemas.microsoft.com/office/powerpoint/2010/main" val="1843487133"/>
+        <p14:creationId xmlns:p14="http://schemas.microsoft.com/office/powerpoint/2010/main" val="1213874065"/>
       </p:ext>
     </p:extLst>
   </p:cSld>
@@ -2842,7 +2842,7 @@
           <p:cNvPr id="13" name="">
             <a:extLst xmlns:a="http://schemas.openxmlformats.org/drawingml/2006/main">
               <a:ext uri="{FF2B5EF4-FFF2-40B4-BE49-F238E27FC236}">
-                <a16:creationId xmlns:a16="http://schemas.microsoft.com/office/drawing/2014/main" id="{D2153BEE-4766-45B8-AC5F-314A46A5CB86}"/>
+                <a16:creationId xmlns:a16="http://schemas.microsoft.com/office/drawing/2014/main" id="{85B17CD4-5E9E-4457-9353-CC63175BDCBD}"/>
               </a:ext>
             </a:extLst>
           </p:cNvPr>
@@ -2899,7 +2899,7 @@
           <p:cNvPr id="2" name="">
             <a:extLst xmlns:a="http://schemas.openxmlformats.org/drawingml/2006/main">
               <a:ext uri="{FF2B5EF4-FFF2-40B4-BE49-F238E27FC236}">
-                <a16:creationId xmlns:a16="http://schemas.microsoft.com/office/drawing/2014/main" id="{6AFCD8AA-876E-477F-B913-2796D2A68C7B}"/>
+                <a16:creationId xmlns:a16="http://schemas.microsoft.com/office/drawing/2014/main" id="{0D0F69CC-72D1-4571-A3A5-3DAFFB28804B}"/>
               </a:ext>
             </a:extLst>
           </p:cNvPr>
@@ -2956,7 +2956,7 @@
           <p:cNvPr id="3" name="">
             <a:extLst xmlns:a="http://schemas.openxmlformats.org/drawingml/2006/main">
               <a:ext uri="{FF2B5EF4-FFF2-40B4-BE49-F238E27FC236}">
-                <a16:creationId xmlns:a16="http://schemas.microsoft.com/office/drawing/2014/main" id="{F0D07AF6-0199-423A-B7EB-1CE2F35F51FB}"/>
+                <a16:creationId xmlns:a16="http://schemas.microsoft.com/office/drawing/2014/main" id="{3440C86D-67D9-4B94-846A-E94D13B2D8ED}"/>
               </a:ext>
             </a:extLst>
           </p:cNvPr>
@@ -3013,7 +3013,7 @@
           <p:cNvPr id="4" name="">
             <a:extLst xmlns:a="http://schemas.openxmlformats.org/drawingml/2006/main">
               <a:ext uri="{FF2B5EF4-FFF2-40B4-BE49-F238E27FC236}">
-                <a16:creationId xmlns:a16="http://schemas.microsoft.com/office/drawing/2014/main" id="{9B5806AC-F31A-48AD-B851-403D33369236}"/>
+                <a16:creationId xmlns:a16="http://schemas.microsoft.com/office/drawing/2014/main" id="{DD76F49D-0840-4C0F-88C0-4E5FA30673D0}"/>
               </a:ext>
             </a:extLst>
           </p:cNvPr>
@@ -3070,7 +3070,7 @@
           <p:cNvPr id="5" name="">
             <a:extLst xmlns:a="http://schemas.openxmlformats.org/drawingml/2006/main">
               <a:ext uri="{FF2B5EF4-FFF2-40B4-BE49-F238E27FC236}">
-                <a16:creationId xmlns:a16="http://schemas.microsoft.com/office/drawing/2014/main" id="{418B74F0-5425-4776-B17E-FFB396F21841}"/>
+                <a16:creationId xmlns:a16="http://schemas.microsoft.com/office/drawing/2014/main" id="{EEF09B64-D96B-4A98-B1A1-1782D3792A5B}"/>
               </a:ext>
             </a:extLst>
           </p:cNvPr>
@@ -3173,7 +3173,7 @@
           <p:cNvPr id="6" name="">
             <a:extLst xmlns:a="http://schemas.openxmlformats.org/drawingml/2006/main">
               <a:ext uri="{FF2B5EF4-FFF2-40B4-BE49-F238E27FC236}">
-                <a16:creationId xmlns:a16="http://schemas.microsoft.com/office/drawing/2014/main" id="{13FD8E38-C40B-406D-BC19-3CD4C710F5A1}"/>
+                <a16:creationId xmlns:a16="http://schemas.microsoft.com/office/drawing/2014/main" id="{AE9EF39C-78F2-432C-87C9-1D1519A36096}"/>
               </a:ext>
             </a:extLst>
           </p:cNvPr>
@@ -3230,7 +3230,7 @@
           <p:cNvPr id="7" name="">
             <a:extLst xmlns:a="http://schemas.openxmlformats.org/drawingml/2006/main">
               <a:ext uri="{FF2B5EF4-FFF2-40B4-BE49-F238E27FC236}">
-                <a16:creationId xmlns:a16="http://schemas.microsoft.com/office/drawing/2014/main" id="{34A59564-F7CD-468D-B168-6E557BF78C89}"/>
+                <a16:creationId xmlns:a16="http://schemas.microsoft.com/office/drawing/2014/main" id="{D4820EFF-AB26-4549-945A-9B7CE26590CB}"/>
               </a:ext>
             </a:extLst>
           </p:cNvPr>
@@ -3287,7 +3287,7 @@
           <p:cNvPr id="8" name="">
             <a:extLst xmlns:a="http://schemas.openxmlformats.org/drawingml/2006/main">
               <a:ext uri="{FF2B5EF4-FFF2-40B4-BE49-F238E27FC236}">
-                <a16:creationId xmlns:a16="http://schemas.microsoft.com/office/drawing/2014/main" id="{A44CA76E-AA79-457A-91CA-049391C0FB9B}"/>
+                <a16:creationId xmlns:a16="http://schemas.microsoft.com/office/drawing/2014/main" id="{A4F36799-4770-4884-936D-5482167FDC95}"/>
               </a:ext>
             </a:extLst>
           </p:cNvPr>
@@ -3344,7 +3344,7 @@
           <p:cNvPr id="9" name="">
             <a:extLst xmlns:a="http://schemas.openxmlformats.org/drawingml/2006/main">
               <a:ext uri="{FF2B5EF4-FFF2-40B4-BE49-F238E27FC236}">
-                <a16:creationId xmlns:a16="http://schemas.microsoft.com/office/drawing/2014/main" id="{6781A426-C8D3-4D1D-8856-6D4A5DF1438B}"/>
+                <a16:creationId xmlns:a16="http://schemas.microsoft.com/office/drawing/2014/main" id="{58FBE2A1-AF1F-46DF-B5AD-9C9DB4AC1C62}"/>
               </a:ext>
             </a:extLst>
           </p:cNvPr>
@@ -3401,7 +3401,7 @@
           <p:cNvPr id="10" name="">
             <a:extLst xmlns:a="http://schemas.openxmlformats.org/drawingml/2006/main">
               <a:ext uri="{FF2B5EF4-FFF2-40B4-BE49-F238E27FC236}">
-                <a16:creationId xmlns:a16="http://schemas.microsoft.com/office/drawing/2014/main" id="{444A5B1C-0538-4A11-9BD9-E2DE1BDE3AC5}"/>
+                <a16:creationId xmlns:a16="http://schemas.microsoft.com/office/drawing/2014/main" id="{60E6FA85-9BE5-4403-BC20-5E40F29958E3}"/>
               </a:ext>
             </a:extLst>
           </p:cNvPr>
@@ -3504,7 +3504,7 @@
           <p:cNvPr id="11" name="">
             <a:extLst xmlns:a="http://schemas.openxmlformats.org/drawingml/2006/main">
               <a:ext uri="{FF2B5EF4-FFF2-40B4-BE49-F238E27FC236}">
-                <a16:creationId xmlns:a16="http://schemas.microsoft.com/office/drawing/2014/main" id="{12776A74-86A8-4634-BEDB-4F129FCC5E91}"/>
+                <a16:creationId xmlns:a16="http://schemas.microsoft.com/office/drawing/2014/main" id="{649589FA-46B7-4FF0-B0DE-D07832EDCBFC}"/>
               </a:ext>
             </a:extLst>
           </p:cNvPr>
@@ -3561,7 +3561,7 @@
           <p:cNvPr id="12" name="">
             <a:extLst xmlns:a="http://schemas.openxmlformats.org/drawingml/2006/main">
               <a:ext uri="{FF2B5EF4-FFF2-40B4-BE49-F238E27FC236}">
-                <a16:creationId xmlns:a16="http://schemas.microsoft.com/office/drawing/2014/main" id="{20041EC0-5D7A-4318-B520-10CA33F0C918}"/>
+                <a16:creationId xmlns:a16="http://schemas.microsoft.com/office/drawing/2014/main" id="{CDD787E1-0070-46E4-9DD1-4D9043B26BA2}"/>
               </a:ext>
             </a:extLst>
           </p:cNvPr>
@@ -3616,7 +3616,7 @@
     </p:spTree>
     <p:extLst>
       <p:ext uri="{BB962C8B-B14F-4D97-AF65-F5344CB8AC3E}">
-        <p14:creationId xmlns:p14="http://schemas.microsoft.com/office/powerpoint/2010/main" val="1053100795"/>
+        <p14:creationId xmlns:p14="http://schemas.microsoft.com/office/powerpoint/2010/main" val="1881011537"/>
       </p:ext>
     </p:extLst>
   </p:cSld>
@@ -3647,7 +3647,7 @@
           <p:cNvPr id="18" name="">
             <a:extLst xmlns:a="http://schemas.openxmlformats.org/drawingml/2006/main">
               <a:ext uri="{FF2B5EF4-FFF2-40B4-BE49-F238E27FC236}">
-                <a16:creationId xmlns:a16="http://schemas.microsoft.com/office/drawing/2014/main" id="{7DB9EF44-BC8A-4D4F-962D-25E97A199BD1}"/>
+                <a16:creationId xmlns:a16="http://schemas.microsoft.com/office/drawing/2014/main" id="{D2E5973C-3688-499D-9368-F1B32918364C}"/>
               </a:ext>
             </a:extLst>
           </p:cNvPr>
@@ -3704,7 +3704,7 @@
           <p:cNvPr id="2" name="">
             <a:extLst xmlns:a="http://schemas.openxmlformats.org/drawingml/2006/main">
               <a:ext uri="{FF2B5EF4-FFF2-40B4-BE49-F238E27FC236}">
-                <a16:creationId xmlns:a16="http://schemas.microsoft.com/office/drawing/2014/main" id="{69B14E4F-1FAC-4E2A-85F9-5DCD2B3EDCA5}"/>
+                <a16:creationId xmlns:a16="http://schemas.microsoft.com/office/drawing/2014/main" id="{D2901C48-3CCF-4888-A06F-7852BE104980}"/>
               </a:ext>
             </a:extLst>
           </p:cNvPr>
@@ -3761,7 +3761,7 @@
           <p:cNvPr id="3" name="">
             <a:extLst xmlns:a="http://schemas.openxmlformats.org/drawingml/2006/main">
               <a:ext uri="{FF2B5EF4-FFF2-40B4-BE49-F238E27FC236}">
-                <a16:creationId xmlns:a16="http://schemas.microsoft.com/office/drawing/2014/main" id="{B7AFE5EE-8333-4F43-8784-22E56B42EB7C}"/>
+                <a16:creationId xmlns:a16="http://schemas.microsoft.com/office/drawing/2014/main" id="{58143E63-B5CF-4F3A-AF9D-490D4509F1A2}"/>
               </a:ext>
             </a:extLst>
           </p:cNvPr>
@@ -3822,7 +3822,7 @@
           <p:cNvPr id="4" name="">
             <a:extLst xmlns:a="http://schemas.openxmlformats.org/drawingml/2006/main">
               <a:ext uri="{FF2B5EF4-FFF2-40B4-BE49-F238E27FC236}">
-                <a16:creationId xmlns:a16="http://schemas.microsoft.com/office/drawing/2014/main" id="{939599BE-F4C0-4C28-A31D-5A088EC46F42}"/>
+                <a16:creationId xmlns:a16="http://schemas.microsoft.com/office/drawing/2014/main" id="{3F3B0B05-92BE-4B03-97D0-876305135DCF}"/>
               </a:ext>
             </a:extLst>
           </p:cNvPr>
@@ -3883,7 +3883,7 @@
           <p:cNvPr id="5" name="">
             <a:extLst xmlns:a="http://schemas.openxmlformats.org/drawingml/2006/main">
               <a:ext uri="{FF2B5EF4-FFF2-40B4-BE49-F238E27FC236}">
-                <a16:creationId xmlns:a16="http://schemas.microsoft.com/office/drawing/2014/main" id="{9A649BE5-1B79-47F2-A6CD-50083D5785B3}"/>
+                <a16:creationId xmlns:a16="http://schemas.microsoft.com/office/drawing/2014/main" id="{BF924540-B415-4338-9E40-664FB5A8CABB}"/>
               </a:ext>
             </a:extLst>
           </p:cNvPr>
@@ -3944,7 +3944,7 @@
           <p:cNvPr id="6" name="">
             <a:extLst xmlns:a="http://schemas.openxmlformats.org/drawingml/2006/main">
               <a:ext uri="{FF2B5EF4-FFF2-40B4-BE49-F238E27FC236}">
-                <a16:creationId xmlns:a16="http://schemas.microsoft.com/office/drawing/2014/main" id="{25B621D2-57AE-4A2E-9FD9-95CA2632486A}"/>
+                <a16:creationId xmlns:a16="http://schemas.microsoft.com/office/drawing/2014/main" id="{89AC28E5-94A9-461D-A07E-C359D10FC4F3}"/>
               </a:ext>
             </a:extLst>
           </p:cNvPr>
@@ -4083,7 +4083,7 @@
           <p:cNvPr id="10" name="">
             <a:extLst xmlns:a="http://schemas.openxmlformats.org/drawingml/2006/main">
               <a:ext uri="{FF2B5EF4-FFF2-40B4-BE49-F238E27FC236}">
-                <a16:creationId xmlns:a16="http://schemas.microsoft.com/office/drawing/2014/main" id="{C3A0A629-3BAB-4829-8C63-8B4C150FE662}"/>
+                <a16:creationId xmlns:a16="http://schemas.microsoft.com/office/drawing/2014/main" id="{73295C0E-993F-4E57-B934-A2B2248C4CC4}"/>
               </a:ext>
             </a:extLst>
           </p:cNvPr>
@@ -4186,7 +4186,7 @@
           <p:cNvPr id="11" name="">
             <a:extLst xmlns:a="http://schemas.openxmlformats.org/drawingml/2006/main">
               <a:ext uri="{FF2B5EF4-FFF2-40B4-BE49-F238E27FC236}">
-                <a16:creationId xmlns:a16="http://schemas.microsoft.com/office/drawing/2014/main" id="{969B75FD-742A-48F4-B445-EBEA23DD3ECB}"/>
+                <a16:creationId xmlns:a16="http://schemas.microsoft.com/office/drawing/2014/main" id="{08C6F166-3B9F-42CA-B4CB-DC874E09EA00}"/>
               </a:ext>
             </a:extLst>
           </p:cNvPr>
@@ -4289,7 +4289,7 @@
           <p:cNvPr id="12" name="">
             <a:extLst xmlns:a="http://schemas.openxmlformats.org/drawingml/2006/main">
               <a:ext uri="{FF2B5EF4-FFF2-40B4-BE49-F238E27FC236}">
-                <a16:creationId xmlns:a16="http://schemas.microsoft.com/office/drawing/2014/main" id="{C2F7D9E1-8AB6-4237-86FD-AFB6F31E3579}"/>
+                <a16:creationId xmlns:a16="http://schemas.microsoft.com/office/drawing/2014/main" id="{110D0641-5261-4118-9D3D-5B9D5A5734A6}"/>
               </a:ext>
             </a:extLst>
           </p:cNvPr>
@@ -4392,7 +4392,7 @@
           <p:cNvPr id="13" name="">
             <a:extLst xmlns:a="http://schemas.openxmlformats.org/drawingml/2006/main">
               <a:ext uri="{FF2B5EF4-FFF2-40B4-BE49-F238E27FC236}">
-                <a16:creationId xmlns:a16="http://schemas.microsoft.com/office/drawing/2014/main" id="{97BF7EA8-A1C4-4C22-B26D-4B2F3F361A12}"/>
+                <a16:creationId xmlns:a16="http://schemas.microsoft.com/office/drawing/2014/main" id="{8B42B45B-2405-4B7D-B0C6-CC5006E4A7DD}"/>
               </a:ext>
             </a:extLst>
           </p:cNvPr>
@@ -4495,7 +4495,7 @@
           <p:cNvPr id="14" name="">
             <a:extLst xmlns:a="http://schemas.openxmlformats.org/drawingml/2006/main">
               <a:ext uri="{FF2B5EF4-FFF2-40B4-BE49-F238E27FC236}">
-                <a16:creationId xmlns:a16="http://schemas.microsoft.com/office/drawing/2014/main" id="{2A77013B-DAD7-4DB2-9E3C-2EBD32A5820C}"/>
+                <a16:creationId xmlns:a16="http://schemas.microsoft.com/office/drawing/2014/main" id="{1FD9F0EF-EB5C-4DBC-92F5-40FBCEB5C8E9}"/>
               </a:ext>
             </a:extLst>
           </p:cNvPr>
@@ -4552,7 +4552,7 @@
           <p:cNvPr id="15" name="">
             <a:extLst xmlns:a="http://schemas.openxmlformats.org/drawingml/2006/main">
               <a:ext uri="{FF2B5EF4-FFF2-40B4-BE49-F238E27FC236}">
-                <a16:creationId xmlns:a16="http://schemas.microsoft.com/office/drawing/2014/main" id="{B0372479-57C4-42AC-9C03-D26CD9346232}"/>
+                <a16:creationId xmlns:a16="http://schemas.microsoft.com/office/drawing/2014/main" id="{93158336-EE73-461F-8031-A27624A0F340}"/>
               </a:ext>
             </a:extLst>
           </p:cNvPr>
@@ -4609,7 +4609,7 @@
           <p:cNvPr id="16" name="">
             <a:extLst xmlns:a="http://schemas.openxmlformats.org/drawingml/2006/main">
               <a:ext uri="{FF2B5EF4-FFF2-40B4-BE49-F238E27FC236}">
-                <a16:creationId xmlns:a16="http://schemas.microsoft.com/office/drawing/2014/main" id="{72010F46-4C0A-4566-9A85-39EB584E16B0}"/>
+                <a16:creationId xmlns:a16="http://schemas.microsoft.com/office/drawing/2014/main" id="{6D43FD18-816A-4397-A534-11058B4EA341}"/>
               </a:ext>
             </a:extLst>
           </p:cNvPr>
@@ -4666,7 +4666,7 @@
           <p:cNvPr id="17" name="">
             <a:extLst xmlns:a="http://schemas.openxmlformats.org/drawingml/2006/main">
               <a:ext uri="{FF2B5EF4-FFF2-40B4-BE49-F238E27FC236}">
-                <a16:creationId xmlns:a16="http://schemas.microsoft.com/office/drawing/2014/main" id="{FEBCD277-BD09-4A0D-B4FC-858A6D4425E5}"/>
+                <a16:creationId xmlns:a16="http://schemas.microsoft.com/office/drawing/2014/main" id="{D930D73C-06E5-4E94-98A8-526C622E8CBC}"/>
               </a:ext>
             </a:extLst>
           </p:cNvPr>
@@ -4721,7 +4721,7 @@
     </p:spTree>
     <p:extLst>
       <p:ext uri="{BB962C8B-B14F-4D97-AF65-F5344CB8AC3E}">
-        <p14:creationId xmlns:p14="http://schemas.microsoft.com/office/powerpoint/2010/main" val="609472238"/>
+        <p14:creationId xmlns:p14="http://schemas.microsoft.com/office/powerpoint/2010/main" val="973305348"/>
       </p:ext>
     </p:extLst>
   </p:cSld>
@@ -4752,7 +4752,7 @@
           <p:cNvPr id="10" name="">
             <a:extLst xmlns:a="http://schemas.openxmlformats.org/drawingml/2006/main">
               <a:ext uri="{FF2B5EF4-FFF2-40B4-BE49-F238E27FC236}">
-                <a16:creationId xmlns:a16="http://schemas.microsoft.com/office/drawing/2014/main" id="{FDC4AAC6-37E0-4C3C-977E-3D4A4A33E9A0}"/>
+                <a16:creationId xmlns:a16="http://schemas.microsoft.com/office/drawing/2014/main" id="{4C051CEF-3C8B-4217-AA5D-7B366535B546}"/>
               </a:ext>
             </a:extLst>
           </p:cNvPr>
@@ -4809,7 +4809,7 @@
           <p:cNvPr id="2" name="">
             <a:extLst xmlns:a="http://schemas.openxmlformats.org/drawingml/2006/main">
               <a:ext uri="{FF2B5EF4-FFF2-40B4-BE49-F238E27FC236}">
-                <a16:creationId xmlns:a16="http://schemas.microsoft.com/office/drawing/2014/main" id="{D50B1D4A-D014-4A2A-9549-1E4064140380}"/>
+                <a16:creationId xmlns:a16="http://schemas.microsoft.com/office/drawing/2014/main" id="{C414DD02-CCBF-4220-A569-E0298726B6AA}"/>
               </a:ext>
             </a:extLst>
           </p:cNvPr>
@@ -4866,7 +4866,7 @@
           <p:cNvPr id="3" name="">
             <a:extLst xmlns:a="http://schemas.openxmlformats.org/drawingml/2006/main">
               <a:ext uri="{FF2B5EF4-FFF2-40B4-BE49-F238E27FC236}">
-                <a16:creationId xmlns:a16="http://schemas.microsoft.com/office/drawing/2014/main" id="{6681EC46-A27E-4239-A01C-A2F8EDDDA6B4}"/>
+                <a16:creationId xmlns:a16="http://schemas.microsoft.com/office/drawing/2014/main" id="{3002D8FA-EFBF-4EFE-A50F-E0606084CCE5}"/>
               </a:ext>
             </a:extLst>
           </p:cNvPr>
@@ -4946,7 +4946,7 @@
           <p:cNvPr id="4" name="">
             <a:extLst xmlns:a="http://schemas.openxmlformats.org/drawingml/2006/main">
               <a:ext uri="{FF2B5EF4-FFF2-40B4-BE49-F238E27FC236}">
-                <a16:creationId xmlns:a16="http://schemas.microsoft.com/office/drawing/2014/main" id="{0D3B1B67-2607-42BC-95EC-7B93A7CEEF03}"/>
+                <a16:creationId xmlns:a16="http://schemas.microsoft.com/office/drawing/2014/main" id="{D575A1AA-C3F6-489F-A0CB-9A4C75EF6214}"/>
               </a:ext>
             </a:extLst>
           </p:cNvPr>
@@ -5049,7 +5049,7 @@
           <p:cNvPr id="5" name="">
             <a:extLst xmlns:a="http://schemas.openxmlformats.org/drawingml/2006/main">
               <a:ext uri="{FF2B5EF4-FFF2-40B4-BE49-F238E27FC236}">
-                <a16:creationId xmlns:a16="http://schemas.microsoft.com/office/drawing/2014/main" id="{76300A18-AC55-40EF-96C7-1AB978C60293}"/>
+                <a16:creationId xmlns:a16="http://schemas.microsoft.com/office/drawing/2014/main" id="{99F58F3E-07CA-4768-88E9-6249A6EB9C34}"/>
               </a:ext>
             </a:extLst>
           </p:cNvPr>
@@ -5106,7 +5106,7 @@
           <p:cNvPr id="6" name="">
             <a:extLst xmlns:a="http://schemas.openxmlformats.org/drawingml/2006/main">
               <a:ext uri="{FF2B5EF4-FFF2-40B4-BE49-F238E27FC236}">
-                <a16:creationId xmlns:a16="http://schemas.microsoft.com/office/drawing/2014/main" id="{9FAE2DDD-9B7E-4AFA-A94E-7CD706A633E0}"/>
+                <a16:creationId xmlns:a16="http://schemas.microsoft.com/office/drawing/2014/main" id="{D2017483-51E6-471B-A064-B435628821C7}"/>
               </a:ext>
             </a:extLst>
           </p:cNvPr>
@@ -5163,7 +5163,7 @@
           <p:cNvPr id="7" name="">
             <a:extLst xmlns:a="http://schemas.openxmlformats.org/drawingml/2006/main">
               <a:ext uri="{FF2B5EF4-FFF2-40B4-BE49-F238E27FC236}">
-                <a16:creationId xmlns:a16="http://schemas.microsoft.com/office/drawing/2014/main" id="{31E815E4-4594-498B-B649-97A97FD00F81}"/>
+                <a16:creationId xmlns:a16="http://schemas.microsoft.com/office/drawing/2014/main" id="{5D61692E-E0F2-4F75-8D0B-7B0994FDFAC7}"/>
               </a:ext>
             </a:extLst>
           </p:cNvPr>
@@ -5243,7 +5243,7 @@
           <p:cNvPr id="8" name="">
             <a:extLst xmlns:a="http://schemas.openxmlformats.org/drawingml/2006/main">
               <a:ext uri="{FF2B5EF4-FFF2-40B4-BE49-F238E27FC236}">
-                <a16:creationId xmlns:a16="http://schemas.microsoft.com/office/drawing/2014/main" id="{31BD49C8-9968-4EFC-AD40-E695D86FDBDC}"/>
+                <a16:creationId xmlns:a16="http://schemas.microsoft.com/office/drawing/2014/main" id="{A7DE75E5-72C8-45CD-BA67-A020C99C114D}"/>
               </a:ext>
             </a:extLst>
           </p:cNvPr>
@@ -5300,7 +5300,7 @@
           <p:cNvPr id="9" name="">
             <a:extLst xmlns:a="http://schemas.openxmlformats.org/drawingml/2006/main">
               <a:ext uri="{FF2B5EF4-FFF2-40B4-BE49-F238E27FC236}">
-                <a16:creationId xmlns:a16="http://schemas.microsoft.com/office/drawing/2014/main" id="{686A8D72-171F-4EF6-9E5D-9F0DB942737B}"/>
+                <a16:creationId xmlns:a16="http://schemas.microsoft.com/office/drawing/2014/main" id="{786BCED1-1C4C-4E28-90D3-C287891808D2}"/>
               </a:ext>
             </a:extLst>
           </p:cNvPr>
@@ -5355,7 +5355,7 @@
     </p:spTree>
     <p:extLst>
       <p:ext uri="{BB962C8B-B14F-4D97-AF65-F5344CB8AC3E}">
-        <p14:creationId xmlns:p14="http://schemas.microsoft.com/office/powerpoint/2010/main" val="1070336842"/>
+        <p14:creationId xmlns:p14="http://schemas.microsoft.com/office/powerpoint/2010/main" val="1827243853"/>
       </p:ext>
     </p:extLst>
   </p:cSld>
@@ -5386,7 +5386,7 @@
           <p:cNvPr id="10" name="">
             <a:extLst xmlns:a="http://schemas.openxmlformats.org/drawingml/2006/main">
               <a:ext uri="{FF2B5EF4-FFF2-40B4-BE49-F238E27FC236}">
-                <a16:creationId xmlns:a16="http://schemas.microsoft.com/office/drawing/2014/main" id="{3B9539AE-5395-4CEF-B2A3-3D0BC63DE54F}"/>
+                <a16:creationId xmlns:a16="http://schemas.microsoft.com/office/drawing/2014/main" id="{A6DAA47B-90D1-448D-B122-DFEEC5D4DE34}"/>
               </a:ext>
             </a:extLst>
           </p:cNvPr>
@@ -5443,7 +5443,7 @@
           <p:cNvPr id="2" name="">
             <a:extLst xmlns:a="http://schemas.openxmlformats.org/drawingml/2006/main">
               <a:ext uri="{FF2B5EF4-FFF2-40B4-BE49-F238E27FC236}">
-                <a16:creationId xmlns:a16="http://schemas.microsoft.com/office/drawing/2014/main" id="{FF25F875-AD37-4B5A-9940-E949B3D2B77F}"/>
+                <a16:creationId xmlns:a16="http://schemas.microsoft.com/office/drawing/2014/main" id="{24AA1BEC-E585-4EC5-92AC-8AFC02171FEC}"/>
               </a:ext>
             </a:extLst>
           </p:cNvPr>
@@ -5500,7 +5500,7 @@
           <p:cNvPr id="3" name="">
             <a:extLst xmlns:a="http://schemas.openxmlformats.org/drawingml/2006/main">
               <a:ext uri="{FF2B5EF4-FFF2-40B4-BE49-F238E27FC236}">
-                <a16:creationId xmlns:a16="http://schemas.microsoft.com/office/drawing/2014/main" id="{645B738D-5331-46DB-BBFC-AFC7A9F52E35}"/>
+                <a16:creationId xmlns:a16="http://schemas.microsoft.com/office/drawing/2014/main" id="{C9BE9750-FD1F-405A-820E-6F7F3C6B4908}"/>
               </a:ext>
             </a:extLst>
           </p:cNvPr>
@@ -5557,7 +5557,7 @@
           <p:cNvPr id="4" name="">
             <a:extLst xmlns:a="http://schemas.openxmlformats.org/drawingml/2006/main">
               <a:ext uri="{FF2B5EF4-FFF2-40B4-BE49-F238E27FC236}">
-                <a16:creationId xmlns:a16="http://schemas.microsoft.com/office/drawing/2014/main" id="{CFD05328-AD9E-4CA3-ACF4-5BDB6F67EA18}"/>
+                <a16:creationId xmlns:a16="http://schemas.microsoft.com/office/drawing/2014/main" id="{68FE42BB-3BE8-4693-B223-6F63D4018952}"/>
               </a:ext>
             </a:extLst>
           </p:cNvPr>
@@ -5627,7 +5627,7 @@
                 <a:ea typeface="Helvetica Neue"/>
                 <a:cs typeface="Helvetica Neue"/>
               </a:rPr>
-              <a:t>58 hosted API checks</a:t>
+              <a:t>60 hosted API checks</a:t>
             </a:r>
           </a:p>
           <a:p xmlns:a="http://schemas.openxmlformats.org/drawingml/2006/main">
@@ -5660,7 +5660,7 @@
           <p:cNvPr id="5" name="">
             <a:extLst xmlns:a="http://schemas.openxmlformats.org/drawingml/2006/main">
               <a:ext uri="{FF2B5EF4-FFF2-40B4-BE49-F238E27FC236}">
-                <a16:creationId xmlns:a16="http://schemas.microsoft.com/office/drawing/2014/main" id="{6FC2BD4B-4558-4C1E-A6A6-D670BCA69CB9}"/>
+                <a16:creationId xmlns:a16="http://schemas.microsoft.com/office/drawing/2014/main" id="{F8509155-3F78-42DB-833C-EC2FAE9958AB}"/>
               </a:ext>
             </a:extLst>
           </p:cNvPr>
@@ -5717,7 +5717,7 @@
           <p:cNvPr id="6" name="">
             <a:extLst xmlns:a="http://schemas.openxmlformats.org/drawingml/2006/main">
               <a:ext uri="{FF2B5EF4-FFF2-40B4-BE49-F238E27FC236}">
-                <a16:creationId xmlns:a16="http://schemas.microsoft.com/office/drawing/2014/main" id="{0215B353-076A-468C-A226-724BDE750F3B}"/>
+                <a16:creationId xmlns:a16="http://schemas.microsoft.com/office/drawing/2014/main" id="{3D0ED9BB-D0CC-4B5C-913A-AEB5FBC702E4}"/>
               </a:ext>
             </a:extLst>
           </p:cNvPr>
@@ -5843,7 +5843,7 @@
           <p:cNvPr id="7" name="">
             <a:extLst xmlns:a="http://schemas.openxmlformats.org/drawingml/2006/main">
               <a:ext uri="{FF2B5EF4-FFF2-40B4-BE49-F238E27FC236}">
-                <a16:creationId xmlns:a16="http://schemas.microsoft.com/office/drawing/2014/main" id="{D0605519-B711-482A-B732-7904F2EE6392}"/>
+                <a16:creationId xmlns:a16="http://schemas.microsoft.com/office/drawing/2014/main" id="{888CE4C2-3C73-463A-B048-1F14B74ED33E}"/>
               </a:ext>
             </a:extLst>
           </p:cNvPr>
@@ -5900,7 +5900,7 @@
           <p:cNvPr id="8" name="">
             <a:extLst xmlns:a="http://schemas.openxmlformats.org/drawingml/2006/main">
               <a:ext uri="{FF2B5EF4-FFF2-40B4-BE49-F238E27FC236}">
-                <a16:creationId xmlns:a16="http://schemas.microsoft.com/office/drawing/2014/main" id="{738837BB-330C-42D8-AB66-A2A455BADD10}"/>
+                <a16:creationId xmlns:a16="http://schemas.microsoft.com/office/drawing/2014/main" id="{67D54B67-AFF5-4F26-A408-607EF83512BE}"/>
               </a:ext>
             </a:extLst>
           </p:cNvPr>
@@ -5957,7 +5957,7 @@
           <p:cNvPr id="9" name="">
             <a:extLst xmlns:a="http://schemas.openxmlformats.org/drawingml/2006/main">
               <a:ext uri="{FF2B5EF4-FFF2-40B4-BE49-F238E27FC236}">
-                <a16:creationId xmlns:a16="http://schemas.microsoft.com/office/drawing/2014/main" id="{1AB3AC7E-8A19-4889-9A6C-9CE3E0356898}"/>
+                <a16:creationId xmlns:a16="http://schemas.microsoft.com/office/drawing/2014/main" id="{F9E9E1D1-16AA-447D-A8B3-B6203F4AC228}"/>
               </a:ext>
             </a:extLst>
           </p:cNvPr>
@@ -6012,7 +6012,7 @@
     </p:spTree>
     <p:extLst>
       <p:ext uri="{BB962C8B-B14F-4D97-AF65-F5344CB8AC3E}">
-        <p14:creationId xmlns:p14="http://schemas.microsoft.com/office/powerpoint/2010/main" val="289799701"/>
+        <p14:creationId xmlns:p14="http://schemas.microsoft.com/office/powerpoint/2010/main" val="655139555"/>
       </p:ext>
     </p:extLst>
   </p:cSld>

</xml_diff>

<commit_message>
Verify live Nebius inference and publish final demo
</commit_message>
<xml_diff>
--- a/docs/pitch/RecallRoom-pitch.pptx
+++ b/docs/pitch/RecallRoom-pitch.pptx
@@ -2,18 +2,18 @@
 <file path=ppt/presentation.xml><?xml version="1.0" encoding="utf-8"?>
 <p:presentation xmlns:p="http://schemas.openxmlformats.org/presentationml/2006/main">
   <p:sldMasterIdLst>
-    <p:sldMasterId xmlns:r="http://schemas.openxmlformats.org/officeDocument/2006/relationships" id="2147483648" r:id="R4c8f035dc7ce4f66"/>
+    <p:sldMasterId xmlns:r="http://schemas.openxmlformats.org/officeDocument/2006/relationships" id="2147483648" r:id="R5a56386669b4413e"/>
   </p:sldMasterIdLst>
   <p:notesMasterIdLst>
-    <p:notesMasterId xmlns:r="http://schemas.openxmlformats.org/officeDocument/2006/relationships" r:id="Rb9e8d2760fbc480e"/>
+    <p:notesMasterId xmlns:r="http://schemas.openxmlformats.org/officeDocument/2006/relationships" r:id="R482f664035c24d22"/>
   </p:notesMasterIdLst>
   <p:sldIdLst>
-    <p:sldId xmlns:r="http://schemas.openxmlformats.org/officeDocument/2006/relationships" id="256" r:id="Ra4a3300759d244f6"/>
-    <p:sldId xmlns:r="http://schemas.openxmlformats.org/officeDocument/2006/relationships" id="257" r:id="R14232779f62042d3"/>
-    <p:sldId xmlns:r="http://schemas.openxmlformats.org/officeDocument/2006/relationships" id="258" r:id="R21eb88db50e249de"/>
-    <p:sldId xmlns:r="http://schemas.openxmlformats.org/officeDocument/2006/relationships" id="259" r:id="Rb2c3ddec8ae14c01"/>
-    <p:sldId xmlns:r="http://schemas.openxmlformats.org/officeDocument/2006/relationships" id="260" r:id="Rfb305191cf474d3e"/>
-    <p:sldId xmlns:r="http://schemas.openxmlformats.org/officeDocument/2006/relationships" id="261" r:id="R64b61bca15ed4b5e"/>
+    <p:sldId xmlns:r="http://schemas.openxmlformats.org/officeDocument/2006/relationships" id="256" r:id="Rcdcab7065fdc4027"/>
+    <p:sldId xmlns:r="http://schemas.openxmlformats.org/officeDocument/2006/relationships" id="257" r:id="R6879b5dad3974e44"/>
+    <p:sldId xmlns:r="http://schemas.openxmlformats.org/officeDocument/2006/relationships" id="258" r:id="R3c2ebe8760624ddd"/>
+    <p:sldId xmlns:r="http://schemas.openxmlformats.org/officeDocument/2006/relationships" id="259" r:id="R64f43d310a994180"/>
+    <p:sldId xmlns:r="http://schemas.openxmlformats.org/officeDocument/2006/relationships" id="260" r:id="R494033216cc24839"/>
+    <p:sldId xmlns:r="http://schemas.openxmlformats.org/officeDocument/2006/relationships" id="261" r:id="Rf883c38a4c784d66"/>
   </p:sldIdLst>
   <p:sldSz cx="12192000" cy="6858000"/>
   <p:notesSz cx="6858000" cy="9144000"/>
@@ -447,7 +447,7 @@
           <a:lstStyle xmlns:a="http://schemas.openxmlformats.org/drawingml/2006/main"/>
           <a:p xmlns:a="http://schemas.openxmlformats.org/drawingml/2006/main">
             <a:r>
-              <a:t>RecallRoom was created by Shivam Gupta with AI-assisted research, implementation, testing, and documentation. This deck describes the Firebase MVP and synthetic demonstration. Public demo: https://recallroom.web.app . Live NVIDIA Nemotron execution through Nebius Token Factory is pending a credential. No customer results or live model performance measurements are claimed.</a:t>
+              <a:t>RecallRoom was created by Shivam Gupta with AI-assisted research, implementation, testing, and documentation. This deck describes the Firebase MVP and synthetic demonstration. Public demo: https://recallroom.web.app . Real NVIDIA Nemotron 3 Super execution through Nebius Token Factory passed the six-file hosted synthetic workflow. The trace records 17.562 seconds, 2600 input plus 4203 output tokens and an estimated $0.0045627 inference cost. One synthetic fixture does not establish real-world recall accuracy. No customer results are claimed.</a:t>
             </a:r>
           </a:p>
         </p:txBody>
@@ -657,7 +657,7 @@
           <a:lstStyle xmlns:a="http://schemas.openxmlformats.org/drawingml/2006/main"/>
           <a:p xmlns:a="http://schemas.openxmlformats.org/drawingml/2006/main">
             <a:r>
-              <a:t>The active deployment uses Firebase Hosting and Firebase Authentication, with server-verified Google or email/password identities. A Cloud Run API controls owner-scoped Firestore investigations and private Google Cloud Storage originals. Cloud Tasks dispatches authenticated background extraction. The NVIDIA Nemotron adapter targets Nebius Token Factory and remains unverified against a live NVIDIA model. Text, CSV, JSON and selectable-text PDFs are supported. A reviewer must compare browser-extracted PDF text with the original. The app validates schema, exact quotations, references, cycles, units and balances, computes deterministic scope and ranges, and preserves reviewed decisions. Customer drafts remain unsent. Sources: repository README.md, docs/architecture.md and docs/STATUS.md for this Firebase release. Public demo: https://recallroom.web.app .</a:t>
+              <a:t>The active deployment uses Firebase Hosting and Firebase Authentication, with server-verified Google or email/password identities. A Cloud Run API controls owner-scoped Firestore investigations and private Google Cloud Storage originals. Cloud Tasks dispatches authenticated background extraction. NVIDIA Nemotron 3 Super on Nebius Token Factory passed the six-file hosted synthetic workflow. Model ID: nvidia/nemotron-3-super-120b-a12b. Latency: 17.562 seconds. Usage: 2600 input and 4203 output tokens. Estimated inference cost: $0.0045627, excluding app infrastructure and review. All five scope totals matched, with no validation issues. A second UUID/PDF variant passed in 42.923 seconds with 1611 input and 4641 output tokens, estimated cost $0.0046602. Earlier incomplete attempts were not imported and prompted coverage checks. The small fictional scenario does not establish typical latency or real-world accuracy. Hosted evidence: docs/evaluation/hosted-nebius.json. Final adapter sends ordinary chat with the exact schema in the prompt and strict server JSON/Zod/evidence/coverage validation. It does not use provider response_format constraints. Hosted records were reviewed and imported, persisted after reload, and exported with source hashes and two quoted decisions. Text, CSV, JSON and selectable-text PDFs are supported. A reviewer must compare browser-extracted PDF text with the original. The app validates schema, exact quotations, references, cycles, units and balances, computes deterministic scope and ranges, and preserves reviewed decisions. Customer drafts remain unsent. Sources: repository README.md, docs/architecture.md and docs/STATUS.md for this Firebase release. Public demo: https://recallroom.web.app .</a:t>
             </a:r>
           </a:p>
         </p:txBody>
@@ -797,7 +797,7 @@
           <a:lstStyle xmlns:a="http://schemas.openxmlformats.org/drawingml/2006/main"/>
           <a:p xmlns:a="http://schemas.openxmlformats.org/drawingml/2006/main">
             <a:r>
-              <a:t>Public demo: https://recallroom.web.app . Repository: https://github.com/shi1720/Nebius-x-NVIDIA . Application verification: 37 automated tests, 60 hosted Firebase API checks and 10 operator checks against production Firestore functions. Hosted API checks use real disposable Firebase accounts and synthetic records. Operator checks do not enqueue inference. Provider contracts use mocks. These results do not prove live NVIDIA inference, customer value, or real-world recall accuracy. Sources: docs/STATUS.md, docs/evaluation/firebase-api.json and docs/evaluation/firebase-operator.json. Founder/project creator credit: Shivam Gupta. AI assistance covered research, implementation, testing, and documentation; no additional personal actions or external validation are invented. Submission requires verified use of an NVIDIA open-source model on Nebius Token Factory or Nebius AI Cloud, a working public demo, public repository with license, and a public demo video at most three minutes with audio naming the provider and model. This deck is an honest MVP pitch, not a claim of readiness for real incident reliance.</a:t>
+              <a:t>Public demo: https://recallroom.web.app . Repository: https://github.com/shi1720/Nebius-x-NVIDIA . Application verification: 41 automated tests, 60 hosted Firebase API checks and 10 operator checks against production Firestore functions. Hosted API checks use real disposable Firebase accounts and synthetic records. Operator checks do not enqueue inference. Provider contracts use mocks. These application tests are separate from the real NVIDIA evaluation, which passed sunward-v1 with exact expected scope totals. See docs/evaluation/hosted-nebius.json for actual hosted review, import, reload and export. Neither the application tests nor a single synthetic fixture proves customer value or real-world recall accuracy. Sources: docs/STATUS.md, docs/evaluation/firebase-api.json and docs/evaluation/firebase-operator.json. Founder/project creator credit: Shivam Gupta. AI assistance covered research, implementation, testing, and documentation; no additional personal actions or external validation are invented. Submission requires verified use of an NVIDIA open-source model on Nebius Token Factory or Nebius AI Cloud, a working public demo, public repository with license, and a public demo video at most three minutes with audio naming the provider and model. This deck is an honest MVP pitch, not a claim of readiness for real incident reliance.</a:t>
             </a:r>
           </a:p>
         </p:txBody>
@@ -865,7 +865,7 @@
   </p:cSld>
   <p:clrMap bg1="lt1" tx1="dk1" bg2="lt2" tx2="dk2" accent1="accent1" accent2="accent2" accent3="accent3" accent4="accent4" accent5="accent5" accent6="accent6" hlink="hlink" folHlink="folHlink"/>
   <p:sldLayoutIdLst>
-    <p:sldLayoutId xmlns:r="http://schemas.openxmlformats.org/officeDocument/2006/relationships" id="2147483649" r:id="R140e9665b3e54076"/>
+    <p:sldLayoutId xmlns:r="http://schemas.openxmlformats.org/officeDocument/2006/relationships" id="2147483649" r:id="R15b7d5b06f3747a9"/>
   </p:sldLayoutIdLst>
   <p:txStyles>
     <p:titleStyle>
@@ -1416,7 +1416,7 @@
           <p:cNvPr id="7" name="">
             <a:extLst xmlns:a="http://schemas.openxmlformats.org/drawingml/2006/main">
               <a:ext uri="{FF2B5EF4-FFF2-40B4-BE49-F238E27FC236}">
-                <a16:creationId xmlns:a16="http://schemas.microsoft.com/office/drawing/2014/main" id="{D4007EDD-433D-45C7-B674-D7DB99946AE1}"/>
+                <a16:creationId xmlns:a16="http://schemas.microsoft.com/office/drawing/2014/main" id="{30C73DCB-E574-4349-88D1-05437336D28B}"/>
               </a:ext>
             </a:extLst>
           </p:cNvPr>
@@ -1473,7 +1473,7 @@
           <p:cNvPr id="2" name="">
             <a:extLst xmlns:a="http://schemas.openxmlformats.org/drawingml/2006/main">
               <a:ext uri="{FF2B5EF4-FFF2-40B4-BE49-F238E27FC236}">
-                <a16:creationId xmlns:a16="http://schemas.microsoft.com/office/drawing/2014/main" id="{95B508B4-51F3-43A1-83B5-153788E6D778}"/>
+                <a16:creationId xmlns:a16="http://schemas.microsoft.com/office/drawing/2014/main" id="{4C32DD52-686F-42D7-8CC4-522143A932AE}"/>
               </a:ext>
             </a:extLst>
           </p:cNvPr>
@@ -1553,7 +1553,7 @@
           <p:cNvPr id="3" name="">
             <a:extLst xmlns:a="http://schemas.openxmlformats.org/drawingml/2006/main">
               <a:ext uri="{FF2B5EF4-FFF2-40B4-BE49-F238E27FC236}">
-                <a16:creationId xmlns:a16="http://schemas.microsoft.com/office/drawing/2014/main" id="{3D65BDBC-CAEC-4E1B-B95C-58CA64482364}"/>
+                <a16:creationId xmlns:a16="http://schemas.microsoft.com/office/drawing/2014/main" id="{6F57F756-1F17-4EF4-815D-491CBB2030DC}"/>
               </a:ext>
             </a:extLst>
           </p:cNvPr>
@@ -1610,7 +1610,7 @@
           <p:cNvPr id="4" name="">
             <a:extLst xmlns:a="http://schemas.openxmlformats.org/drawingml/2006/main">
               <a:ext uri="{FF2B5EF4-FFF2-40B4-BE49-F238E27FC236}">
-                <a16:creationId xmlns:a16="http://schemas.microsoft.com/office/drawing/2014/main" id="{C0613749-5165-43D8-8FBB-852B75082E7A}"/>
+                <a16:creationId xmlns:a16="http://schemas.microsoft.com/office/drawing/2014/main" id="{AAAD7489-720E-4D2A-94DA-3A5F6335BE0F}"/>
               </a:ext>
             </a:extLst>
           </p:cNvPr>
@@ -1667,7 +1667,7 @@
           <p:cNvPr id="5" name="">
             <a:extLst xmlns:a="http://schemas.openxmlformats.org/drawingml/2006/main">
               <a:ext uri="{FF2B5EF4-FFF2-40B4-BE49-F238E27FC236}">
-                <a16:creationId xmlns:a16="http://schemas.microsoft.com/office/drawing/2014/main" id="{F9846826-FB28-424A-9B30-31381F316C45}"/>
+                <a16:creationId xmlns:a16="http://schemas.microsoft.com/office/drawing/2014/main" id="{C6525D3A-0FF1-4299-BC55-25EF51F59879}"/>
               </a:ext>
             </a:extLst>
           </p:cNvPr>
@@ -1747,7 +1747,7 @@
           <p:cNvPr id="6" name="">
             <a:extLst xmlns:a="http://schemas.openxmlformats.org/drawingml/2006/main">
               <a:ext uri="{FF2B5EF4-FFF2-40B4-BE49-F238E27FC236}">
-                <a16:creationId xmlns:a16="http://schemas.microsoft.com/office/drawing/2014/main" id="{4AD7187A-2FB2-4A18-A599-AA6C3F14D37C}"/>
+                <a16:creationId xmlns:a16="http://schemas.microsoft.com/office/drawing/2014/main" id="{CE80CE26-F317-48E9-ACC2-222CD97DA9EA}"/>
               </a:ext>
             </a:extLst>
           </p:cNvPr>
@@ -1825,7 +1825,7 @@
     </p:spTree>
     <p:extLst>
       <p:ext uri="{BB962C8B-B14F-4D97-AF65-F5344CB8AC3E}">
-        <p14:creationId xmlns:p14="http://schemas.microsoft.com/office/powerpoint/2010/main" val="292797611"/>
+        <p14:creationId xmlns:p14="http://schemas.microsoft.com/office/powerpoint/2010/main" val="1064833669"/>
       </p:ext>
     </p:extLst>
   </p:cSld>
@@ -1856,7 +1856,7 @@
           <p:cNvPr id="18" name="">
             <a:extLst xmlns:a="http://schemas.openxmlformats.org/drawingml/2006/main">
               <a:ext uri="{FF2B5EF4-FFF2-40B4-BE49-F238E27FC236}">
-                <a16:creationId xmlns:a16="http://schemas.microsoft.com/office/drawing/2014/main" id="{1B4C0368-C5EA-4C72-B000-8F1C341E3187}"/>
+                <a16:creationId xmlns:a16="http://schemas.microsoft.com/office/drawing/2014/main" id="{51BDE0A6-0DC2-4A3A-8BD5-FA0B91BEF301}"/>
               </a:ext>
             </a:extLst>
           </p:cNvPr>
@@ -1913,7 +1913,7 @@
           <p:cNvPr id="2" name="">
             <a:extLst xmlns:a="http://schemas.openxmlformats.org/drawingml/2006/main">
               <a:ext uri="{FF2B5EF4-FFF2-40B4-BE49-F238E27FC236}">
-                <a16:creationId xmlns:a16="http://schemas.microsoft.com/office/drawing/2014/main" id="{FE53455A-02FB-4733-B7E2-C3D373D63417}"/>
+                <a16:creationId xmlns:a16="http://schemas.microsoft.com/office/drawing/2014/main" id="{47FBAEF1-0AA1-49A3-AD2E-EDE2F2FDAACE}"/>
               </a:ext>
             </a:extLst>
           </p:cNvPr>
@@ -1970,7 +1970,7 @@
           <p:cNvPr id="3" name="">
             <a:extLst xmlns:a="http://schemas.openxmlformats.org/drawingml/2006/main">
               <a:ext uri="{FF2B5EF4-FFF2-40B4-BE49-F238E27FC236}">
-                <a16:creationId xmlns:a16="http://schemas.microsoft.com/office/drawing/2014/main" id="{53C0B9F0-62A7-41A7-BC90-EEE2D55D8B71}"/>
+                <a16:creationId xmlns:a16="http://schemas.microsoft.com/office/drawing/2014/main" id="{3CBA955B-2493-4B8A-9D3D-54412360947F}"/>
               </a:ext>
             </a:extLst>
           </p:cNvPr>
@@ -2027,7 +2027,7 @@
           <p:cNvPr id="4" name="">
             <a:extLst xmlns:a="http://schemas.openxmlformats.org/drawingml/2006/main">
               <a:ext uri="{FF2B5EF4-FFF2-40B4-BE49-F238E27FC236}">
-                <a16:creationId xmlns:a16="http://schemas.microsoft.com/office/drawing/2014/main" id="{4B881104-82E7-4B5E-8E98-A95DF3A811B7}"/>
+                <a16:creationId xmlns:a16="http://schemas.microsoft.com/office/drawing/2014/main" id="{793693A1-D281-4B7C-B742-08FC3BDBB7ED}"/>
               </a:ext>
             </a:extLst>
           </p:cNvPr>
@@ -2111,7 +2111,7 @@
           <p:cNvPr id="5" name="">
             <a:extLst xmlns:a="http://schemas.openxmlformats.org/drawingml/2006/main">
               <a:ext uri="{FF2B5EF4-FFF2-40B4-BE49-F238E27FC236}">
-                <a16:creationId xmlns:a16="http://schemas.microsoft.com/office/drawing/2014/main" id="{D7BC225F-87D8-4107-B53F-C4DBD9FB00EF}"/>
+                <a16:creationId xmlns:a16="http://schemas.microsoft.com/office/drawing/2014/main" id="{4219E5BD-9719-4F62-8898-FEB522471776}"/>
               </a:ext>
             </a:extLst>
           </p:cNvPr>
@@ -2195,7 +2195,7 @@
           <p:cNvPr id="6" name="">
             <a:extLst xmlns:a="http://schemas.openxmlformats.org/drawingml/2006/main">
               <a:ext uri="{FF2B5EF4-FFF2-40B4-BE49-F238E27FC236}">
-                <a16:creationId xmlns:a16="http://schemas.microsoft.com/office/drawing/2014/main" id="{6348EFC0-ECA9-461A-8459-B8D34956A846}"/>
+                <a16:creationId xmlns:a16="http://schemas.microsoft.com/office/drawing/2014/main" id="{3421C76A-CFD1-4998-8800-EDEDC886C1AD}"/>
               </a:ext>
             </a:extLst>
           </p:cNvPr>
@@ -2279,7 +2279,7 @@
           <p:cNvPr id="7" name="">
             <a:extLst xmlns:a="http://schemas.openxmlformats.org/drawingml/2006/main">
               <a:ext uri="{FF2B5EF4-FFF2-40B4-BE49-F238E27FC236}">
-                <a16:creationId xmlns:a16="http://schemas.microsoft.com/office/drawing/2014/main" id="{FF54A811-9730-40F9-9112-C5082E5C3A17}"/>
+                <a16:creationId xmlns:a16="http://schemas.microsoft.com/office/drawing/2014/main" id="{6C1C7209-A47D-41B3-9D13-BE60F76C0053}"/>
               </a:ext>
             </a:extLst>
           </p:cNvPr>
@@ -2363,7 +2363,7 @@
           <p:cNvPr id="8" name="">
             <a:extLst xmlns:a="http://schemas.openxmlformats.org/drawingml/2006/main">
               <a:ext uri="{FF2B5EF4-FFF2-40B4-BE49-F238E27FC236}">
-                <a16:creationId xmlns:a16="http://schemas.microsoft.com/office/drawing/2014/main" id="{7DB1C37A-5071-4208-92D0-87A644E5C3EE}"/>
+                <a16:creationId xmlns:a16="http://schemas.microsoft.com/office/drawing/2014/main" id="{573D51E2-A950-479A-972F-8D677A8ABBFE}"/>
               </a:ext>
             </a:extLst>
           </p:cNvPr>
@@ -2447,7 +2447,7 @@
           <p:cNvPr id="9" name="">
             <a:extLst xmlns:a="http://schemas.openxmlformats.org/drawingml/2006/main">
               <a:ext uri="{FF2B5EF4-FFF2-40B4-BE49-F238E27FC236}">
-                <a16:creationId xmlns:a16="http://schemas.microsoft.com/office/drawing/2014/main" id="{9FFC4BC3-21F0-4957-BD42-950ECA730D58}"/>
+                <a16:creationId xmlns:a16="http://schemas.microsoft.com/office/drawing/2014/main" id="{C9645D90-9C01-4B7A-83D0-9F6351203F70}"/>
               </a:ext>
             </a:extLst>
           </p:cNvPr>
@@ -2699,7 +2699,7 @@
           <p:cNvPr id="16" name="">
             <a:extLst xmlns:a="http://schemas.openxmlformats.org/drawingml/2006/main">
               <a:ext uri="{FF2B5EF4-FFF2-40B4-BE49-F238E27FC236}">
-                <a16:creationId xmlns:a16="http://schemas.microsoft.com/office/drawing/2014/main" id="{F1EB8A74-B63C-4C06-93CC-2A0149D24C96}"/>
+                <a16:creationId xmlns:a16="http://schemas.microsoft.com/office/drawing/2014/main" id="{1A295E02-B04C-438A-BB13-8A888E6734D3}"/>
               </a:ext>
             </a:extLst>
           </p:cNvPr>
@@ -2756,7 +2756,7 @@
           <p:cNvPr id="17" name="">
             <a:extLst xmlns:a="http://schemas.openxmlformats.org/drawingml/2006/main">
               <a:ext uri="{FF2B5EF4-FFF2-40B4-BE49-F238E27FC236}">
-                <a16:creationId xmlns:a16="http://schemas.microsoft.com/office/drawing/2014/main" id="{CA63E4DF-B91E-42DE-8CC5-6AE6C465E5AF}"/>
+                <a16:creationId xmlns:a16="http://schemas.microsoft.com/office/drawing/2014/main" id="{D2E1DFEA-843E-4AEF-840E-28AAD18DA5A5}"/>
               </a:ext>
             </a:extLst>
           </p:cNvPr>
@@ -2811,7 +2811,7 @@
     </p:spTree>
     <p:extLst>
       <p:ext uri="{BB962C8B-B14F-4D97-AF65-F5344CB8AC3E}">
-        <p14:creationId xmlns:p14="http://schemas.microsoft.com/office/powerpoint/2010/main" val="1213874065"/>
+        <p14:creationId xmlns:p14="http://schemas.microsoft.com/office/powerpoint/2010/main" val="307842273"/>
       </p:ext>
     </p:extLst>
   </p:cSld>
@@ -2842,7 +2842,7 @@
           <p:cNvPr id="13" name="">
             <a:extLst xmlns:a="http://schemas.openxmlformats.org/drawingml/2006/main">
               <a:ext uri="{FF2B5EF4-FFF2-40B4-BE49-F238E27FC236}">
-                <a16:creationId xmlns:a16="http://schemas.microsoft.com/office/drawing/2014/main" id="{85B17CD4-5E9E-4457-9353-CC63175BDCBD}"/>
+                <a16:creationId xmlns:a16="http://schemas.microsoft.com/office/drawing/2014/main" id="{031B6F31-4812-4AB5-91C0-C876178C09C8}"/>
               </a:ext>
             </a:extLst>
           </p:cNvPr>
@@ -2899,7 +2899,7 @@
           <p:cNvPr id="2" name="">
             <a:extLst xmlns:a="http://schemas.openxmlformats.org/drawingml/2006/main">
               <a:ext uri="{FF2B5EF4-FFF2-40B4-BE49-F238E27FC236}">
-                <a16:creationId xmlns:a16="http://schemas.microsoft.com/office/drawing/2014/main" id="{0D0F69CC-72D1-4571-A3A5-3DAFFB28804B}"/>
+                <a16:creationId xmlns:a16="http://schemas.microsoft.com/office/drawing/2014/main" id="{FA56A92A-7BDA-48DC-A2D0-DF660D50074F}"/>
               </a:ext>
             </a:extLst>
           </p:cNvPr>
@@ -2956,7 +2956,7 @@
           <p:cNvPr id="3" name="">
             <a:extLst xmlns:a="http://schemas.openxmlformats.org/drawingml/2006/main">
               <a:ext uri="{FF2B5EF4-FFF2-40B4-BE49-F238E27FC236}">
-                <a16:creationId xmlns:a16="http://schemas.microsoft.com/office/drawing/2014/main" id="{3440C86D-67D9-4B94-846A-E94D13B2D8ED}"/>
+                <a16:creationId xmlns:a16="http://schemas.microsoft.com/office/drawing/2014/main" id="{509C6AAB-6AAA-4355-BB36-03F9040E21DF}"/>
               </a:ext>
             </a:extLst>
           </p:cNvPr>
@@ -3013,7 +3013,7 @@
           <p:cNvPr id="4" name="">
             <a:extLst xmlns:a="http://schemas.openxmlformats.org/drawingml/2006/main">
               <a:ext uri="{FF2B5EF4-FFF2-40B4-BE49-F238E27FC236}">
-                <a16:creationId xmlns:a16="http://schemas.microsoft.com/office/drawing/2014/main" id="{DD76F49D-0840-4C0F-88C0-4E5FA30673D0}"/>
+                <a16:creationId xmlns:a16="http://schemas.microsoft.com/office/drawing/2014/main" id="{A2E0DE01-C15B-4CF9-8284-EC7DCCBBFE8E}"/>
               </a:ext>
             </a:extLst>
           </p:cNvPr>
@@ -3070,7 +3070,7 @@
           <p:cNvPr id="5" name="">
             <a:extLst xmlns:a="http://schemas.openxmlformats.org/drawingml/2006/main">
               <a:ext uri="{FF2B5EF4-FFF2-40B4-BE49-F238E27FC236}">
-                <a16:creationId xmlns:a16="http://schemas.microsoft.com/office/drawing/2014/main" id="{EEF09B64-D96B-4A98-B1A1-1782D3792A5B}"/>
+                <a16:creationId xmlns:a16="http://schemas.microsoft.com/office/drawing/2014/main" id="{33A31678-51E5-4925-BA25-AC65053CEFEA}"/>
               </a:ext>
             </a:extLst>
           </p:cNvPr>
@@ -3173,7 +3173,7 @@
           <p:cNvPr id="6" name="">
             <a:extLst xmlns:a="http://schemas.openxmlformats.org/drawingml/2006/main">
               <a:ext uri="{FF2B5EF4-FFF2-40B4-BE49-F238E27FC236}">
-                <a16:creationId xmlns:a16="http://schemas.microsoft.com/office/drawing/2014/main" id="{AE9EF39C-78F2-432C-87C9-1D1519A36096}"/>
+                <a16:creationId xmlns:a16="http://schemas.microsoft.com/office/drawing/2014/main" id="{01C4CF95-94F5-418B-BDA1-2A9D58305726}"/>
               </a:ext>
             </a:extLst>
           </p:cNvPr>
@@ -3230,7 +3230,7 @@
           <p:cNvPr id="7" name="">
             <a:extLst xmlns:a="http://schemas.openxmlformats.org/drawingml/2006/main">
               <a:ext uri="{FF2B5EF4-FFF2-40B4-BE49-F238E27FC236}">
-                <a16:creationId xmlns:a16="http://schemas.microsoft.com/office/drawing/2014/main" id="{D4820EFF-AB26-4549-945A-9B7CE26590CB}"/>
+                <a16:creationId xmlns:a16="http://schemas.microsoft.com/office/drawing/2014/main" id="{5F61D965-C766-4804-B769-53B9BA5B1A41}"/>
               </a:ext>
             </a:extLst>
           </p:cNvPr>
@@ -3287,7 +3287,7 @@
           <p:cNvPr id="8" name="">
             <a:extLst xmlns:a="http://schemas.openxmlformats.org/drawingml/2006/main">
               <a:ext uri="{FF2B5EF4-FFF2-40B4-BE49-F238E27FC236}">
-                <a16:creationId xmlns:a16="http://schemas.microsoft.com/office/drawing/2014/main" id="{A4F36799-4770-4884-936D-5482167FDC95}"/>
+                <a16:creationId xmlns:a16="http://schemas.microsoft.com/office/drawing/2014/main" id="{D8BD515E-6AB3-425B-9DF6-C315483C4209}"/>
               </a:ext>
             </a:extLst>
           </p:cNvPr>
@@ -3344,7 +3344,7 @@
           <p:cNvPr id="9" name="">
             <a:extLst xmlns:a="http://schemas.openxmlformats.org/drawingml/2006/main">
               <a:ext uri="{FF2B5EF4-FFF2-40B4-BE49-F238E27FC236}">
-                <a16:creationId xmlns:a16="http://schemas.microsoft.com/office/drawing/2014/main" id="{58FBE2A1-AF1F-46DF-B5AD-9C9DB4AC1C62}"/>
+                <a16:creationId xmlns:a16="http://schemas.microsoft.com/office/drawing/2014/main" id="{AB85B1DC-7CB2-4B54-810A-0584BA775AE9}"/>
               </a:ext>
             </a:extLst>
           </p:cNvPr>
@@ -3401,7 +3401,7 @@
           <p:cNvPr id="10" name="">
             <a:extLst xmlns:a="http://schemas.openxmlformats.org/drawingml/2006/main">
               <a:ext uri="{FF2B5EF4-FFF2-40B4-BE49-F238E27FC236}">
-                <a16:creationId xmlns:a16="http://schemas.microsoft.com/office/drawing/2014/main" id="{60E6FA85-9BE5-4403-BC20-5E40F29958E3}"/>
+                <a16:creationId xmlns:a16="http://schemas.microsoft.com/office/drawing/2014/main" id="{D3DA7A57-42E0-4822-836B-A672E9D51B8E}"/>
               </a:ext>
             </a:extLst>
           </p:cNvPr>
@@ -3504,7 +3504,7 @@
           <p:cNvPr id="11" name="">
             <a:extLst xmlns:a="http://schemas.openxmlformats.org/drawingml/2006/main">
               <a:ext uri="{FF2B5EF4-FFF2-40B4-BE49-F238E27FC236}">
-                <a16:creationId xmlns:a16="http://schemas.microsoft.com/office/drawing/2014/main" id="{649589FA-46B7-4FF0-B0DE-D07832EDCBFC}"/>
+                <a16:creationId xmlns:a16="http://schemas.microsoft.com/office/drawing/2014/main" id="{DA0A3217-78A4-4D99-BF31-F4428B5DA73B}"/>
               </a:ext>
             </a:extLst>
           </p:cNvPr>
@@ -3561,7 +3561,7 @@
           <p:cNvPr id="12" name="">
             <a:extLst xmlns:a="http://schemas.openxmlformats.org/drawingml/2006/main">
               <a:ext uri="{FF2B5EF4-FFF2-40B4-BE49-F238E27FC236}">
-                <a16:creationId xmlns:a16="http://schemas.microsoft.com/office/drawing/2014/main" id="{CDD787E1-0070-46E4-9DD1-4D9043B26BA2}"/>
+                <a16:creationId xmlns:a16="http://schemas.microsoft.com/office/drawing/2014/main" id="{8988024E-C1C9-4228-A9ED-E22A64070365}"/>
               </a:ext>
             </a:extLst>
           </p:cNvPr>
@@ -3616,7 +3616,7 @@
     </p:spTree>
     <p:extLst>
       <p:ext uri="{BB962C8B-B14F-4D97-AF65-F5344CB8AC3E}">
-        <p14:creationId xmlns:p14="http://schemas.microsoft.com/office/powerpoint/2010/main" val="1881011537"/>
+        <p14:creationId xmlns:p14="http://schemas.microsoft.com/office/powerpoint/2010/main" val="1968813232"/>
       </p:ext>
     </p:extLst>
   </p:cSld>
@@ -3647,7 +3647,7 @@
           <p:cNvPr id="18" name="">
             <a:extLst xmlns:a="http://schemas.openxmlformats.org/drawingml/2006/main">
               <a:ext uri="{FF2B5EF4-FFF2-40B4-BE49-F238E27FC236}">
-                <a16:creationId xmlns:a16="http://schemas.microsoft.com/office/drawing/2014/main" id="{D2E5973C-3688-499D-9368-F1B32918364C}"/>
+                <a16:creationId xmlns:a16="http://schemas.microsoft.com/office/drawing/2014/main" id="{87ADE55E-DBEF-41FF-9224-22DA22795D5E}"/>
               </a:ext>
             </a:extLst>
           </p:cNvPr>
@@ -3704,7 +3704,7 @@
           <p:cNvPr id="2" name="">
             <a:extLst xmlns:a="http://schemas.openxmlformats.org/drawingml/2006/main">
               <a:ext uri="{FF2B5EF4-FFF2-40B4-BE49-F238E27FC236}">
-                <a16:creationId xmlns:a16="http://schemas.microsoft.com/office/drawing/2014/main" id="{D2901C48-3CCF-4888-A06F-7852BE104980}"/>
+                <a16:creationId xmlns:a16="http://schemas.microsoft.com/office/drawing/2014/main" id="{761E9B09-D10F-4305-9F1D-A87A4BA68DCD}"/>
               </a:ext>
             </a:extLst>
           </p:cNvPr>
@@ -3761,7 +3761,7 @@
           <p:cNvPr id="3" name="">
             <a:extLst xmlns:a="http://schemas.openxmlformats.org/drawingml/2006/main">
               <a:ext uri="{FF2B5EF4-FFF2-40B4-BE49-F238E27FC236}">
-                <a16:creationId xmlns:a16="http://schemas.microsoft.com/office/drawing/2014/main" id="{58143E63-B5CF-4F3A-AF9D-490D4509F1A2}"/>
+                <a16:creationId xmlns:a16="http://schemas.microsoft.com/office/drawing/2014/main" id="{84245AA7-80BF-48E8-B922-BC5F709F49C4}"/>
               </a:ext>
             </a:extLst>
           </p:cNvPr>
@@ -3822,7 +3822,7 @@
           <p:cNvPr id="4" name="">
             <a:extLst xmlns:a="http://schemas.openxmlformats.org/drawingml/2006/main">
               <a:ext uri="{FF2B5EF4-FFF2-40B4-BE49-F238E27FC236}">
-                <a16:creationId xmlns:a16="http://schemas.microsoft.com/office/drawing/2014/main" id="{3F3B0B05-92BE-4B03-97D0-876305135DCF}"/>
+                <a16:creationId xmlns:a16="http://schemas.microsoft.com/office/drawing/2014/main" id="{59D9516B-0E61-4F01-B163-C21219A23F28}"/>
               </a:ext>
             </a:extLst>
           </p:cNvPr>
@@ -3883,7 +3883,7 @@
           <p:cNvPr id="5" name="">
             <a:extLst xmlns:a="http://schemas.openxmlformats.org/drawingml/2006/main">
               <a:ext uri="{FF2B5EF4-FFF2-40B4-BE49-F238E27FC236}">
-                <a16:creationId xmlns:a16="http://schemas.microsoft.com/office/drawing/2014/main" id="{BF924540-B415-4338-9E40-664FB5A8CABB}"/>
+                <a16:creationId xmlns:a16="http://schemas.microsoft.com/office/drawing/2014/main" id="{FE84125F-F67D-4092-831F-E3F9ABDDEB55}"/>
               </a:ext>
             </a:extLst>
           </p:cNvPr>
@@ -3944,7 +3944,7 @@
           <p:cNvPr id="6" name="">
             <a:extLst xmlns:a="http://schemas.openxmlformats.org/drawingml/2006/main">
               <a:ext uri="{FF2B5EF4-FFF2-40B4-BE49-F238E27FC236}">
-                <a16:creationId xmlns:a16="http://schemas.microsoft.com/office/drawing/2014/main" id="{89AC28E5-94A9-461D-A07E-C359D10FC4F3}"/>
+                <a16:creationId xmlns:a16="http://schemas.microsoft.com/office/drawing/2014/main" id="{433AB595-A69D-44F8-A298-27456F5F6958}"/>
               </a:ext>
             </a:extLst>
           </p:cNvPr>
@@ -4083,7 +4083,7 @@
           <p:cNvPr id="10" name="">
             <a:extLst xmlns:a="http://schemas.openxmlformats.org/drawingml/2006/main">
               <a:ext uri="{FF2B5EF4-FFF2-40B4-BE49-F238E27FC236}">
-                <a16:creationId xmlns:a16="http://schemas.microsoft.com/office/drawing/2014/main" id="{73295C0E-993F-4E57-B934-A2B2248C4CC4}"/>
+                <a16:creationId xmlns:a16="http://schemas.microsoft.com/office/drawing/2014/main" id="{DC9F738A-D324-46FC-BB45-4F84F3DE2C93}"/>
               </a:ext>
             </a:extLst>
           </p:cNvPr>
@@ -4186,7 +4186,7 @@
           <p:cNvPr id="11" name="">
             <a:extLst xmlns:a="http://schemas.openxmlformats.org/drawingml/2006/main">
               <a:ext uri="{FF2B5EF4-FFF2-40B4-BE49-F238E27FC236}">
-                <a16:creationId xmlns:a16="http://schemas.microsoft.com/office/drawing/2014/main" id="{08C6F166-3B9F-42CA-B4CB-DC874E09EA00}"/>
+                <a16:creationId xmlns:a16="http://schemas.microsoft.com/office/drawing/2014/main" id="{410B2FF7-4084-488C-9D53-262B376B705D}"/>
               </a:ext>
             </a:extLst>
           </p:cNvPr>
@@ -4256,7 +4256,7 @@
                 <a:ea typeface="Helvetica Neue"/>
                 <a:cs typeface="Helvetica Neue"/>
               </a:rPr>
-              <a:t>Structured extraction</a:t>
+              <a:t>Schema in prompt</a:t>
             </a:r>
           </a:p>
           <a:p xmlns:a="http://schemas.openxmlformats.org/drawingml/2006/main">
@@ -4279,7 +4279,7 @@
                 <a:ea typeface="Helvetica Neue"/>
                 <a:cs typeface="Helvetica Neue"/>
               </a:rPr>
-              <a:t>Source-linked proposals</a:t>
+              <a:t>Cited proposals</a:t>
             </a:r>
           </a:p>
         </p:txBody>
@@ -4289,7 +4289,7 @@
           <p:cNvPr id="12" name="">
             <a:extLst xmlns:a="http://schemas.openxmlformats.org/drawingml/2006/main">
               <a:ext uri="{FF2B5EF4-FFF2-40B4-BE49-F238E27FC236}">
-                <a16:creationId xmlns:a16="http://schemas.microsoft.com/office/drawing/2014/main" id="{110D0641-5261-4118-9D3D-5B9D5A5734A6}"/>
+                <a16:creationId xmlns:a16="http://schemas.microsoft.com/office/drawing/2014/main" id="{219EE39B-8E2A-4BFB-BD9D-3BD72A57817D}"/>
               </a:ext>
             </a:extLst>
           </p:cNvPr>
@@ -4392,7 +4392,7 @@
           <p:cNvPr id="13" name="">
             <a:extLst xmlns:a="http://schemas.openxmlformats.org/drawingml/2006/main">
               <a:ext uri="{FF2B5EF4-FFF2-40B4-BE49-F238E27FC236}">
-                <a16:creationId xmlns:a16="http://schemas.microsoft.com/office/drawing/2014/main" id="{8B42B45B-2405-4B7D-B0C6-CC5006E4A7DD}"/>
+                <a16:creationId xmlns:a16="http://schemas.microsoft.com/office/drawing/2014/main" id="{FE79580C-3040-44FC-B1AA-61DC67BEA836}"/>
               </a:ext>
             </a:extLst>
           </p:cNvPr>
@@ -4495,7 +4495,7 @@
           <p:cNvPr id="14" name="">
             <a:extLst xmlns:a="http://schemas.openxmlformats.org/drawingml/2006/main">
               <a:ext uri="{FF2B5EF4-FFF2-40B4-BE49-F238E27FC236}">
-                <a16:creationId xmlns:a16="http://schemas.microsoft.com/office/drawing/2014/main" id="{1FD9F0EF-EB5C-4DBC-92F5-40FBCEB5C8E9}"/>
+                <a16:creationId xmlns:a16="http://schemas.microsoft.com/office/drawing/2014/main" id="{1529AC23-8E43-48BD-A7EC-AFD775EA30FB}"/>
               </a:ext>
             </a:extLst>
           </p:cNvPr>
@@ -4552,7 +4552,7 @@
           <p:cNvPr id="15" name="">
             <a:extLst xmlns:a="http://schemas.openxmlformats.org/drawingml/2006/main">
               <a:ext uri="{FF2B5EF4-FFF2-40B4-BE49-F238E27FC236}">
-                <a16:creationId xmlns:a16="http://schemas.microsoft.com/office/drawing/2014/main" id="{93158336-EE73-461F-8031-A27624A0F340}"/>
+                <a16:creationId xmlns:a16="http://schemas.microsoft.com/office/drawing/2014/main" id="{1C75C4E2-B1C7-4787-9BB1-0B78E011EA7E}"/>
               </a:ext>
             </a:extLst>
           </p:cNvPr>
@@ -4609,7 +4609,7 @@
           <p:cNvPr id="16" name="">
             <a:extLst xmlns:a="http://schemas.openxmlformats.org/drawingml/2006/main">
               <a:ext uri="{FF2B5EF4-FFF2-40B4-BE49-F238E27FC236}">
-                <a16:creationId xmlns:a16="http://schemas.microsoft.com/office/drawing/2014/main" id="{6D43FD18-816A-4397-A534-11058B4EA341}"/>
+                <a16:creationId xmlns:a16="http://schemas.microsoft.com/office/drawing/2014/main" id="{AB872C5A-2BA9-4480-B419-08CC2761A847}"/>
               </a:ext>
             </a:extLst>
           </p:cNvPr>
@@ -4640,7 +4640,7 @@
             <a:pPr>
               <a:defRPr sz="1725" b="1">
                 <a:solidFill>
-                  <a:srgbClr val="9B6409"/>
+                  <a:srgbClr val="136956"/>
                 </a:solidFill>
                 <a:latin typeface="Helvetica Neue"/>
                 <a:ea typeface="Helvetica Neue"/>
@@ -4650,13 +4650,13 @@
             <a:r>
               <a:rPr sz="1725" b="1">
                 <a:solidFill>
-                  <a:srgbClr val="9B6409"/>
-                </a:solidFill>
-                <a:latin typeface="Helvetica Neue"/>
-                <a:ea typeface="Helvetica Neue"/>
-                <a:cs typeface="Helvetica Neue"/>
-              </a:rPr>
-              <a:t>Live Nebius execution awaits a credential. No measured model latency, accuracy or cost yet.</a:t>
+                  <a:srgbClr val="136956"/>
+                </a:solidFill>
+                <a:latin typeface="Helvetica Neue"/>
+                <a:ea typeface="Helvetica Neue"/>
+                <a:cs typeface="Helvetica Neue"/>
+              </a:rPr>
+              <a:t>Hosted Nemotron 3 Super run: 17.562 seconds, about $0.00456 in estimated inference cost.</a:t>
             </a:r>
           </a:p>
         </p:txBody>
@@ -4666,7 +4666,7 @@
           <p:cNvPr id="17" name="">
             <a:extLst xmlns:a="http://schemas.openxmlformats.org/drawingml/2006/main">
               <a:ext uri="{FF2B5EF4-FFF2-40B4-BE49-F238E27FC236}">
-                <a16:creationId xmlns:a16="http://schemas.microsoft.com/office/drawing/2014/main" id="{D930D73C-06E5-4E94-98A8-526C622E8CBC}"/>
+                <a16:creationId xmlns:a16="http://schemas.microsoft.com/office/drawing/2014/main" id="{FA7F7AB5-1F47-4AD0-A677-FEAD33E8EFE8}"/>
               </a:ext>
             </a:extLst>
           </p:cNvPr>
@@ -4721,7 +4721,7 @@
     </p:spTree>
     <p:extLst>
       <p:ext uri="{BB962C8B-B14F-4D97-AF65-F5344CB8AC3E}">
-        <p14:creationId xmlns:p14="http://schemas.microsoft.com/office/powerpoint/2010/main" val="973305348"/>
+        <p14:creationId xmlns:p14="http://schemas.microsoft.com/office/powerpoint/2010/main" val="458497784"/>
       </p:ext>
     </p:extLst>
   </p:cSld>
@@ -4752,7 +4752,7 @@
           <p:cNvPr id="10" name="">
             <a:extLst xmlns:a="http://schemas.openxmlformats.org/drawingml/2006/main">
               <a:ext uri="{FF2B5EF4-FFF2-40B4-BE49-F238E27FC236}">
-                <a16:creationId xmlns:a16="http://schemas.microsoft.com/office/drawing/2014/main" id="{4C051CEF-3C8B-4217-AA5D-7B366535B546}"/>
+                <a16:creationId xmlns:a16="http://schemas.microsoft.com/office/drawing/2014/main" id="{82D2F3A3-9BC7-446E-8893-81DE19F4048E}"/>
               </a:ext>
             </a:extLst>
           </p:cNvPr>
@@ -4809,7 +4809,7 @@
           <p:cNvPr id="2" name="">
             <a:extLst xmlns:a="http://schemas.openxmlformats.org/drawingml/2006/main">
               <a:ext uri="{FF2B5EF4-FFF2-40B4-BE49-F238E27FC236}">
-                <a16:creationId xmlns:a16="http://schemas.microsoft.com/office/drawing/2014/main" id="{C414DD02-CCBF-4220-A569-E0298726B6AA}"/>
+                <a16:creationId xmlns:a16="http://schemas.microsoft.com/office/drawing/2014/main" id="{4318F53D-FB49-4F97-AC30-4B66B39FE749}"/>
               </a:ext>
             </a:extLst>
           </p:cNvPr>
@@ -4866,7 +4866,7 @@
           <p:cNvPr id="3" name="">
             <a:extLst xmlns:a="http://schemas.openxmlformats.org/drawingml/2006/main">
               <a:ext uri="{FF2B5EF4-FFF2-40B4-BE49-F238E27FC236}">
-                <a16:creationId xmlns:a16="http://schemas.microsoft.com/office/drawing/2014/main" id="{3002D8FA-EFBF-4EFE-A50F-E0606084CCE5}"/>
+                <a16:creationId xmlns:a16="http://schemas.microsoft.com/office/drawing/2014/main" id="{6463AA16-8D13-4887-A1FE-E0BCED4936E8}"/>
               </a:ext>
             </a:extLst>
           </p:cNvPr>
@@ -4946,7 +4946,7 @@
           <p:cNvPr id="4" name="">
             <a:extLst xmlns:a="http://schemas.openxmlformats.org/drawingml/2006/main">
               <a:ext uri="{FF2B5EF4-FFF2-40B4-BE49-F238E27FC236}">
-                <a16:creationId xmlns:a16="http://schemas.microsoft.com/office/drawing/2014/main" id="{D575A1AA-C3F6-489F-A0CB-9A4C75EF6214}"/>
+                <a16:creationId xmlns:a16="http://schemas.microsoft.com/office/drawing/2014/main" id="{D049B527-5288-4659-B44F-EAAFCBF69EDA}"/>
               </a:ext>
             </a:extLst>
           </p:cNvPr>
@@ -5049,7 +5049,7 @@
           <p:cNvPr id="5" name="">
             <a:extLst xmlns:a="http://schemas.openxmlformats.org/drawingml/2006/main">
               <a:ext uri="{FF2B5EF4-FFF2-40B4-BE49-F238E27FC236}">
-                <a16:creationId xmlns:a16="http://schemas.microsoft.com/office/drawing/2014/main" id="{99F58F3E-07CA-4768-88E9-6249A6EB9C34}"/>
+                <a16:creationId xmlns:a16="http://schemas.microsoft.com/office/drawing/2014/main" id="{6514817B-3B6C-4D2C-9C15-521399083DE8}"/>
               </a:ext>
             </a:extLst>
           </p:cNvPr>
@@ -5106,7 +5106,7 @@
           <p:cNvPr id="6" name="">
             <a:extLst xmlns:a="http://schemas.openxmlformats.org/drawingml/2006/main">
               <a:ext uri="{FF2B5EF4-FFF2-40B4-BE49-F238E27FC236}">
-                <a16:creationId xmlns:a16="http://schemas.microsoft.com/office/drawing/2014/main" id="{D2017483-51E6-471B-A064-B435628821C7}"/>
+                <a16:creationId xmlns:a16="http://schemas.microsoft.com/office/drawing/2014/main" id="{14C33E2E-76FD-4C93-8A9C-17119767CC38}"/>
               </a:ext>
             </a:extLst>
           </p:cNvPr>
@@ -5163,7 +5163,7 @@
           <p:cNvPr id="7" name="">
             <a:extLst xmlns:a="http://schemas.openxmlformats.org/drawingml/2006/main">
               <a:ext uri="{FF2B5EF4-FFF2-40B4-BE49-F238E27FC236}">
-                <a16:creationId xmlns:a16="http://schemas.microsoft.com/office/drawing/2014/main" id="{5D61692E-E0F2-4F75-8D0B-7B0994FDFAC7}"/>
+                <a16:creationId xmlns:a16="http://schemas.microsoft.com/office/drawing/2014/main" id="{E669FBD7-C532-416B-A57A-7CBA6F3C73BF}"/>
               </a:ext>
             </a:extLst>
           </p:cNvPr>
@@ -5243,7 +5243,7 @@
           <p:cNvPr id="8" name="">
             <a:extLst xmlns:a="http://schemas.openxmlformats.org/drawingml/2006/main">
               <a:ext uri="{FF2B5EF4-FFF2-40B4-BE49-F238E27FC236}">
-                <a16:creationId xmlns:a16="http://schemas.microsoft.com/office/drawing/2014/main" id="{A7DE75E5-72C8-45CD-BA67-A020C99C114D}"/>
+                <a16:creationId xmlns:a16="http://schemas.microsoft.com/office/drawing/2014/main" id="{6BD862F6-020E-4DDC-A572-47D7EBDE4918}"/>
               </a:ext>
             </a:extLst>
           </p:cNvPr>
@@ -5300,7 +5300,7 @@
           <p:cNvPr id="9" name="">
             <a:extLst xmlns:a="http://schemas.openxmlformats.org/drawingml/2006/main">
               <a:ext uri="{FF2B5EF4-FFF2-40B4-BE49-F238E27FC236}">
-                <a16:creationId xmlns:a16="http://schemas.microsoft.com/office/drawing/2014/main" id="{786BCED1-1C4C-4E28-90D3-C287891808D2}"/>
+                <a16:creationId xmlns:a16="http://schemas.microsoft.com/office/drawing/2014/main" id="{D0BC3017-BFA5-43DF-B585-CA0B8F325A44}"/>
               </a:ext>
             </a:extLst>
           </p:cNvPr>
@@ -5355,7 +5355,7 @@
     </p:spTree>
     <p:extLst>
       <p:ext uri="{BB962C8B-B14F-4D97-AF65-F5344CB8AC3E}">
-        <p14:creationId xmlns:p14="http://schemas.microsoft.com/office/powerpoint/2010/main" val="1827243853"/>
+        <p14:creationId xmlns:p14="http://schemas.microsoft.com/office/powerpoint/2010/main" val="400606707"/>
       </p:ext>
     </p:extLst>
   </p:cSld>
@@ -5386,7 +5386,7 @@
           <p:cNvPr id="10" name="">
             <a:extLst xmlns:a="http://schemas.openxmlformats.org/drawingml/2006/main">
               <a:ext uri="{FF2B5EF4-FFF2-40B4-BE49-F238E27FC236}">
-                <a16:creationId xmlns:a16="http://schemas.microsoft.com/office/drawing/2014/main" id="{A6DAA47B-90D1-448D-B122-DFEEC5D4DE34}"/>
+                <a16:creationId xmlns:a16="http://schemas.microsoft.com/office/drawing/2014/main" id="{04DBD771-B864-4240-8898-107B5ECFA9BF}"/>
               </a:ext>
             </a:extLst>
           </p:cNvPr>
@@ -5443,7 +5443,7 @@
           <p:cNvPr id="2" name="">
             <a:extLst xmlns:a="http://schemas.openxmlformats.org/drawingml/2006/main">
               <a:ext uri="{FF2B5EF4-FFF2-40B4-BE49-F238E27FC236}">
-                <a16:creationId xmlns:a16="http://schemas.microsoft.com/office/drawing/2014/main" id="{24AA1BEC-E585-4EC5-92AC-8AFC02171FEC}"/>
+                <a16:creationId xmlns:a16="http://schemas.microsoft.com/office/drawing/2014/main" id="{0BA9D65F-9A72-4B87-9183-2C38F01804F3}"/>
               </a:ext>
             </a:extLst>
           </p:cNvPr>
@@ -5500,7 +5500,7 @@
           <p:cNvPr id="3" name="">
             <a:extLst xmlns:a="http://schemas.openxmlformats.org/drawingml/2006/main">
               <a:ext uri="{FF2B5EF4-FFF2-40B4-BE49-F238E27FC236}">
-                <a16:creationId xmlns:a16="http://schemas.microsoft.com/office/drawing/2014/main" id="{C9BE9750-FD1F-405A-820E-6F7F3C6B4908}"/>
+                <a16:creationId xmlns:a16="http://schemas.microsoft.com/office/drawing/2014/main" id="{4192B071-69CE-46DB-A4F2-24B6C88DA0C6}"/>
               </a:ext>
             </a:extLst>
           </p:cNvPr>
@@ -5557,7 +5557,7 @@
           <p:cNvPr id="4" name="">
             <a:extLst xmlns:a="http://schemas.openxmlformats.org/drawingml/2006/main">
               <a:ext uri="{FF2B5EF4-FFF2-40B4-BE49-F238E27FC236}">
-                <a16:creationId xmlns:a16="http://schemas.microsoft.com/office/drawing/2014/main" id="{68FE42BB-3BE8-4693-B223-6F63D4018952}"/>
+                <a16:creationId xmlns:a16="http://schemas.microsoft.com/office/drawing/2014/main" id="{52C1FCAF-44BE-4925-9AE3-9F53C697D492}"/>
               </a:ext>
             </a:extLst>
           </p:cNvPr>
@@ -5604,7 +5604,7 @@
                 <a:ea typeface="Helvetica Neue"/>
                 <a:cs typeface="Helvetica Neue"/>
               </a:rPr>
-              <a:t>37 automated tests</a:t>
+              <a:t>41 automated tests</a:t>
             </a:r>
           </a:p>
           <a:p xmlns:a="http://schemas.openxmlformats.org/drawingml/2006/main">
@@ -5651,6 +5651,29 @@
                 <a:cs typeface="Helvetica Neue"/>
               </a:rPr>
               <a:t>10 operator checks</a:t>
+            </a:r>
+          </a:p>
+          <a:p xmlns:a="http://schemas.openxmlformats.org/drawingml/2006/main">
+            <a:pPr>
+              <a:defRPr sz="2325" b="0">
+                <a:solidFill>
+                  <a:srgbClr val="FFFFFF"/>
+                </a:solidFill>
+                <a:latin typeface="Helvetica Neue"/>
+                <a:ea typeface="Helvetica Neue"/>
+                <a:cs typeface="Helvetica Neue"/>
+              </a:defRPr>
+            </a:pPr>
+            <a:r>
+              <a:rPr sz="2325" b="0">
+                <a:solidFill>
+                  <a:srgbClr val="FFFFFF"/>
+                </a:solidFill>
+                <a:latin typeface="Helvetica Neue"/>
+                <a:ea typeface="Helvetica Neue"/>
+                <a:cs typeface="Helvetica Neue"/>
+              </a:rPr>
+              <a:t>Hosted NVIDIA flow passed</a:t>
             </a:r>
           </a:p>
         </p:txBody>
@@ -5660,7 +5683,7 @@
           <p:cNvPr id="5" name="">
             <a:extLst xmlns:a="http://schemas.openxmlformats.org/drawingml/2006/main">
               <a:ext uri="{FF2B5EF4-FFF2-40B4-BE49-F238E27FC236}">
-                <a16:creationId xmlns:a16="http://schemas.microsoft.com/office/drawing/2014/main" id="{F8509155-3F78-42DB-833C-EC2FAE9958AB}"/>
+                <a16:creationId xmlns:a16="http://schemas.microsoft.com/office/drawing/2014/main" id="{70333A2A-C1F6-4DC0-8F93-392AED435EC8}"/>
               </a:ext>
             </a:extLst>
           </p:cNvPr>
@@ -5717,7 +5740,7 @@
           <p:cNvPr id="6" name="">
             <a:extLst xmlns:a="http://schemas.openxmlformats.org/drawingml/2006/main">
               <a:ext uri="{FF2B5EF4-FFF2-40B4-BE49-F238E27FC236}">
-                <a16:creationId xmlns:a16="http://schemas.microsoft.com/office/drawing/2014/main" id="{3D0ED9BB-D0CC-4B5C-913A-AEB5FBC702E4}"/>
+                <a16:creationId xmlns:a16="http://schemas.microsoft.com/office/drawing/2014/main" id="{77412DD7-4C17-4BBA-9DDA-A00E20CE6F2D}"/>
               </a:ext>
             </a:extLst>
           </p:cNvPr>
@@ -5764,7 +5787,7 @@
                 <a:ea typeface="Helvetica Neue"/>
                 <a:cs typeface="Helvetica Neue"/>
               </a:rPr>
-              <a:t>Verify live Nemotron on Nebius</a:t>
+              <a:t>Evaluate more difficult source files</a:t>
             </a:r>
           </a:p>
           <a:p xmlns:a="http://schemas.openxmlformats.org/drawingml/2006/main">
@@ -5843,7 +5866,7 @@
           <p:cNvPr id="7" name="">
             <a:extLst xmlns:a="http://schemas.openxmlformats.org/drawingml/2006/main">
               <a:ext uri="{FF2B5EF4-FFF2-40B4-BE49-F238E27FC236}">
-                <a16:creationId xmlns:a16="http://schemas.microsoft.com/office/drawing/2014/main" id="{888CE4C2-3C73-463A-B048-1F14B74ED33E}"/>
+                <a16:creationId xmlns:a16="http://schemas.microsoft.com/office/drawing/2014/main" id="{6354BA42-DF0D-4D74-B080-777AECE0410D}"/>
               </a:ext>
             </a:extLst>
           </p:cNvPr>
@@ -5890,7 +5913,7 @@
                 <a:ea typeface="Helvetica Neue"/>
                 <a:cs typeface="Helvetica Neue"/>
               </a:rPr>
-              <a:t>Synthetic records and mocked provider contracts do not verify live model quality.</a:t>
+              <a:t>One fictional scenario tested end to end. Real-world accuracy remains unmeasured.</a:t>
             </a:r>
           </a:p>
         </p:txBody>
@@ -5900,7 +5923,7 @@
           <p:cNvPr id="8" name="">
             <a:extLst xmlns:a="http://schemas.openxmlformats.org/drawingml/2006/main">
               <a:ext uri="{FF2B5EF4-FFF2-40B4-BE49-F238E27FC236}">
-                <a16:creationId xmlns:a16="http://schemas.microsoft.com/office/drawing/2014/main" id="{67D54B67-AFF5-4F26-A408-607EF83512BE}"/>
+                <a16:creationId xmlns:a16="http://schemas.microsoft.com/office/drawing/2014/main" id="{CCCC86C5-2CCA-411F-B7EC-F49CB15D8824}"/>
               </a:ext>
             </a:extLst>
           </p:cNvPr>
@@ -5957,7 +5980,7 @@
           <p:cNvPr id="9" name="">
             <a:extLst xmlns:a="http://schemas.openxmlformats.org/drawingml/2006/main">
               <a:ext uri="{FF2B5EF4-FFF2-40B4-BE49-F238E27FC236}">
-                <a16:creationId xmlns:a16="http://schemas.microsoft.com/office/drawing/2014/main" id="{F9E9E1D1-16AA-447D-A8B3-B6203F4AC228}"/>
+                <a16:creationId xmlns:a16="http://schemas.microsoft.com/office/drawing/2014/main" id="{8EE2B08F-89CF-4783-956B-42021CDF6939}"/>
               </a:ext>
             </a:extLst>
           </p:cNvPr>
@@ -6012,7 +6035,7 @@
     </p:spTree>
     <p:extLst>
       <p:ext uri="{BB962C8B-B14F-4D97-AF65-F5344CB8AC3E}">
-        <p14:creationId xmlns:p14="http://schemas.microsoft.com/office/powerpoint/2010/main" val="655139555"/>
+        <p14:creationId xmlns:p14="http://schemas.microsoft.com/office/powerpoint/2010/main" val="586202460"/>
       </p:ext>
     </p:extLst>
   </p:cSld>

</xml_diff>